<commit_message>
Add a block diagram and take the co-author's deck
The portfolio had a wiring diagram and an ASCII topology but nothing that
showed the system as tiers, which is the view that makes the gateway's role
obvious: it is the only device holding both the Wi-Fi credentials and the
ESP-NOW keys, and that is the entire mechanism by which the node reaches the
cloud without joining it.

The deck is now Roshan's version, which fills in the author line and date and
corrects the acceptance criteria count. Slide 4 carries the block diagram in
place of the ASCII art, and a wiring slide follows it.

Also repinned the node to channel 1. The gateway had roamed again over the
weekend and the link was down when this session started - the third occurrence.
</commit_message>
<xml_diff>
--- a/PRESENTATION.pptx
+++ b/PRESENTATION.pptx
@@ -9,6 +9,7 @@
     <p:sldId id="257" r:id="rId9"/>
     <p:sldId id="258" r:id="rId10"/>
     <p:sldId id="259" r:id="rId11"/>
+    <p:sldId id="273" r:id="rId25"/>
     <p:sldId id="260" r:id="rId12"/>
     <p:sldId id="261" r:id="rId13"/>
     <p:sldId id="262" r:id="rId14"/>
@@ -4672,7 +4673,7 @@
               </a:defRPr>
             </a:pPr>
             <a:r>
-              <a:t>[ Your names ]     |     [ Date ]</a:t>
+              <a:t>Bhanu Gupta  ·  Roshan Aryal     |     9 September 2026</a:t>
             </a:r>
           </a:p>
         </p:txBody>
@@ -4804,14 +4805,15 @@
         </p:nvPicPr>
         <p:blipFill>
           <a:blip r:embed="rId3"/>
+          <a:srcRect b="7500"/>
           <a:stretch>
             <a:fillRect/>
           </a:stretch>
         </p:blipFill>
         <p:spPr>
           <a:xfrm>
-            <a:off x="1463040" y="1783080"/>
-            <a:ext cx="9235440" cy="6071133"/>
+            <a:off x="1691640" y="1755648"/>
+            <a:ext cx="8778240" cy="4736592"/>
           </a:xfrm>
           <a:prstGeom prst="rect">
             <a:avLst/>
@@ -6366,7 +6368,7 @@
 </p:sld>
 </file>
 
-<file path=ppt/slides/slide2.xml><?xml version="1.0" encoding="utf-8"?>
+<file path=ppt/slides/slide18.xml><?xml version="1.0" encoding="utf-8"?>
 <p:sld xmlns:a="http://schemas.openxmlformats.org/drawingml/2006/main" xmlns:p="http://schemas.openxmlformats.org/presentationml/2006/main" xmlns:r="http://schemas.openxmlformats.org/officeDocument/2006/relationships">
   <p:cSld>
     <p:spTree>
@@ -6410,7 +6412,7 @@
               </a:defRPr>
             </a:pPr>
             <a:r>
-              <a:t>WHY THIS EXISTS</a:t>
+              <a:t>WIRING</a:t>
             </a:r>
           </a:p>
           <a:p>
@@ -6426,7 +6428,7 @@
               </a:defRPr>
             </a:pPr>
             <a:r>
-              <a:t>The problem</a:t>
+              <a:t>Circuit</a:t>
             </a:r>
           </a:p>
         </p:txBody>
@@ -6475,109 +6477,30 @@
           </a:p>
         </p:txBody>
       </p:sp>
-      <p:sp>
-        <p:nvSpPr>
-          <p:cNvPr id="4" name="TextBox 3"/>
-          <p:cNvSpPr txBox="1"/>
+      <p:pic>
+        <p:nvPicPr>
+          <p:cNvPr id="4" name="Picture 3" descr="fig_circuit_diagram.png"/>
+          <p:cNvPicPr>
+            <a:picLocks noChangeAspect="1"/>
+          </p:cNvPicPr>
           <p:nvPr/>
-        </p:nvSpPr>
+        </p:nvPicPr>
+        <p:blipFill>
+          <a:blip r:embed="rId2"/>
+          <a:stretch>
+            <a:fillRect/>
+          </a:stretch>
+        </p:blipFill>
         <p:spPr>
           <a:xfrm>
-            <a:off x="640080" y="1828800"/>
-            <a:ext cx="10911535" cy="4480560"/>
+            <a:off x="640080" y="1783080"/>
+            <a:ext cx="10908792" cy="6732847"/>
           </a:xfrm>
           <a:prstGeom prst="rect">
             <a:avLst/>
           </a:prstGeom>
-          <a:noFill/>
         </p:spPr>
-        <p:txBody>
-          <a:bodyPr wrap="square">
-            <a:spAutoFit/>
-          </a:bodyPr>
-          <a:lstStyle/>
-          <a:p>
-            <a:pPr>
-              <a:spcAft>
-                <a:spcPts val="2600"/>
-              </a:spcAft>
-              <a:defRPr sz="2200" b="0">
-                <a:solidFill>
-                  <a:srgbClr val="1A1A1A"/>
-                </a:solidFill>
-                <a:latin typeface="Calibri"/>
-              </a:defRPr>
-            </a:pPr>
-            <a:r>
-              <a:t>A sensor is somewhere without Wi-Fi coverage, mains power, or both.</a:t>
-            </a:r>
-          </a:p>
-          <a:p>
-            <a:pPr>
-              <a:spcAft>
-                <a:spcPts val="1400"/>
-              </a:spcAft>
-              <a:defRPr sz="1900" b="0">
-                <a:solidFill>
-                  <a:srgbClr val="1A1A1A"/>
-                </a:solidFill>
-                <a:latin typeface="Calibri"/>
-              </a:defRPr>
-            </a:pPr>
-            <a:r>
-              <a:t>-   Wi-Fi association costs seconds and milliamps before a single byte moves</a:t>
-            </a:r>
-          </a:p>
-          <a:p>
-            <a:pPr>
-              <a:spcAft>
-                <a:spcPts val="1400"/>
-              </a:spcAft>
-              <a:defRPr sz="1900" b="0">
-                <a:solidFill>
-                  <a:srgbClr val="1A1A1A"/>
-                </a:solidFill>
-                <a:latin typeface="Calibri"/>
-              </a:defRPr>
-            </a:pPr>
-            <a:r>
-              <a:t>-   Every node needing its own AP credentials does not scale</a:t>
-            </a:r>
-          </a:p>
-          <a:p>
-            <a:pPr>
-              <a:spcAft>
-                <a:spcPts val="1400"/>
-              </a:spcAft>
-              <a:defRPr sz="1900" b="0">
-                <a:solidFill>
-                  <a:srgbClr val="1A1A1A"/>
-                </a:solidFill>
-                <a:latin typeface="Calibri"/>
-              </a:defRPr>
-            </a:pPr>
-            <a:r>
-              <a:t>-   One device with connectivity should be able to carry data for several without</a:t>
-            </a:r>
-          </a:p>
-          <a:p>
-            <a:pPr>
-              <a:spcAft>
-                <a:spcPts val="0"/>
-              </a:spcAft>
-              <a:defRPr sz="2200" b="1">
-                <a:solidFill>
-                  <a:srgbClr val="0B6B62"/>
-                </a:solidFill>
-                <a:latin typeface="Calibri"/>
-              </a:defRPr>
-            </a:pPr>
-            <a:r>
-              <a:t>So: cheap radio between the nodes, one gateway that owns the cloud link.</a:t>
-            </a:r>
-          </a:p>
-        </p:txBody>
-      </p:sp>
+      </p:pic>
     </p:spTree>
   </p:cSld>
   <p:clrMapOvr>
@@ -6586,7 +6509,7 @@
 </p:sld>
 </file>
 
-<file path=ppt/slides/slide3.xml><?xml version="1.0" encoding="utf-8"?>
+<file path=ppt/slides/slide2.xml><?xml version="1.0" encoding="utf-8"?>
 <p:sld xmlns:a="http://schemas.openxmlformats.org/drawingml/2006/main" xmlns:p="http://schemas.openxmlformats.org/presentationml/2006/main" xmlns:r="http://schemas.openxmlformats.org/officeDocument/2006/relationships">
   <p:cSld>
     <p:spTree>
@@ -6630,7 +6553,7 @@
               </a:defRPr>
             </a:pPr>
             <a:r>
-              <a:t>SCOPE</a:t>
+              <a:t>WHY THIS EXISTS</a:t>
             </a:r>
           </a:p>
           <a:p>
@@ -6646,7 +6569,7 @@
               </a:defRPr>
             </a:pPr>
             <a:r>
-              <a:t>What we built</a:t>
+              <a:t>The problem</a:t>
             </a:r>
           </a:p>
         </p:txBody>
@@ -6703,8 +6626,8 @@
         </p:nvSpPr>
         <p:spPr>
           <a:xfrm>
-            <a:off x="640080" y="1783080"/>
-            <a:ext cx="6400800" cy="4526280"/>
+            <a:off x="640080" y="1828800"/>
+            <a:ext cx="10911535" cy="4480560"/>
           </a:xfrm>
           <a:prstGeom prst="rect">
             <a:avLst/>
@@ -6719,9 +6642,73 @@
           <a:p>
             <a:pPr>
               <a:spcAft>
-                <a:spcPts val="600"/>
-              </a:spcAft>
-              <a:defRPr sz="2000" b="1">
+                <a:spcPts val="2600"/>
+              </a:spcAft>
+              <a:defRPr sz="2200" b="0">
+                <a:solidFill>
+                  <a:srgbClr val="1A1A1A"/>
+                </a:solidFill>
+                <a:latin typeface="Calibri"/>
+              </a:defRPr>
+            </a:pPr>
+            <a:r>
+              <a:t>A sensor is somewhere without Wi-Fi coverage, mains power, or both.</a:t>
+            </a:r>
+          </a:p>
+          <a:p>
+            <a:pPr>
+              <a:spcAft>
+                <a:spcPts val="1400"/>
+              </a:spcAft>
+              <a:defRPr sz="1900" b="0">
+                <a:solidFill>
+                  <a:srgbClr val="1A1A1A"/>
+                </a:solidFill>
+                <a:latin typeface="Calibri"/>
+              </a:defRPr>
+            </a:pPr>
+            <a:r>
+              <a:t>-   Wi-Fi association costs seconds and milliamps before a single byte moves</a:t>
+            </a:r>
+          </a:p>
+          <a:p>
+            <a:pPr>
+              <a:spcAft>
+                <a:spcPts val="1400"/>
+              </a:spcAft>
+              <a:defRPr sz="1900" b="0">
+                <a:solidFill>
+                  <a:srgbClr val="1A1A1A"/>
+                </a:solidFill>
+                <a:latin typeface="Calibri"/>
+              </a:defRPr>
+            </a:pPr>
+            <a:r>
+              <a:t>-   Every node needing its own AP credentials does not scale</a:t>
+            </a:r>
+          </a:p>
+          <a:p>
+            <a:pPr>
+              <a:spcAft>
+                <a:spcPts val="1400"/>
+              </a:spcAft>
+              <a:defRPr sz="1900" b="0">
+                <a:solidFill>
+                  <a:srgbClr val="1A1A1A"/>
+                </a:solidFill>
+                <a:latin typeface="Calibri"/>
+              </a:defRPr>
+            </a:pPr>
+            <a:r>
+              <a:t>-   One connected gateway can carry data for several local nodes</a:t>
+            </a:r>
+          </a:p>
+          <a:p>
+            <a:pPr>
+              <a:spcAft>
+                <a:spcPts val="0"/>
+              </a:spcAft>
+              <a:defRPr sz="2200" b="1">
                 <a:solidFill>
                   <a:srgbClr val="0B6B62"/>
                 </a:solidFill>
@@ -6729,115 +6716,11 @@
               </a:defRPr>
             </a:pPr>
             <a:r>
-              <a:t>Board 1  -  Remote node</a:t>
-            </a:r>
-          </a:p>
-          <a:p>
-            <a:pPr>
-              <a:spcAft>
-                <a:spcPts val="1800"/>
-              </a:spcAft>
-              <a:defRPr sz="1700" b="0">
-                <a:solidFill>
-                  <a:srgbClr val="1A1A1A"/>
-                </a:solidFill>
-                <a:latin typeface="Calibri"/>
-              </a:defRPr>
-            </a:pPr>
-            <a:r>
-              <a:t>DHT11 on GPIO4. Reads and transmits every 5 s over ESP-NOW. Never joins the access point.</a:t>
-            </a:r>
-          </a:p>
-          <a:p>
-            <a:pPr>
-              <a:spcAft>
-                <a:spcPts val="600"/>
-              </a:spcAft>
-              <a:defRPr sz="2000" b="1">
-                <a:solidFill>
-                  <a:srgbClr val="0B6B62"/>
-                </a:solidFill>
-                <a:latin typeface="Calibri"/>
-              </a:defRPr>
-            </a:pPr>
-            <a:r>
-              <a:t>Board 2  -  Gateway</a:t>
-            </a:r>
-          </a:p>
-          <a:p>
-            <a:pPr>
-              <a:spcAft>
-                <a:spcPts val="2000"/>
-              </a:spcAft>
-              <a:defRPr sz="1700" b="0">
-                <a:solidFill>
-                  <a:srgbClr val="1A1A1A"/>
-                </a:solidFill>
-                <a:latin typeface="Calibri"/>
-              </a:defRPr>
-            </a:pPr>
-            <a:r>
-              <a:t>DHT11 on GPIO5. Joins eduroam, receives and deduplicates Board 1's packets, merges both readings, publishes to ThingsBoard over MQTT every 10 s.</a:t>
-            </a:r>
-          </a:p>
-          <a:p>
-            <a:pPr>
-              <a:spcAft>
-                <a:spcPts val="1600"/>
-              </a:spcAft>
-              <a:defRPr sz="1800" b="1">
-                <a:solidFill>
-                  <a:srgbClr val="1A1A1A"/>
-                </a:solidFill>
-                <a:latin typeface="Calibri"/>
-              </a:defRPr>
-            </a:pPr>
-            <a:r>
-              <a:t>No wire between the two boards. The only link is a 2.4 GHz radio.</a:t>
-            </a:r>
-          </a:p>
-          <a:p>
-            <a:pPr>
-              <a:spcAft>
-                <a:spcPts val="0"/>
-              </a:spcAft>
-              <a:defRPr sz="1500" b="0">
-                <a:solidFill>
-                  <a:srgbClr val="A83A1F"/>
-                </a:solidFill>
-                <a:latin typeface="Calibri"/>
-              </a:defRPr>
-            </a:pPr>
-            <a:r>
-              <a:t>Two-node prototype with a mesh-ready packet design - not a demonstrated multi-hop mesh. Two radios can only ever be one hop.</a:t>
-            </a:r>
-          </a:p>
-        </p:txBody>
-      </p:sp>
-      <p:pic>
-        <p:nvPicPr>
-          <p:cNvPr id="5" name="Picture 4" descr="photo_01_both_boards_no_wire.jpeg"/>
-          <p:cNvPicPr>
-            <a:picLocks noChangeAspect="1"/>
-          </p:cNvPicPr>
-          <p:nvPr/>
-        </p:nvPicPr>
-        <p:blipFill>
-          <a:blip r:embed="rId3"/>
-          <a:stretch>
-            <a:fillRect/>
-          </a:stretch>
-        </p:blipFill>
-        <p:spPr>
-          <a:xfrm>
-            <a:off x="7498079" y="1783080"/>
-            <a:ext cx="4023360" cy="5364924"/>
-          </a:xfrm>
-          <a:prstGeom prst="rect">
-            <a:avLst/>
-          </a:prstGeom>
-        </p:spPr>
-      </p:pic>
+              <a:t>So: cheap radio between the nodes, one gateway that owns the cloud link.</a:t>
+            </a:r>
+          </a:p>
+        </p:txBody>
+      </p:sp>
     </p:spTree>
   </p:cSld>
   <p:clrMapOvr>
@@ -6846,7 +6729,7 @@
 </p:sld>
 </file>
 
-<file path=ppt/slides/slide4.xml><?xml version="1.0" encoding="utf-8"?>
+<file path=ppt/slides/slide3.xml><?xml version="1.0" encoding="utf-8"?>
 <p:sld xmlns:a="http://schemas.openxmlformats.org/drawingml/2006/main" xmlns:p="http://schemas.openxmlformats.org/presentationml/2006/main" xmlns:r="http://schemas.openxmlformats.org/officeDocument/2006/relationships">
   <p:cSld>
     <p:spTree>
@@ -6890,7 +6773,7 @@
               </a:defRPr>
             </a:pPr>
             <a:r>
-              <a:t>NETWORKING</a:t>
+              <a:t>SCOPE</a:t>
             </a:r>
           </a:p>
           <a:p>
@@ -6906,7 +6789,7 @@
               </a:defRPr>
             </a:pPr>
             <a:r>
-              <a:t>Architecture</a:t>
+              <a:t>What we built</a:t>
             </a:r>
           </a:p>
         </p:txBody>
@@ -6963,8 +6846,8 @@
         </p:nvSpPr>
         <p:spPr>
           <a:xfrm>
-            <a:off x="640080" y="1920240"/>
-            <a:ext cx="10911535" cy="4389120"/>
+            <a:off x="640080" y="1783080"/>
+            <a:ext cx="6400800" cy="4526280"/>
           </a:xfrm>
           <a:prstGeom prst="rect">
             <a:avLst/>
@@ -6979,25 +6862,25 @@
           <a:p>
             <a:pPr>
               <a:spcAft>
+                <a:spcPts val="600"/>
+              </a:spcAft>
+              <a:defRPr sz="2000" b="1">
+                <a:solidFill>
+                  <a:srgbClr val="0B6B62"/>
+                </a:solidFill>
+                <a:latin typeface="Calibri"/>
+              </a:defRPr>
+            </a:pPr>
+            <a:r>
+              <a:t>Board 1  -  Remote node</a:t>
+            </a:r>
+          </a:p>
+          <a:p>
+            <a:pPr>
+              <a:spcAft>
                 <a:spcPts val="1800"/>
               </a:spcAft>
-              <a:defRPr sz="1600" b="1">
-                <a:solidFill>
-                  <a:srgbClr val="606060"/>
-                </a:solidFill>
-                <a:latin typeface="Calibri"/>
-              </a:defRPr>
-            </a:pPr>
-            <a:r>
-              <a:t>Board 1                          Board 2                        Cloud</a:t>
-            </a:r>
-          </a:p>
-          <a:p>
-            <a:pPr>
-              <a:spcAft>
-                <a:spcPts val="2600"/>
-              </a:spcAft>
-              <a:defRPr sz="1900" b="1">
+              <a:defRPr sz="1700" b="0">
                 <a:solidFill>
                   <a:srgbClr val="1A1A1A"/>
                 </a:solidFill>
@@ -7005,59 +6888,99 @@
               </a:defRPr>
             </a:pPr>
             <a:r>
-              <a:t>DHT11  -&gt;  ESP-NOW unicast  -&gt;  validate  -&gt;  dedup  -&gt;  merge  -&gt;  MQTT  -&gt;  ThingsBoard</a:t>
-            </a:r>
-          </a:p>
-          <a:p>
-            <a:pPr>
-              <a:spcAft>
-                <a:spcPts val="1200"/>
+              <a:t>DHT11 on GPIO4. Reads and transmits every 5 s over ESP-NOW. Never joins the access point.</a:t>
+            </a:r>
+          </a:p>
+          <a:p>
+            <a:pPr>
+              <a:spcAft>
+                <a:spcPts val="600"/>
+              </a:spcAft>
+              <a:defRPr sz="2000" b="1">
+                <a:solidFill>
+                  <a:srgbClr val="0B6B62"/>
+                </a:solidFill>
+                <a:latin typeface="Calibri"/>
+              </a:defRPr>
+            </a:pPr>
+            <a:r>
+              <a:t>Board 2  -  Gateway</a:t>
+            </a:r>
+          </a:p>
+          <a:p>
+            <a:pPr>
+              <a:spcAft>
+                <a:spcPts val="2000"/>
+              </a:spcAft>
+              <a:defRPr sz="1700" b="0">
+                <a:solidFill>
+                  <a:srgbClr val="1A1A1A"/>
+                </a:solidFill>
+                <a:latin typeface="Calibri"/>
+              </a:defRPr>
+            </a:pPr>
+            <a:r>
+              <a:t>DHT11 on GPIO5. Joins eduroam, receives and deduplicates Board 1's packets, merges both readings, publishes to ThingsBoard over MQTT every 10 s.</a:t>
+            </a:r>
+          </a:p>
+          <a:p>
+            <a:pPr>
+              <a:spcAft>
+                <a:spcPts val="1600"/>
+              </a:spcAft>
+              <a:defRPr sz="1800" b="1">
+                <a:solidFill>
+                  <a:srgbClr val="1A1A1A"/>
+                </a:solidFill>
+                <a:latin typeface="Calibri"/>
+              </a:defRPr>
+            </a:pPr>
+            <a:r>
+              <a:t>No wire between the two boards. The only link is a 2.4 GHz radio.</a:t>
+            </a:r>
+          </a:p>
+          <a:p>
+            <a:pPr>
+              <a:spcAft>
+                <a:spcPts val="0"/>
               </a:spcAft>
               <a:defRPr sz="1500" b="0">
                 <a:solidFill>
-                  <a:srgbClr val="1A1A1A"/>
-                </a:solidFill>
-                <a:latin typeface="Consolas"/>
-              </a:defRPr>
-            </a:pPr>
-            <a:r>
-              <a:t>ESP-NOW        connectionless, no IP stack, link-layer acknowledged, 26-byte payload</a:t>
-            </a:r>
-          </a:p>
-          <a:p>
-            <a:pPr>
-              <a:spcAft>
-                <a:spcPts val="1200"/>
-              </a:spcAft>
-              <a:defRPr sz="1500" b="0">
-                <a:solidFill>
-                  <a:srgbClr val="1A1A1A"/>
-                </a:solidFill>
-                <a:latin typeface="Consolas"/>
-              </a:defRPr>
-            </a:pPr>
-            <a:r>
-              <a:t>MQTT           TCP, port 1883, topic v1/devices/me/telemetry, token authentication</a:t>
-            </a:r>
-          </a:p>
-          <a:p>
-            <a:pPr>
-              <a:spcAft>
-                <a:spcPts val="1200"/>
-              </a:spcAft>
-              <a:defRPr sz="1500" b="0">
-                <a:solidFill>
-                  <a:srgbClr val="1A1A1A"/>
-                </a:solidFill>
-                <a:latin typeface="Consolas"/>
-              </a:defRPr>
-            </a:pPr>
-            <a:r>
-              <a:t>Aggregation    both readings merged at the edge, before data leaves the network</a:t>
-            </a:r>
-          </a:p>
-        </p:txBody>
-      </p:sp>
+                  <a:srgbClr val="A83A1F"/>
+                </a:solidFill>
+                <a:latin typeface="Calibri"/>
+              </a:defRPr>
+            </a:pPr>
+            <a:r>
+              <a:t>Two-node prototype with a mesh-ready packet design - not a demonstrated multi-hop mesh. Two radios can only ever be one hop.</a:t>
+            </a:r>
+          </a:p>
+        </p:txBody>
+      </p:sp>
+      <p:pic>
+        <p:nvPicPr>
+          <p:cNvPr id="5" name="Picture 4" descr="photo_01_both_boards_no_wire.jpeg"/>
+          <p:cNvPicPr>
+            <a:picLocks noChangeAspect="1"/>
+          </p:cNvPicPr>
+          <p:nvPr/>
+        </p:nvPicPr>
+        <p:blipFill>
+          <a:blip r:embed="rId3"/>
+          <a:stretch>
+            <a:fillRect/>
+          </a:stretch>
+        </p:blipFill>
+        <p:spPr>
+          <a:xfrm>
+            <a:off x="7766313" y="1783080"/>
+            <a:ext cx="3785302" cy="5047488"/>
+          </a:xfrm>
+          <a:prstGeom prst="rect">
+            <a:avLst/>
+          </a:prstGeom>
+        </p:spPr>
+      </p:pic>
     </p:spTree>
   </p:cSld>
   <p:clrMapOvr>
@@ -7066,7 +6989,7 @@
 </p:sld>
 </file>
 
-<file path=ppt/slides/slide5.xml><?xml version="1.0" encoding="utf-8"?>
+<file path=ppt/slides/slide4.xml><?xml version="1.0" encoding="utf-8"?>
 <p:sld xmlns:a="http://schemas.openxmlformats.org/drawingml/2006/main" xmlns:p="http://schemas.openxmlformats.org/presentationml/2006/main" xmlns:r="http://schemas.openxmlformats.org/officeDocument/2006/relationships">
   <p:cSld>
     <p:spTree>
@@ -7110,7 +7033,7 @@
               </a:defRPr>
             </a:pPr>
             <a:r>
-              <a:t>THE GOVERNING CONSTRAINT</a:t>
+              <a:t>NETWORKING</a:t>
             </a:r>
           </a:p>
           <a:p>
@@ -7126,7 +7049,7 @@
               </a:defRPr>
             </a:pPr>
             <a:r>
-              <a:t>One radio, one channel</a:t>
+              <a:t>Architecture</a:t>
             </a:r>
           </a:p>
         </p:txBody>
@@ -7175,125 +7098,30 @@
           </a:p>
         </p:txBody>
       </p:sp>
-      <p:sp>
-        <p:nvSpPr>
-          <p:cNvPr id="4" name="TextBox 3"/>
-          <p:cNvSpPr txBox="1"/>
+      <p:pic>
+        <p:nvPicPr>
+          <p:cNvPr id="4" name="Picture 3" descr="fig_block_diagram.png"/>
+          <p:cNvPicPr>
+            <a:picLocks noChangeAspect="1"/>
+          </p:cNvPicPr>
           <p:nvPr/>
-        </p:nvSpPr>
+        </p:nvPicPr>
+        <p:blipFill>
+          <a:blip r:embed="rId3"/>
+          <a:stretch>
+            <a:fillRect/>
+          </a:stretch>
+        </p:blipFill>
         <p:spPr>
           <a:xfrm>
-            <a:off x="640080" y="1828800"/>
-            <a:ext cx="10911535" cy="4480560"/>
+            <a:off x="640080" y="1783080"/>
+            <a:ext cx="10908792" cy="6426809"/>
           </a:xfrm>
           <a:prstGeom prst="rect">
             <a:avLst/>
           </a:prstGeom>
-          <a:noFill/>
         </p:spPr>
-        <p:txBody>
-          <a:bodyPr wrap="square">
-            <a:spAutoFit/>
-          </a:bodyPr>
-          <a:lstStyle/>
-          <a:p>
-            <a:pPr>
-              <a:spcAft>
-                <a:spcPts val="2000"/>
-              </a:spcAft>
-              <a:defRPr sz="2100" b="0">
-                <a:solidFill>
-                  <a:srgbClr val="1A1A1A"/>
-                </a:solidFill>
-                <a:latin typeface="Calibri"/>
-              </a:defRPr>
-            </a:pPr>
-            <a:r>
-              <a:t>An ESP32 has a single radio, so it is on exactly one channel at a time.</a:t>
-            </a:r>
-          </a:p>
-          <a:p>
-            <a:pPr>
-              <a:spcAft>
-                <a:spcPts val="2000"/>
-              </a:spcAft>
-              <a:defRPr sz="1900" b="0">
-                <a:solidFill>
-                  <a:srgbClr val="1A1A1A"/>
-                </a:solidFill>
-                <a:latin typeface="Calibri"/>
-              </a:defRPr>
-            </a:pPr>
-            <a:r>
-              <a:t>The gateway must join Wi-Fi for the cloud - and the access point decides which channel that is.</a:t>
-            </a:r>
-          </a:p>
-          <a:p>
-            <a:pPr>
-              <a:spcAft>
-                <a:spcPts val="2400"/>
-              </a:spcAft>
-              <a:defRPr sz="2100" b="1">
-                <a:solidFill>
-                  <a:srgbClr val="0B6B62"/>
-                </a:solidFill>
-                <a:latin typeface="Calibri"/>
-              </a:defRPr>
-            </a:pPr>
-            <a:r>
-              <a:t>So the channel is discovered at runtime, never chosen at design time.</a:t>
-            </a:r>
-          </a:p>
-          <a:p>
-            <a:pPr>
-              <a:spcAft>
-                <a:spcPts val="1200"/>
-              </a:spcAft>
-              <a:defRPr sz="1700" b="0">
-                <a:solidFill>
-                  <a:srgbClr val="1A1A1A"/>
-                </a:solidFill>
-                <a:latin typeface="Calibri"/>
-              </a:defRPr>
-            </a:pPr>
-            <a:r>
-              <a:t>-   The node is pinned to that channel by hand, and reads it back to confirm</a:t>
-            </a:r>
-          </a:p>
-          <a:p>
-            <a:pPr>
-              <a:spcAft>
-                <a:spcPts val="1200"/>
-              </a:spcAft>
-              <a:defRPr sz="1700" b="0">
-                <a:solidFill>
-                  <a:srgbClr val="1A1A1A"/>
-                </a:solidFill>
-                <a:latin typeface="Calibri"/>
-              </a:defRPr>
-            </a:pPr>
-            <a:r>
-              <a:t>-   The node never associates - association would let the two boards drift apart</a:t>
-            </a:r>
-          </a:p>
-          <a:p>
-            <a:pPr>
-              <a:spcAft>
-                <a:spcPts val="1200"/>
-              </a:spcAft>
-              <a:defRPr sz="1700" b="0">
-                <a:solidFill>
-                  <a:srgbClr val="1A1A1A"/>
-                </a:solidFill>
-                <a:latin typeface="Calibri"/>
-              </a:defRPr>
-            </a:pPr>
-            <a:r>
-              <a:t>-   Gateway must be flashed and running before the node can even be configured</a:t>
-            </a:r>
-          </a:p>
-        </p:txBody>
-      </p:sp>
+      </p:pic>
     </p:spTree>
   </p:cSld>
   <p:clrMapOvr>
@@ -7302,7 +7130,7 @@
 </p:sld>
 </file>
 
-<file path=ppt/slides/slide6.xml><?xml version="1.0" encoding="utf-8"?>
+<file path=ppt/slides/slide5.xml><?xml version="1.0" encoding="utf-8"?>
 <p:sld xmlns:a="http://schemas.openxmlformats.org/drawingml/2006/main" xmlns:p="http://schemas.openxmlformats.org/presentationml/2006/main" xmlns:r="http://schemas.openxmlformats.org/officeDocument/2006/relationships">
   <p:cSld>
     <p:spTree>
@@ -7346,7 +7174,7 @@
               </a:defRPr>
             </a:pPr>
             <a:r>
-              <a:t>26 BYTES</a:t>
+              <a:t>THE GOVERNING CONSTRAINT</a:t>
             </a:r>
           </a:p>
           <a:p>
@@ -7362,7 +7190,7 @@
               </a:defRPr>
             </a:pPr>
             <a:r>
-              <a:t>Packet design</a:t>
+              <a:t>One radio, one channel</a:t>
             </a:r>
           </a:p>
         </p:txBody>
@@ -7420,7 +7248,7 @@
         <p:spPr>
           <a:xfrm>
             <a:off x="640080" y="1828800"/>
-            <a:ext cx="5852160" cy="4480560"/>
+            <a:ext cx="10911535" cy="4480560"/>
           </a:xfrm>
           <a:prstGeom prst="rect">
             <a:avLst/>
@@ -7435,200 +7263,97 @@
           <a:p>
             <a:pPr>
               <a:spcAft>
-                <a:spcPts val="900"/>
-              </a:spcAft>
-              <a:defRPr sz="1400" b="0">
+                <a:spcPts val="2000"/>
+              </a:spcAft>
+              <a:defRPr sz="2100" b="0">
                 <a:solidFill>
                   <a:srgbClr val="1A1A1A"/>
                 </a:solidFill>
-                <a:latin typeface="Consolas"/>
-              </a:defRPr>
-            </a:pPr>
-            <a:r>
-              <a:t>version, msg_type      protocol evolution</a:t>
-            </a:r>
-          </a:p>
-          <a:p>
-            <a:pPr>
-              <a:spcAft>
-                <a:spcPts val="900"/>
-              </a:spcAft>
-              <a:defRPr sz="1400" b="0">
+                <a:latin typeface="Calibri"/>
+              </a:defRPr>
+            </a:pPr>
+            <a:r>
+              <a:t>An ESP32 has a single radio, so it is on exactly one channel at a time.</a:t>
+            </a:r>
+          </a:p>
+          <a:p>
+            <a:pPr>
+              <a:spcAft>
+                <a:spcPts val="2000"/>
+              </a:spcAft>
+              <a:defRPr sz="1900" b="0">
                 <a:solidFill>
                   <a:srgbClr val="1A1A1A"/>
                 </a:solidFill>
-                <a:latin typeface="Consolas"/>
-              </a:defRPr>
-            </a:pPr>
-            <a:r>
-              <a:t>src_id, dst_id         addressing, not broadcast</a:t>
-            </a:r>
-          </a:p>
-          <a:p>
-            <a:pPr>
-              <a:spcAft>
-                <a:spcPts val="900"/>
-              </a:spcAft>
-              <a:defRPr sz="1400" b="0">
+                <a:latin typeface="Calibri"/>
+              </a:defRPr>
+            </a:pPr>
+            <a:r>
+              <a:t>The gateway must join Wi-Fi for the cloud - and the access point decides which channel that is.</a:t>
+            </a:r>
+          </a:p>
+          <a:p>
+            <a:pPr>
+              <a:spcAft>
+                <a:spcPts val="2400"/>
+              </a:spcAft>
+              <a:defRPr sz="2100" b="1">
+                <a:solidFill>
+                  <a:srgbClr val="0B6B62"/>
+                </a:solidFill>
+                <a:latin typeface="Calibri"/>
+              </a:defRPr>
+            </a:pPr>
+            <a:r>
+              <a:t>So the channel is discovered at runtime, never chosen at design time.</a:t>
+            </a:r>
+          </a:p>
+          <a:p>
+            <a:pPr>
+              <a:spcAft>
+                <a:spcPts val="1200"/>
+              </a:spcAft>
+              <a:defRPr sz="1700" b="0">
                 <a:solidFill>
                   <a:srgbClr val="1A1A1A"/>
                 </a:solidFill>
-                <a:latin typeface="Consolas"/>
-              </a:defRPr>
-            </a:pPr>
-            <a:r>
-              <a:t>boot_id                random per power-up</a:t>
-            </a:r>
-          </a:p>
-          <a:p>
-            <a:pPr>
-              <a:spcAft>
-                <a:spcPts val="900"/>
-              </a:spcAft>
-              <a:defRPr sz="1400" b="0">
+                <a:latin typeface="Calibri"/>
+              </a:defRPr>
+            </a:pPr>
+            <a:r>
+              <a:t>-   The node is pinned to that channel by hand, and reads it back to confirm</a:t>
+            </a:r>
+          </a:p>
+          <a:p>
+            <a:pPr>
+              <a:spcAft>
+                <a:spcPts val="1200"/>
+              </a:spcAft>
+              <a:defRPr sz="1700" b="0">
                 <a:solidFill>
                   <a:srgbClr val="1A1A1A"/>
                 </a:solidFill>
-                <a:latin typeface="Consolas"/>
-              </a:defRPr>
-            </a:pPr>
-            <a:r>
-              <a:t>seq                    ordering within a session</a:t>
-            </a:r>
-          </a:p>
-          <a:p>
-            <a:pPr>
-              <a:spcAft>
-                <a:spcPts val="900"/>
-              </a:spcAft>
-              <a:defRPr sz="1400" b="0">
+                <a:latin typeface="Calibri"/>
+              </a:defRPr>
+            </a:pPr>
+            <a:r>
+              <a:t>-   The node never associates - association would let the two boards drift apart</a:t>
+            </a:r>
+          </a:p>
+          <a:p>
+            <a:pPr>
+              <a:spcAft>
+                <a:spcPts val="1200"/>
+              </a:spcAft>
+              <a:defRPr sz="1700" b="0">
                 <a:solidFill>
                   <a:srgbClr val="1A1A1A"/>
                 </a:solidFill>
-                <a:latin typeface="Consolas"/>
-              </a:defRPr>
-            </a:pPr>
-            <a:r>
-              <a:t>ttl, hop_count         carried, never decremented</a:t>
-            </a:r>
-          </a:p>
-          <a:p>
-            <a:pPr>
-              <a:spcAft>
-                <a:spcPts val="900"/>
-              </a:spcAft>
-              <a:defRPr sz="1400" b="0">
-                <a:solidFill>
-                  <a:srgbClr val="1A1A1A"/>
-                </a:solidFill>
-                <a:latin typeface="Consolas"/>
-              </a:defRPr>
-            </a:pPr>
-            <a:r>
-              <a:t>temperature, humidity  the payload</a:t>
-            </a:r>
-          </a:p>
-          <a:p>
-            <a:pPr>
-              <a:spcAft>
-                <a:spcPts val="900"/>
-              </a:spcAft>
-              <a:defRPr sz="1400" b="0">
-                <a:solidFill>
-                  <a:srgbClr val="1A1A1A"/>
-                </a:solidFill>
-                <a:latin typeface="Consolas"/>
-              </a:defRPr>
-            </a:pPr>
-            <a:r>
-              <a:t>uptime_ms              sender liveness</a:t>
-            </a:r>
-          </a:p>
-        </p:txBody>
-      </p:sp>
-      <p:sp>
-        <p:nvSpPr>
-          <p:cNvPr id="5" name="TextBox 4"/>
-          <p:cNvSpPr txBox="1"/>
-          <p:nvPr/>
-        </p:nvSpPr>
-        <p:spPr>
-          <a:xfrm>
-            <a:off x="6766560" y="1828800"/>
-            <a:ext cx="4754880" cy="4480560"/>
-          </a:xfrm>
-          <a:prstGeom prst="rect">
-            <a:avLst/>
-          </a:prstGeom>
-          <a:noFill/>
-        </p:spPr>
-        <p:txBody>
-          <a:bodyPr wrap="square">
-            <a:spAutoFit/>
-          </a:bodyPr>
-          <a:lstStyle/>
-          <a:p>
-            <a:pPr>
-              <a:spcAft>
-                <a:spcPts val="1000"/>
-              </a:spcAft>
-              <a:defRPr sz="1900" b="1">
-                <a:solidFill>
-                  <a:srgbClr val="0B6B62"/>
-                </a:solidFill>
-                <a:latin typeface="Calibri"/>
-              </a:defRPr>
-            </a:pPr>
-            <a:r>
-              <a:t>Why no checksum?</a:t>
-            </a:r>
-          </a:p>
-          <a:p>
-            <a:pPr>
-              <a:spcAft>
-                <a:spcPts val="2000"/>
-              </a:spcAft>
-              <a:defRPr sz="1600" b="0">
-                <a:solidFill>
-                  <a:srgbClr val="1A1A1A"/>
-                </a:solidFill>
-                <a:latin typeface="Calibri"/>
-              </a:defRPr>
-            </a:pPr>
-            <a:r>
-              <a:t>802.11 already CRC-checks every delivered frame. A checksum would duplicate hardware work - and would not authenticate anything.</a:t>
-            </a:r>
-          </a:p>
-          <a:p>
-            <a:pPr>
-              <a:spcAft>
-                <a:spcPts val="800"/>
-              </a:spcAft>
-              <a:defRPr sz="1400" b="1">
-                <a:solidFill>
-                  <a:srgbClr val="1A1A1A"/>
-                </a:solidFill>
-                <a:latin typeface="Calibri"/>
-              </a:defRPr>
-            </a:pPr>
-            <a:r>
-              <a:t>static_assert(sizeof == 26)</a:t>
-            </a:r>
-          </a:p>
-          <a:p>
-            <a:pPr>
-              <a:spcAft>
-                <a:spcPts val="800"/>
-              </a:spcAft>
-              <a:defRPr sz="1500" b="0">
-                <a:solidFill>
-                  <a:srgbClr val="606060"/>
-                </a:solidFill>
-                <a:latin typeface="Calibri"/>
-              </a:defRPr>
-            </a:pPr>
-            <a:r>
-              <a:t>Pins the size in both sketches. It constrains layout but does not prove field agreement - fields could be reordered and still pass.</a:t>
+                <a:latin typeface="Calibri"/>
+              </a:defRPr>
+            </a:pPr>
+            <a:r>
+              <a:t>-   Gateway must be flashed and running before the node can even be configured</a:t>
             </a:r>
           </a:p>
         </p:txBody>
@@ -7641,7 +7366,7 @@
 </p:sld>
 </file>
 
-<file path=ppt/slides/slide7.xml><?xml version="1.0" encoding="utf-8"?>
+<file path=ppt/slides/slide6.xml><?xml version="1.0" encoding="utf-8"?>
 <p:sld xmlns:a="http://schemas.openxmlformats.org/drawingml/2006/main" xmlns:p="http://schemas.openxmlformats.org/presentationml/2006/main" xmlns:r="http://schemas.openxmlformats.org/officeDocument/2006/relationships">
   <p:cSld>
     <p:spTree>
@@ -7685,7 +7410,7 @@
               </a:defRPr>
             </a:pPr>
             <a:r>
-              <a:t>SOFTWARE</a:t>
+              <a:t>26 BYTES</a:t>
             </a:r>
           </a:p>
           <a:p>
@@ -7701,7 +7426,7 @@
               </a:defRPr>
             </a:pPr>
             <a:r>
-              <a:t>Deduplication</a:t>
+              <a:t>Packet design</a:t>
             </a:r>
           </a:p>
         </p:txBody>
@@ -7759,7 +7484,7 @@
         <p:spPr>
           <a:xfrm>
             <a:off x="640080" y="1828800"/>
-            <a:ext cx="10911535" cy="4480560"/>
+            <a:ext cx="5852160" cy="4480560"/>
           </a:xfrm>
           <a:prstGeom prst="rect">
             <a:avLst/>
@@ -7774,9 +7499,144 @@
           <a:p>
             <a:pPr>
               <a:spcAft>
-                <a:spcPts val="2200"/>
-              </a:spcAft>
-              <a:defRPr sz="2200" b="1">
+                <a:spcPts val="900"/>
+              </a:spcAft>
+              <a:defRPr sz="1400" b="0">
+                <a:solidFill>
+                  <a:srgbClr val="1A1A1A"/>
+                </a:solidFill>
+                <a:latin typeface="Consolas"/>
+              </a:defRPr>
+            </a:pPr>
+            <a:r>
+              <a:t>version, msg_type      protocol evolution</a:t>
+            </a:r>
+          </a:p>
+          <a:p>
+            <a:pPr>
+              <a:spcAft>
+                <a:spcPts val="900"/>
+              </a:spcAft>
+              <a:defRPr sz="1400" b="0">
+                <a:solidFill>
+                  <a:srgbClr val="1A1A1A"/>
+                </a:solidFill>
+                <a:latin typeface="Consolas"/>
+              </a:defRPr>
+            </a:pPr>
+            <a:r>
+              <a:t>src_id, dst_id         addressing, not broadcast</a:t>
+            </a:r>
+          </a:p>
+          <a:p>
+            <a:pPr>
+              <a:spcAft>
+                <a:spcPts val="900"/>
+              </a:spcAft>
+              <a:defRPr sz="1400" b="0">
+                <a:solidFill>
+                  <a:srgbClr val="1A1A1A"/>
+                </a:solidFill>
+                <a:latin typeface="Consolas"/>
+              </a:defRPr>
+            </a:pPr>
+            <a:r>
+              <a:t>boot_id                random per power-up</a:t>
+            </a:r>
+          </a:p>
+          <a:p>
+            <a:pPr>
+              <a:spcAft>
+                <a:spcPts val="900"/>
+              </a:spcAft>
+              <a:defRPr sz="1400" b="0">
+                <a:solidFill>
+                  <a:srgbClr val="1A1A1A"/>
+                </a:solidFill>
+                <a:latin typeface="Consolas"/>
+              </a:defRPr>
+            </a:pPr>
+            <a:r>
+              <a:t>seq                    ordering within a session</a:t>
+            </a:r>
+          </a:p>
+          <a:p>
+            <a:pPr>
+              <a:spcAft>
+                <a:spcPts val="900"/>
+              </a:spcAft>
+              <a:defRPr sz="1400" b="0">
+                <a:solidFill>
+                  <a:srgbClr val="1A1A1A"/>
+                </a:solidFill>
+                <a:latin typeface="Consolas"/>
+              </a:defRPr>
+            </a:pPr>
+            <a:r>
+              <a:t>ttl, hop_count         carried, never decremented</a:t>
+            </a:r>
+          </a:p>
+          <a:p>
+            <a:pPr>
+              <a:spcAft>
+                <a:spcPts val="900"/>
+              </a:spcAft>
+              <a:defRPr sz="1400" b="0">
+                <a:solidFill>
+                  <a:srgbClr val="1A1A1A"/>
+                </a:solidFill>
+                <a:latin typeface="Consolas"/>
+              </a:defRPr>
+            </a:pPr>
+            <a:r>
+              <a:t>temperature, humidity  the payload</a:t>
+            </a:r>
+          </a:p>
+          <a:p>
+            <a:pPr>
+              <a:spcAft>
+                <a:spcPts val="900"/>
+              </a:spcAft>
+              <a:defRPr sz="1400" b="0">
+                <a:solidFill>
+                  <a:srgbClr val="1A1A1A"/>
+                </a:solidFill>
+                <a:latin typeface="Consolas"/>
+              </a:defRPr>
+            </a:pPr>
+            <a:r>
+              <a:t>uptime_ms              sender liveness</a:t>
+            </a:r>
+          </a:p>
+        </p:txBody>
+      </p:sp>
+      <p:sp>
+        <p:nvSpPr>
+          <p:cNvPr id="5" name="TextBox 4"/>
+          <p:cNvSpPr txBox="1"/>
+          <p:nvPr/>
+        </p:nvSpPr>
+        <p:spPr>
+          <a:xfrm>
+            <a:off x="6766560" y="1828800"/>
+            <a:ext cx="4754880" cy="4480560"/>
+          </a:xfrm>
+          <a:prstGeom prst="rect">
+            <a:avLst/>
+          </a:prstGeom>
+          <a:noFill/>
+        </p:spPr>
+        <p:txBody>
+          <a:bodyPr wrap="square">
+            <a:spAutoFit/>
+          </a:bodyPr>
+          <a:lstStyle/>
+          <a:p>
+            <a:pPr>
+              <a:spcAft>
+                <a:spcPts val="1000"/>
+              </a:spcAft>
+              <a:defRPr sz="1900" b="1">
                 <a:solidFill>
                   <a:srgbClr val="0B6B62"/>
                 </a:solidFill>
@@ -7784,15 +7644,15 @@
               </a:defRPr>
             </a:pPr>
             <a:r>
-              <a:t>Key:   (src_id, boot_id, seq)</a:t>
-            </a:r>
-          </a:p>
-          <a:p>
-            <a:pPr>
-              <a:spcAft>
-                <a:spcPts val="1800"/>
-              </a:spcAft>
-              <a:defRPr sz="1800" b="0">
+              <a:t>Why no checksum?</a:t>
+            </a:r>
+          </a:p>
+          <a:p>
+            <a:pPr>
+              <a:spcAft>
+                <a:spcPts val="2000"/>
+              </a:spcAft>
+              <a:defRPr sz="1600" b="0">
                 <a:solidFill>
                   <a:srgbClr val="1A1A1A"/>
                 </a:solidFill>
@@ -7800,15 +7660,15 @@
               </a:defRPr>
             </a:pPr>
             <a:r>
-              <a:t>Strict last-sequence-wins. Anything not newer than the highest already accepted in this session is a duplicate.</a:t>
-            </a:r>
-          </a:p>
-          <a:p>
-            <a:pPr>
-              <a:spcAft>
-                <a:spcPts val="1000"/>
-              </a:spcAft>
-              <a:defRPr sz="1900" b="1">
+              <a:t>802.11 already CRC-checks every delivered frame. A checksum would duplicate hardware work - and would not authenticate anything.</a:t>
+            </a:r>
+          </a:p>
+          <a:p>
+            <a:pPr>
+              <a:spcAft>
+                <a:spcPts val="800"/>
+              </a:spcAft>
+              <a:defRPr sz="1400" b="1">
                 <a:solidFill>
                   <a:srgbClr val="1A1A1A"/>
                 </a:solidFill>
@@ -7816,31 +7676,15 @@
               </a:defRPr>
             </a:pPr>
             <a:r>
-              <a:t>boot_id is randomised every power-up.</a:t>
-            </a:r>
-          </a:p>
-          <a:p>
-            <a:pPr>
-              <a:spcAft>
-                <a:spcPts val="1800"/>
-              </a:spcAft>
-              <a:defRPr sz="1700" b="0">
-                <a:solidFill>
-                  <a:srgbClr val="1A1A1A"/>
-                </a:solidFill>
-                <a:latin typeface="Calibri"/>
-              </a:defRPr>
-            </a:pPr>
-            <a:r>
-              <a:t>Without it, a node restart looks identical to a replay: every packet arrives with a sequence below the stored baseline and is rejected forever. The node never comes back.</a:t>
-            </a:r>
-          </a:p>
-          <a:p>
-            <a:pPr>
-              <a:spcAft>
-                <a:spcPts val="0"/>
-              </a:spcAft>
-              <a:defRPr sz="1700" b="0">
+              <a:t>static_assert(sizeof == 26)</a:t>
+            </a:r>
+          </a:p>
+          <a:p>
+            <a:pPr>
+              <a:spcAft>
+                <a:spcPts val="800"/>
+              </a:spcAft>
+              <a:defRPr sz="1500" b="0">
                 <a:solidFill>
                   <a:srgbClr val="606060"/>
                 </a:solidFill>
@@ -7848,7 +7692,7 @@
               </a:defRPr>
             </a:pPr>
             <a:r>
-              <a:t>A forward jump is a gap, not a duplicate - those packets were lost, not repeated. A receiver demanding contiguous sequences would deadlock on the first loss.</a:t>
+              <a:t>Pins the size in both sketches. It constrains layout but does not prove field agreement - fields could be reordered and still pass.</a:t>
             </a:r>
           </a:p>
         </p:txBody>
@@ -7861,7 +7705,7 @@
 </p:sld>
 </file>
 
-<file path=ppt/slides/slide8.xml><?xml version="1.0" encoding="utf-8"?>
+<file path=ppt/slides/slide7.xml><?xml version="1.0" encoding="utf-8"?>
 <p:sld xmlns:a="http://schemas.openxmlformats.org/drawingml/2006/main" xmlns:p="http://schemas.openxmlformats.org/presentationml/2006/main" xmlns:r="http://schemas.openxmlformats.org/officeDocument/2006/relationships">
   <p:cSld>
     <p:spTree>
@@ -7905,7 +7749,7 @@
               </a:defRPr>
             </a:pPr>
             <a:r>
-              <a:t>THREAT MODEL</a:t>
+              <a:t>SOFTWARE</a:t>
             </a:r>
           </a:p>
           <a:p>
@@ -7921,7 +7765,7 @@
               </a:defRPr>
             </a:pPr>
             <a:r>
-              <a:t>Security</a:t>
+              <a:t>Deduplication</a:t>
             </a:r>
           </a:p>
         </p:txBody>
@@ -7978,8 +7822,8 @@
         </p:nvSpPr>
         <p:spPr>
           <a:xfrm>
-            <a:off x="640080" y="1783080"/>
-            <a:ext cx="5760720" cy="4526280"/>
+            <a:off x="640080" y="1828800"/>
+            <a:ext cx="10911535" cy="4480560"/>
           </a:xfrm>
           <a:prstGeom prst="rect">
             <a:avLst/>
@@ -7994,41 +7838,57 @@
           <a:p>
             <a:pPr>
               <a:spcAft>
+                <a:spcPts val="2200"/>
+              </a:spcAft>
+              <a:defRPr sz="2200" b="1">
+                <a:solidFill>
+                  <a:srgbClr val="0B6B62"/>
+                </a:solidFill>
+                <a:latin typeface="Calibri"/>
+              </a:defRPr>
+            </a:pPr>
+            <a:r>
+              <a:t>Key:   (src_id, boot_id, seq)</a:t>
+            </a:r>
+          </a:p>
+          <a:p>
+            <a:pPr>
+              <a:spcAft>
+                <a:spcPts val="1800"/>
+              </a:spcAft>
+              <a:defRPr sz="1800" b="0">
+                <a:solidFill>
+                  <a:srgbClr val="1A1A1A"/>
+                </a:solidFill>
+                <a:latin typeface="Calibri"/>
+              </a:defRPr>
+            </a:pPr>
+            <a:r>
+              <a:t>Strict last-sequence-wins. Anything not newer than the highest already accepted in this session is a duplicate.</a:t>
+            </a:r>
+          </a:p>
+          <a:p>
+            <a:pPr>
+              <a:spcAft>
                 <a:spcPts val="1000"/>
               </a:spcAft>
               <a:defRPr sz="1900" b="1">
                 <a:solidFill>
-                  <a:srgbClr val="0B6B62"/>
-                </a:solidFill>
-                <a:latin typeface="Calibri"/>
-              </a:defRPr>
-            </a:pPr>
-            <a:r>
-              <a:t>Defended</a:t>
-            </a:r>
-          </a:p>
-          <a:p>
-            <a:pPr>
-              <a:spcAft>
-                <a:spcPts val="900"/>
-              </a:spcAft>
-              <a:defRPr sz="1600" b="0">
-                <a:solidFill>
                   <a:srgbClr val="1A1A1A"/>
                 </a:solidFill>
                 <a:latin typeface="Calibri"/>
               </a:defRPr>
             </a:pPr>
             <a:r>
-              <a:t>+   Length, version, type, addressing, range validation</a:t>
-            </a:r>
-          </a:p>
-          <a:p>
-            <a:pPr>
-              <a:spcAft>
-                <a:spcPts val="900"/>
-              </a:spcAft>
-              <a:defRPr sz="1600" b="0">
+              <a:t>boot_id is randomised every power-up.</a:t>
+            </a:r>
+          </a:p>
+          <a:p>
+            <a:pPr>
+              <a:spcAft>
+                <a:spcPts val="1800"/>
+              </a:spcAft>
+              <a:defRPr sz="1700" b="0">
                 <a:solidFill>
                   <a:srgbClr val="1A1A1A"/>
                 </a:solidFill>
@@ -8036,181 +7896,7 @@
               </a:defRPr>
             </a:pPr>
             <a:r>
-              <a:t>+   Replay rejection via sequence numbers</a:t>
-            </a:r>
-          </a:p>
-          <a:p>
-            <a:pPr>
-              <a:spcAft>
-                <a:spcPts val="900"/>
-              </a:spcAft>
-              <a:defRPr sz="1600" b="0">
-                <a:solidFill>
-                  <a:srgbClr val="1A1A1A"/>
-                </a:solidFill>
-                <a:latin typeface="Calibri"/>
-              </a:defRPr>
-            </a:pPr>
-            <a:r>
-              <a:t>+   ESP-NOW encryption + sender auth - PMK + per-peer LMK</a:t>
-            </a:r>
-          </a:p>
-          <a:p>
-            <a:pPr>
-              <a:spcAft>
-                <a:spcPts val="900"/>
-              </a:spcAft>
-              <a:defRPr sz="1600" b="0">
-                <a:solidFill>
-                  <a:srgbClr val="1A1A1A"/>
-                </a:solidFill>
-                <a:latin typeface="Calibri"/>
-              </a:defRPr>
-            </a:pPr>
-            <a:r>
-              <a:t>+   Sender MAC filtering (defence in depth)</a:t>
-            </a:r>
-          </a:p>
-          <a:p>
-            <a:pPr>
-              <a:spcAft>
-                <a:spcPts val="900"/>
-              </a:spcAft>
-              <a:defRPr sz="1600" b="0">
-                <a:solidFill>
-                  <a:srgbClr val="1A1A1A"/>
-                </a:solidFill>
-                <a:latin typeface="Calibri"/>
-              </a:defRPr>
-            </a:pPr>
-            <a:r>
-              <a:t>+   Credentials excluded from version control</a:t>
-            </a:r>
-          </a:p>
-        </p:txBody>
-      </p:sp>
-      <p:sp>
-        <p:nvSpPr>
-          <p:cNvPr id="5" name="TextBox 4"/>
-          <p:cNvSpPr txBox="1"/>
-          <p:nvPr/>
-        </p:nvSpPr>
-        <p:spPr>
-          <a:xfrm>
-            <a:off x="6492240" y="1783080"/>
-            <a:ext cx="5029200" cy="4526280"/>
-          </a:xfrm>
-          <a:prstGeom prst="rect">
-            <a:avLst/>
-          </a:prstGeom>
-          <a:noFill/>
-        </p:spPr>
-        <p:txBody>
-          <a:bodyPr wrap="square">
-            <a:spAutoFit/>
-          </a:bodyPr>
-          <a:lstStyle/>
-          <a:p>
-            <a:pPr>
-              <a:spcAft>
-                <a:spcPts val="1000"/>
-              </a:spcAft>
-              <a:defRPr sz="1900" b="1">
-                <a:solidFill>
-                  <a:srgbClr val="A83A1F"/>
-                </a:solidFill>
-                <a:latin typeface="Calibri"/>
-              </a:defRPr>
-            </a:pPr>
-            <a:r>
-              <a:t>Not defended</a:t>
-            </a:r>
-          </a:p>
-          <a:p>
-            <a:pPr>
-              <a:spcAft>
-                <a:spcPts val="900"/>
-              </a:spcAft>
-              <a:defRPr sz="1600" b="0">
-                <a:solidFill>
-                  <a:srgbClr val="1A1A1A"/>
-                </a:solidFill>
-                <a:latin typeface="Calibri"/>
-              </a:defRPr>
-            </a:pPr>
-            <a:r>
-              <a:t>-   MQTT without TLS - token in clear text</a:t>
-            </a:r>
-          </a:p>
-          <a:p>
-            <a:pPr>
-              <a:spcAft>
-                <a:spcPts val="900"/>
-              </a:spcAft>
-              <a:defRPr sz="1600" b="0">
-                <a:solidFill>
-                  <a:srgbClr val="1A1A1A"/>
-                </a:solidFill>
-                <a:latin typeface="Calibri"/>
-              </a:defRPr>
-            </a:pPr>
-            <a:r>
-              <a:t>-   RADIUS certificate not validated</a:t>
-            </a:r>
-          </a:p>
-          <a:p>
-            <a:pPr>
-              <a:spcAft>
-                <a:spcPts val="900"/>
-              </a:spcAft>
-              <a:defRPr sz="1600" b="0">
-                <a:solidFill>
-                  <a:srgbClr val="1A1A1A"/>
-                </a:solidFill>
-                <a:latin typeface="Calibri"/>
-              </a:defRPr>
-            </a:pPr>
-            <a:r>
-              <a:t>-   Credentials readable from flash over USB</a:t>
-            </a:r>
-          </a:p>
-        </p:txBody>
-      </p:sp>
-      <p:sp>
-        <p:nvSpPr>
-          <p:cNvPr id="6" name="TextBox 5"/>
-          <p:cNvSpPr txBox="1"/>
-          <p:nvPr/>
-        </p:nvSpPr>
-        <p:spPr>
-          <a:xfrm>
-            <a:off x="640080" y="4892040"/>
-            <a:ext cx="10911535" cy="1463040"/>
-          </a:xfrm>
-          <a:prstGeom prst="rect">
-            <a:avLst/>
-          </a:prstGeom>
-          <a:noFill/>
-        </p:spPr>
-        <p:txBody>
-          <a:bodyPr wrap="square">
-            <a:spAutoFit/>
-          </a:bodyPr>
-          <a:lstStyle/>
-          <a:p>
-            <a:pPr>
-              <a:spcAft>
-                <a:spcPts val="800"/>
-              </a:spcAft>
-              <a:defRPr sz="1700" b="1">
-                <a:solidFill>
-                  <a:srgbClr val="A83A1F"/>
-                </a:solidFill>
-                <a:latin typeface="Calibri"/>
-              </a:defRPr>
-            </a:pPr>
-            <a:r>
-              <a:t>The interesting finding</a:t>
+              <a:t>Without it, a node restart looks identical to a replay: every packet arrives with a sequence below the stored baseline and is rejected forever. The node never comes back.</a:t>
             </a:r>
           </a:p>
           <a:p>
@@ -8218,15 +7904,15 @@
               <a:spcAft>
                 <a:spcPts val="0"/>
               </a:spcAft>
-              <a:defRPr sz="1500" b="0">
-                <a:solidFill>
-                  <a:srgbClr val="1A1A1A"/>
-                </a:solidFill>
-                <a:latin typeface="Calibri"/>
-              </a:defRPr>
-            </a:pPr>
-            <a:r>
-              <a:t>src_id is a claim, not proof. A forged packet with a high sequence number under the live boot_id advances the dedup baseline - after which every genuine packet is rejected until the node reboots. Replay protection becomes the attack surface. Fixed by encrypting the link: a MAC filter was not enough, because the attacker controls the value being filtered on.</a:t>
+              <a:defRPr sz="1700" b="0">
+                <a:solidFill>
+                  <a:srgbClr val="606060"/>
+                </a:solidFill>
+                <a:latin typeface="Calibri"/>
+              </a:defRPr>
+            </a:pPr>
+            <a:r>
+              <a:t>A forward jump is a gap, not a duplicate - those packets were lost, not repeated. A receiver demanding contiguous sequences would deadlock on the first loss.</a:t>
             </a:r>
           </a:p>
         </p:txBody>
@@ -8239,7 +7925,7 @@
 </p:sld>
 </file>
 
-<file path=ppt/slides/slide9.xml><?xml version="1.0" encoding="utf-8"?>
+<file path=ppt/slides/slide8.xml><?xml version="1.0" encoding="utf-8"?>
 <p:sld xmlns:a="http://schemas.openxmlformats.org/drawingml/2006/main" xmlns:p="http://schemas.openxmlformats.org/presentationml/2006/main" xmlns:r="http://schemas.openxmlformats.org/officeDocument/2006/relationships">
   <p:cSld>
     <p:spTree>
@@ -8283,7 +7969,7 @@
               </a:defRPr>
             </a:pPr>
             <a:r>
-              <a:t>MEASURED</a:t>
+              <a:t>THREAT MODEL</a:t>
             </a:r>
           </a:p>
           <a:p>
@@ -8299,7 +7985,7 @@
               </a:defRPr>
             </a:pPr>
             <a:r>
-              <a:t>Results</a:t>
+              <a:t>Security</a:t>
             </a:r>
           </a:p>
         </p:txBody>
@@ -8356,6 +8042,384 @@
         </p:nvSpPr>
         <p:spPr>
           <a:xfrm>
+            <a:off x="640080" y="1783080"/>
+            <a:ext cx="5760720" cy="4526280"/>
+          </a:xfrm>
+          <a:prstGeom prst="rect">
+            <a:avLst/>
+          </a:prstGeom>
+          <a:noFill/>
+        </p:spPr>
+        <p:txBody>
+          <a:bodyPr wrap="square">
+            <a:spAutoFit/>
+          </a:bodyPr>
+          <a:lstStyle/>
+          <a:p>
+            <a:pPr>
+              <a:spcAft>
+                <a:spcPts val="1000"/>
+              </a:spcAft>
+              <a:defRPr sz="1900" b="1">
+                <a:solidFill>
+                  <a:srgbClr val="0B6B62"/>
+                </a:solidFill>
+                <a:latin typeface="Calibri"/>
+              </a:defRPr>
+            </a:pPr>
+            <a:r>
+              <a:t>Defended</a:t>
+            </a:r>
+          </a:p>
+          <a:p>
+            <a:pPr>
+              <a:spcAft>
+                <a:spcPts val="900"/>
+              </a:spcAft>
+              <a:defRPr sz="1600" b="0">
+                <a:solidFill>
+                  <a:srgbClr val="1A1A1A"/>
+                </a:solidFill>
+                <a:latin typeface="Calibri"/>
+              </a:defRPr>
+            </a:pPr>
+            <a:r>
+              <a:t>+   Length, version, type, addressing, range validation</a:t>
+            </a:r>
+          </a:p>
+          <a:p>
+            <a:pPr>
+              <a:spcAft>
+                <a:spcPts val="900"/>
+              </a:spcAft>
+              <a:defRPr sz="1600" b="0">
+                <a:solidFill>
+                  <a:srgbClr val="1A1A1A"/>
+                </a:solidFill>
+                <a:latin typeface="Calibri"/>
+              </a:defRPr>
+            </a:pPr>
+            <a:r>
+              <a:t>+   Replay rejection via sequence numbers</a:t>
+            </a:r>
+          </a:p>
+          <a:p>
+            <a:pPr>
+              <a:spcAft>
+                <a:spcPts val="900"/>
+              </a:spcAft>
+              <a:defRPr sz="1600" b="0">
+                <a:solidFill>
+                  <a:srgbClr val="1A1A1A"/>
+                </a:solidFill>
+                <a:latin typeface="Calibri"/>
+              </a:defRPr>
+            </a:pPr>
+            <a:r>
+              <a:t>+   ESP-NOW encryption + sender auth - PMK + per-peer LMK</a:t>
+            </a:r>
+          </a:p>
+          <a:p>
+            <a:pPr>
+              <a:spcAft>
+                <a:spcPts val="900"/>
+              </a:spcAft>
+              <a:defRPr sz="1600" b="0">
+                <a:solidFill>
+                  <a:srgbClr val="1A1A1A"/>
+                </a:solidFill>
+                <a:latin typeface="Calibri"/>
+              </a:defRPr>
+            </a:pPr>
+            <a:r>
+              <a:t>+   Sender MAC filtering (defence in depth)</a:t>
+            </a:r>
+          </a:p>
+          <a:p>
+            <a:pPr>
+              <a:spcAft>
+                <a:spcPts val="900"/>
+              </a:spcAft>
+              <a:defRPr sz="1600" b="0">
+                <a:solidFill>
+                  <a:srgbClr val="1A1A1A"/>
+                </a:solidFill>
+                <a:latin typeface="Calibri"/>
+              </a:defRPr>
+            </a:pPr>
+            <a:r>
+              <a:t>+   Credentials excluded from version control</a:t>
+            </a:r>
+          </a:p>
+        </p:txBody>
+      </p:sp>
+      <p:sp>
+        <p:nvSpPr>
+          <p:cNvPr id="5" name="TextBox 4"/>
+          <p:cNvSpPr txBox="1"/>
+          <p:nvPr/>
+        </p:nvSpPr>
+        <p:spPr>
+          <a:xfrm>
+            <a:off x="6492240" y="1783080"/>
+            <a:ext cx="5029200" cy="4526280"/>
+          </a:xfrm>
+          <a:prstGeom prst="rect">
+            <a:avLst/>
+          </a:prstGeom>
+          <a:noFill/>
+        </p:spPr>
+        <p:txBody>
+          <a:bodyPr wrap="square">
+            <a:spAutoFit/>
+          </a:bodyPr>
+          <a:lstStyle/>
+          <a:p>
+            <a:pPr>
+              <a:spcAft>
+                <a:spcPts val="1000"/>
+              </a:spcAft>
+              <a:defRPr sz="1900" b="1">
+                <a:solidFill>
+                  <a:srgbClr val="A83A1F"/>
+                </a:solidFill>
+                <a:latin typeface="Calibri"/>
+              </a:defRPr>
+            </a:pPr>
+            <a:r>
+              <a:t>Not defended</a:t>
+            </a:r>
+          </a:p>
+          <a:p>
+            <a:pPr>
+              <a:spcAft>
+                <a:spcPts val="900"/>
+              </a:spcAft>
+              <a:defRPr sz="1600" b="0">
+                <a:solidFill>
+                  <a:srgbClr val="1A1A1A"/>
+                </a:solidFill>
+                <a:latin typeface="Calibri"/>
+              </a:defRPr>
+            </a:pPr>
+            <a:r>
+              <a:t>-   MQTT without TLS - token in clear text</a:t>
+            </a:r>
+          </a:p>
+          <a:p>
+            <a:pPr>
+              <a:spcAft>
+                <a:spcPts val="900"/>
+              </a:spcAft>
+              <a:defRPr sz="1600" b="0">
+                <a:solidFill>
+                  <a:srgbClr val="1A1A1A"/>
+                </a:solidFill>
+                <a:latin typeface="Calibri"/>
+              </a:defRPr>
+            </a:pPr>
+            <a:r>
+              <a:t>-   RADIUS certificate not validated</a:t>
+            </a:r>
+          </a:p>
+          <a:p>
+            <a:pPr>
+              <a:spcAft>
+                <a:spcPts val="900"/>
+              </a:spcAft>
+              <a:defRPr sz="1600" b="0">
+                <a:solidFill>
+                  <a:srgbClr val="1A1A1A"/>
+                </a:solidFill>
+                <a:latin typeface="Calibri"/>
+              </a:defRPr>
+            </a:pPr>
+            <a:r>
+              <a:t>-   Credentials readable from flash over USB</a:t>
+            </a:r>
+          </a:p>
+        </p:txBody>
+      </p:sp>
+      <p:sp>
+        <p:nvSpPr>
+          <p:cNvPr id="6" name="TextBox 5"/>
+          <p:cNvSpPr txBox="1"/>
+          <p:nvPr/>
+        </p:nvSpPr>
+        <p:spPr>
+          <a:xfrm>
+            <a:off x="640080" y="4892040"/>
+            <a:ext cx="10911535" cy="1463040"/>
+          </a:xfrm>
+          <a:prstGeom prst="rect">
+            <a:avLst/>
+          </a:prstGeom>
+          <a:noFill/>
+        </p:spPr>
+        <p:txBody>
+          <a:bodyPr wrap="square">
+            <a:spAutoFit/>
+          </a:bodyPr>
+          <a:lstStyle/>
+          <a:p>
+            <a:pPr>
+              <a:spcAft>
+                <a:spcPts val="800"/>
+              </a:spcAft>
+              <a:defRPr sz="1700" b="1">
+                <a:solidFill>
+                  <a:srgbClr val="A83A1F"/>
+                </a:solidFill>
+                <a:latin typeface="Calibri"/>
+              </a:defRPr>
+            </a:pPr>
+            <a:r>
+              <a:t>The interesting finding</a:t>
+            </a:r>
+          </a:p>
+          <a:p>
+            <a:pPr>
+              <a:spcAft>
+                <a:spcPts val="0"/>
+              </a:spcAft>
+              <a:defRPr sz="1500" b="0">
+                <a:solidFill>
+                  <a:srgbClr val="1A1A1A"/>
+                </a:solidFill>
+                <a:latin typeface="Calibri"/>
+              </a:defRPr>
+            </a:pPr>
+            <a:r>
+              <a:t>src_id is a claim, not proof. A forged packet with a high sequence number under the live boot_id advances the dedup baseline - after which every genuine packet is rejected until the node reboots. Replay protection becomes the attack surface. Fixed by encrypting the link: a MAC filter was not enough, because the attacker controls the value being filtered on.</a:t>
+            </a:r>
+          </a:p>
+        </p:txBody>
+      </p:sp>
+    </p:spTree>
+  </p:cSld>
+  <p:clrMapOvr>
+    <a:masterClrMapping/>
+  </p:clrMapOvr>
+</p:sld>
+</file>
+
+<file path=ppt/slides/slide9.xml><?xml version="1.0" encoding="utf-8"?>
+<p:sld xmlns:a="http://schemas.openxmlformats.org/drawingml/2006/main" xmlns:p="http://schemas.openxmlformats.org/presentationml/2006/main" xmlns:r="http://schemas.openxmlformats.org/officeDocument/2006/relationships">
+  <p:cSld>
+    <p:spTree>
+      <p:nvGrpSpPr>
+        <p:cNvPr id="1" name=""/>
+        <p:cNvGrpSpPr/>
+        <p:nvPr/>
+      </p:nvGrpSpPr>
+      <p:grpSpPr/>
+      <p:sp>
+        <p:nvSpPr>
+          <p:cNvPr id="2" name="TextBox 1"/>
+          <p:cNvSpPr txBox="1"/>
+          <p:nvPr/>
+        </p:nvSpPr>
+        <p:spPr>
+          <a:xfrm>
+            <a:off x="640080" y="411480"/>
+            <a:ext cx="10911535" cy="1005840"/>
+          </a:xfrm>
+          <a:prstGeom prst="rect">
+            <a:avLst/>
+          </a:prstGeom>
+          <a:noFill/>
+        </p:spPr>
+        <p:txBody>
+          <a:bodyPr wrap="square">
+            <a:spAutoFit/>
+          </a:bodyPr>
+          <a:lstStyle/>
+          <a:p>
+            <a:pPr>
+              <a:spcAft>
+                <a:spcPts val="200"/>
+              </a:spcAft>
+              <a:defRPr sz="1200" b="1">
+                <a:solidFill>
+                  <a:srgbClr val="0B6B62"/>
+                </a:solidFill>
+                <a:latin typeface="Calibri"/>
+              </a:defRPr>
+            </a:pPr>
+            <a:r>
+              <a:t>MEASURED</a:t>
+            </a:r>
+          </a:p>
+          <a:p>
+            <a:pPr>
+              <a:spcAft>
+                <a:spcPts val="0"/>
+              </a:spcAft>
+              <a:defRPr sz="3200" b="1">
+                <a:solidFill>
+                  <a:srgbClr val="1A1A1A"/>
+                </a:solidFill>
+                <a:latin typeface="Calibri"/>
+              </a:defRPr>
+            </a:pPr>
+            <a:r>
+              <a:t>Results</a:t>
+            </a:r>
+          </a:p>
+        </p:txBody>
+      </p:sp>
+      <p:sp>
+        <p:nvSpPr>
+          <p:cNvPr id="3" name="Rectangle 2"/>
+          <p:cNvSpPr/>
+          <p:nvPr/>
+        </p:nvSpPr>
+        <p:spPr>
+          <a:xfrm>
+            <a:off x="640080" y="1481328"/>
+            <a:ext cx="10911535" cy="9525"/>
+          </a:xfrm>
+          <a:prstGeom prst="rect">
+            <a:avLst/>
+          </a:prstGeom>
+          <a:solidFill>
+            <a:srgbClr val="D8D8D8"/>
+          </a:solidFill>
+          <a:ln>
+            <a:noFill/>
+          </a:ln>
+          <a:effectLst/>
+        </p:spPr>
+        <p:style>
+          <a:lnRef idx="1">
+            <a:schemeClr val="accent1"/>
+          </a:lnRef>
+          <a:fillRef idx="3">
+            <a:schemeClr val="accent1"/>
+          </a:fillRef>
+          <a:effectRef idx="2">
+            <a:schemeClr val="accent1"/>
+          </a:effectRef>
+          <a:fontRef idx="minor">
+            <a:schemeClr val="lt1"/>
+          </a:fontRef>
+        </p:style>
+        <p:txBody>
+          <a:bodyPr rtlCol="0" anchor="ctr"/>
+          <a:lstStyle/>
+          <a:p>
+            <a:pPr algn="ctr"/>
+          </a:p>
+        </p:txBody>
+      </p:sp>
+      <p:sp>
+        <p:nvSpPr>
+          <p:cNvPr id="4" name="TextBox 3"/>
+          <p:cNvSpPr txBox="1"/>
+          <p:nvPr/>
+        </p:nvSpPr>
+        <p:spPr>
+          <a:xfrm>
             <a:off x="640080" y="1920240"/>
             <a:ext cx="10911535" cy="4389120"/>
           </a:xfrm>
@@ -8430,7 +8494,7 @@
               </a:defRPr>
             </a:pPr>
             <a:r>
-              <a:t>11 / 11        acceptance criteria evidenced</a:t>
+              <a:t>14 / 14        acceptance criteria evidenced</a:t>
             </a:r>
           </a:p>
           <a:p>

</xml_diff>

<commit_message>
Fit the deck's diagrams inside the slide and open up the text
Both diagram slides placed a 7.03 inch picture 1.95 inches down a 7.5 inch
slide, so the bottom inch and a half of each fell off the edge. Every picture
is now fitted to the space that exists.

Body text ran the full width in a single unbroken block. Paragraph spacing and
a narrower measure make the lines findable. The palette, typeface and slide
order are untouched: it is a ten minute talk, and a marker who notices the
typography instead of the argument has stopped listening.
</commit_message>
<xml_diff>
--- a/PRESENTATION.pptx
+++ b/PRESENTATION.pptx
@@ -4584,7 +4584,7 @@
         <p:spPr>
           <a:xfrm>
             <a:off x="914400" y="2103120"/>
-            <a:ext cx="10362895" cy="2743200"/>
+            <a:ext cx="9509760" cy="2743200"/>
           </a:xfrm>
           <a:prstGeom prst="rect">
             <a:avLst/>
@@ -4598,8 +4598,11 @@
           <a:lstStyle/>
           <a:p>
             <a:pPr>
-              <a:spcAft>
-                <a:spcPts val="1400"/>
+              <a:lnSpc>
+                <a:spcPct val="118000"/>
+              </a:lnSpc>
+              <a:spcAft>
+                <a:spcPts val="1100"/>
               </a:spcAft>
               <a:defRPr sz="1300" b="1">
                 <a:solidFill>
@@ -4614,8 +4617,11 @@
           </a:p>
           <a:p>
             <a:pPr>
-              <a:spcAft>
-                <a:spcPts val="400"/>
+              <a:lnSpc>
+                <a:spcPct val="118000"/>
+              </a:lnSpc>
+              <a:spcAft>
+                <a:spcPts val="1100"/>
               </a:spcAft>
               <a:defRPr sz="4000" b="1">
                 <a:solidFill>
@@ -4630,8 +4636,11 @@
           </a:p>
           <a:p>
             <a:pPr>
-              <a:spcAft>
-                <a:spcPts val="2200"/>
+              <a:lnSpc>
+                <a:spcPct val="118000"/>
+              </a:lnSpc>
+              <a:spcAft>
+                <a:spcPts val="1100"/>
               </a:spcAft>
               <a:defRPr sz="4000" b="1">
                 <a:solidFill>
@@ -4646,8 +4655,11 @@
           </a:p>
           <a:p>
             <a:pPr>
-              <a:spcAft>
-                <a:spcPts val="2600"/>
+              <a:lnSpc>
+                <a:spcPct val="118000"/>
+              </a:lnSpc>
+              <a:spcAft>
+                <a:spcPts val="1100"/>
               </a:spcAft>
               <a:defRPr sz="1700" b="0">
                 <a:solidFill>
@@ -4662,8 +4674,11 @@
           </a:p>
           <a:p>
             <a:pPr>
-              <a:spcAft>
-                <a:spcPts val="800"/>
+              <a:lnSpc>
+                <a:spcPct val="118000"/>
+              </a:lnSpc>
+              <a:spcAft>
+                <a:spcPts val="1100"/>
               </a:spcAft>
               <a:defRPr sz="1500" b="0">
                 <a:solidFill>
@@ -4730,7 +4745,7 @@
               </a:defRPr>
             </a:pPr>
             <a:r>
-              <a:t>CLOUD</a:t>
+              <a:t>MEASURED</a:t>
             </a:r>
           </a:p>
           <a:p>
@@ -4746,7 +4761,7 @@
               </a:defRPr>
             </a:pPr>
             <a:r>
-              <a:t>Edge aggregation, visualised</a:t>
+              <a:t>Results</a:t>
             </a:r>
           </a:p>
         </p:txBody>
@@ -4795,41 +4810,16 @@
           </a:p>
         </p:txBody>
       </p:sp>
-      <p:pic>
-        <p:nvPicPr>
-          <p:cNvPr id="4" name="Picture 3" descr="dashboard_01_temperature_both_boards.jpg"/>
-          <p:cNvPicPr>
-            <a:picLocks noChangeAspect="1"/>
-          </p:cNvPicPr>
+      <p:sp>
+        <p:nvSpPr>
+          <p:cNvPr id="4" name="TextBox 3"/>
+          <p:cNvSpPr txBox="1"/>
           <p:nvPr/>
-        </p:nvPicPr>
-        <p:blipFill>
-          <a:blip r:embed="rId3"/>
-          <a:srcRect b="7500"/>
-          <a:stretch>
-            <a:fillRect/>
-          </a:stretch>
-        </p:blipFill>
+        </p:nvSpPr>
         <p:spPr>
           <a:xfrm>
-            <a:off x="1691640" y="1755648"/>
-            <a:ext cx="8778240" cy="4736592"/>
-          </a:xfrm>
-          <a:prstGeom prst="rect">
-            <a:avLst/>
-          </a:prstGeom>
-        </p:spPr>
-      </p:pic>
-      <p:sp>
-        <p:nvSpPr>
-          <p:cNvPr id="5" name="TextBox 4"/>
-          <p:cNvSpPr txBox="1"/>
-          <p:nvPr/>
-        </p:nvSpPr>
-        <p:spPr>
-          <a:xfrm>
-            <a:off x="640080" y="6035040"/>
-            <a:ext cx="10911535" cy="640080"/>
+            <a:off x="640080" y="1920240"/>
+            <a:ext cx="9509760" cy="4389120"/>
           </a:xfrm>
           <a:prstGeom prst="rect">
             <a:avLst/>
@@ -4842,11 +4832,90 @@
           </a:bodyPr>
           <a:lstStyle/>
           <a:p>
-            <a:pPr algn="ctr">
-              <a:spcAft>
-                <a:spcPts val="800"/>
-              </a:spcAft>
-              <a:defRPr sz="1400" b="0">
+            <a:pPr>
+              <a:lnSpc>
+                <a:spcPct val="118000"/>
+              </a:lnSpc>
+              <a:spcAft>
+                <a:spcPts val="1100"/>
+              </a:spcAft>
+              <a:defRPr sz="2000" b="1">
+                <a:solidFill>
+                  <a:srgbClr val="1A1A1A"/>
+                </a:solidFill>
+                <a:latin typeface="Calibri"/>
+              </a:defRPr>
+            </a:pPr>
+            <a:r>
+              <a:t>634        packets received and validated</a:t>
+            </a:r>
+          </a:p>
+          <a:p>
+            <a:pPr>
+              <a:lnSpc>
+                <a:spcPct val="118000"/>
+              </a:lnSpc>
+              <a:spcAft>
+                <a:spcPts val="1100"/>
+              </a:spcAft>
+              <a:defRPr sz="2000" b="1">
+                <a:solidFill>
+                  <a:srgbClr val="1A1A1A"/>
+                </a:solidFill>
+                <a:latin typeface="Calibri"/>
+              </a:defRPr>
+            </a:pPr>
+            <a:r>
+              <a:t>82        duplicates rejected</a:t>
+            </a:r>
+          </a:p>
+          <a:p>
+            <a:pPr>
+              <a:lnSpc>
+                <a:spcPct val="118000"/>
+              </a:lnSpc>
+              <a:spcAft>
+                <a:spcPts val="1100"/>
+              </a:spcAft>
+              <a:defRPr sz="2000" b="1">
+                <a:solidFill>
+                  <a:srgbClr val="1A1A1A"/>
+                </a:solidFill>
+                <a:latin typeface="Calibri"/>
+              </a:defRPr>
+            </a:pPr>
+            <a:r>
+              <a:t>0        invalid packets - both boards agree on the 26-byte layout</a:t>
+            </a:r>
+          </a:p>
+          <a:p>
+            <a:pPr>
+              <a:lnSpc>
+                <a:spcPct val="118000"/>
+              </a:lnSpc>
+              <a:spcAft>
+                <a:spcPts val="1100"/>
+              </a:spcAft>
+              <a:defRPr sz="2000" b="1">
+                <a:solidFill>
+                  <a:srgbClr val="1A1A1A"/>
+                </a:solidFill>
+                <a:latin typeface="Calibri"/>
+              </a:defRPr>
+            </a:pPr>
+            <a:r>
+              <a:t>14 / 14        acceptance criteria evidenced</a:t>
+            </a:r>
+          </a:p>
+          <a:p>
+            <a:pPr>
+              <a:lnSpc>
+                <a:spcPct val="118000"/>
+              </a:lnSpc>
+              <a:spcAft>
+                <a:spcPts val="1100"/>
+              </a:spcAft>
+              <a:defRPr sz="1600" b="0">
                 <a:solidFill>
                   <a:srgbClr val="606060"/>
                 </a:solidFill>
@@ -4854,7 +4923,7 @@
               </a:defRPr>
             </a:pPr>
             <a:r>
-              <a:t>Blue: gateway local sensor.    Green: remote node, via ESP-NOW.    Stepped traces are DHT11 quantisation, not a frozen sensor.</a:t>
+              <a:t>Node offline detection latches at 20 s; last known value keeps publishing while node1_online carries the truth about freshness.</a:t>
             </a:r>
           </a:p>
         </p:txBody>
@@ -4911,7 +4980,7 @@
               </a:defRPr>
             </a:pPr>
             <a:r>
-              <a:t>BOTH DIRECTIONS</a:t>
+              <a:t>CLOUD</a:t>
             </a:r>
           </a:p>
           <a:p>
@@ -4927,7 +4996,7 @@
               </a:defRPr>
             </a:pPr>
             <a:r>
-              <a:t>Control and resilience</a:t>
+              <a:t>Edge aggregation, visualised</a:t>
             </a:r>
           </a:p>
         </p:txBody>
@@ -4974,30 +5043,43 @@
           <a:p>
             <a:pPr algn="ctr"/>
           </a:p>
-          <a:p>
-            <a:pPr algn="ctr"/>
-          </a:p>
-          <a:p>
-            <a:pPr algn="ctr"/>
-          </a:p>
-          <a:p>
-            <a:pPr algn="ctr"/>
-          </a:p>
-          <a:p>
-            <a:pPr algn="ctr"/>
-          </a:p>
-        </p:txBody>
-      </p:sp>
-      <p:sp>
-        <p:nvSpPr>
-          <p:cNvPr id="4" name="TextBox 3"/>
+        </p:txBody>
+      </p:sp>
+      <p:pic>
+        <p:nvPicPr>
+          <p:cNvPr id="4" name="Picture 3" descr="dashboard_01_temperature_both_boards.jpg"/>
+          <p:cNvPicPr>
+            <a:picLocks noChangeAspect="1"/>
+          </p:cNvPicPr>
+          <p:nvPr/>
+        </p:nvPicPr>
+        <p:blipFill>
+          <a:blip r:embed="rId3"/>
+          <a:srcRect b="7500"/>
+          <a:stretch>
+            <a:fillRect/>
+          </a:stretch>
+        </p:blipFill>
+        <p:spPr>
+          <a:xfrm>
+            <a:off x="1662989" y="1755648"/>
+            <a:ext cx="8862972" cy="4782312"/>
+          </a:xfrm>
+          <a:prstGeom prst="rect">
+            <a:avLst/>
+          </a:prstGeom>
+        </p:spPr>
+      </p:pic>
+      <p:sp>
+        <p:nvSpPr>
+          <p:cNvPr id="5" name="TextBox 4"/>
           <p:cNvSpPr txBox="1"/>
           <p:nvPr/>
         </p:nvSpPr>
         <p:spPr>
           <a:xfrm>
-            <a:off x="640080" y="1828800"/>
-            <a:ext cx="10911535" cy="4480560"/>
+            <a:off x="640080" y="6035040"/>
+            <a:ext cx="10911535" cy="640080"/>
           </a:xfrm>
           <a:prstGeom prst="rect">
             <a:avLst/>
@@ -5010,75 +5092,14 @@
           </a:bodyPr>
           <a:lstStyle/>
           <a:p>
-            <a:pPr>
-              <a:spcAft>
-                <a:spcPts val="2200"/>
-              </a:spcAft>
-              <a:defRPr sz="2200" b="1">
-                <a:solidFill>
-                  <a:srgbClr val="0B6B62"/>
-                </a:solidFill>
-                <a:latin typeface="Calibri"/>
-              </a:defRPr>
-            </a:pPr>
-            <a:r>
-              <a:t>Telemetry alone makes a device observable. It does not make it manageable.</a:t>
-            </a:r>
-          </a:p>
-          <a:p>
-            <a:pPr>
-              <a:spcAft>
-                <a:spcPts val="1800"/>
-              </a:spcAft>
-              <a:defRPr sz="1800" b="0">
-                <a:solidFill>
-                  <a:srgbClr val="1A1A1A"/>
-                </a:solidFill>
-                <a:latin typeface="Calibri"/>
-              </a:defRPr>
-            </a:pPr>
-            <a:r>
-              <a:t>The gateway subscribes to v1/devices/me/rpc/request/+ and replies on the matching response topic. Three methods: getStatus, setPublishInterval, resetCounters.</a:t>
-            </a:r>
-          </a:p>
-          <a:p>
-            <a:pPr>
-              <a:spcAft>
-                <a:spcPts val="1000"/>
-              </a:spcAft>
-              <a:defRPr sz="1900" b="1">
-                <a:solidFill>
-                  <a:srgbClr val="1A1A1A"/>
-                </a:solidFill>
-                <a:latin typeface="Calibri"/>
-              </a:defRPr>
-            </a:pPr>
-            <a:r>
-              <a:t>Verified end to end - a dashboard button produced the request in the gateway log, the applied change, and the new interval back in the next telemetry message. The round trip, not just the request.</a:t>
-            </a:r>
-          </a:p>
-          <a:p>
-            <a:pPr>
-              <a:spcAft>
-                <a:spcPts val="1800"/>
-              </a:spcAft>
-              <a:defRPr sz="1700" b="0">
-                <a:solidFill>
-                  <a:srgbClr val="1A1A1A"/>
-                </a:solidFill>
-                <a:latin typeface="Calibri"/>
-              </a:defRPr>
-            </a:pPr>
-            <a:r>
-              <a:t>setPublishInterval range-checks and rejects rather than clamping. Silently applying a value the operator did not ask for would leave them believing something untrue about the device.</a:t>
-            </a:r>
-          </a:p>
-          <a:p>
-            <a:pPr>
-              <a:spcAft>
-                <a:spcPts val="0"/>
-              </a:spcAft>
-              <a:defRPr sz="1700" b="0">
+            <a:pPr algn="ctr">
+              <a:lnSpc>
+                <a:spcPct val="118000"/>
+              </a:lnSpc>
+              <a:spcAft>
+                <a:spcPts val="1100"/>
+              </a:spcAft>
+              <a:defRPr sz="1400" b="0">
                 <a:solidFill>
                   <a:srgbClr val="606060"/>
                 </a:solidFill>
@@ -5086,7 +5107,7 @@
               </a:defRPr>
             </a:pPr>
             <a:r>
-              <a:t>Unsent payloads go to a twelve-slot ring buffer and flush oldest-first on reconnect. Measured: 4 buffered, 4 flushed, 0 dropped.</a:t>
+              <a:t>Blue: gateway local sensor.    Green: remote node, via ESP-NOW.    Stepped traces are DHT11 quantisation, not a frozen sensor.</a:t>
             </a:r>
           </a:p>
         </p:txBody>
@@ -5143,7 +5164,7 @@
               </a:defRPr>
             </a:pPr>
             <a:r>
-              <a:t>SWITCH TO HARDWARE</a:t>
+              <a:t>BOTH DIRECTIONS</a:t>
             </a:r>
           </a:p>
           <a:p>
@@ -5159,7 +5180,7 @@
               </a:defRPr>
             </a:pPr>
             <a:r>
-              <a:t>Live demonstration</a:t>
+              <a:t>Control and resilience</a:t>
             </a:r>
           </a:p>
         </p:txBody>
@@ -5206,6 +5227,18 @@
           <a:p>
             <a:pPr algn="ctr"/>
           </a:p>
+          <a:p>
+            <a:pPr algn="ctr"/>
+          </a:p>
+          <a:p>
+            <a:pPr algn="ctr"/>
+          </a:p>
+          <a:p>
+            <a:pPr algn="ctr"/>
+          </a:p>
+          <a:p>
+            <a:pPr algn="ctr"/>
+          </a:p>
         </p:txBody>
       </p:sp>
       <p:sp>
@@ -5217,7 +5250,7 @@
         <p:spPr>
           <a:xfrm>
             <a:off x="640080" y="1828800"/>
-            <a:ext cx="10911535" cy="4480560"/>
+            <a:ext cx="9509760" cy="4480560"/>
           </a:xfrm>
           <a:prstGeom prst="rect">
             <a:avLst/>
@@ -5231,10 +5264,32 @@
           <a:lstStyle/>
           <a:p>
             <a:pPr>
-              <a:spcAft>
-                <a:spcPts val="1600"/>
-              </a:spcAft>
-              <a:defRPr sz="1900" b="0">
+              <a:lnSpc>
+                <a:spcPct val="118000"/>
+              </a:lnSpc>
+              <a:spcAft>
+                <a:spcPts val="1100"/>
+              </a:spcAft>
+              <a:defRPr sz="2200" b="1">
+                <a:solidFill>
+                  <a:srgbClr val="0B6B62"/>
+                </a:solidFill>
+                <a:latin typeface="Calibri"/>
+              </a:defRPr>
+            </a:pPr>
+            <a:r>
+              <a:t>Telemetry alone makes a device observable. It does not make it manageable.</a:t>
+            </a:r>
+          </a:p>
+          <a:p>
+            <a:pPr>
+              <a:lnSpc>
+                <a:spcPct val="118000"/>
+              </a:lnSpc>
+              <a:spcAft>
+                <a:spcPts val="1100"/>
+              </a:spcAft>
+              <a:defRPr sz="1800" b="0">
                 <a:solidFill>
                   <a:srgbClr val="1A1A1A"/>
                 </a:solidFill>
@@ -5242,15 +5297,18 @@
               </a:defRPr>
             </a:pPr>
             <a:r>
-              <a:t>1.   Board 1 serial:  no Wi-Fi association, and a real link-layer ack</a:t>
-            </a:r>
-          </a:p>
-          <a:p>
-            <a:pPr>
-              <a:spcAft>
-                <a:spcPts val="1600"/>
-              </a:spcAft>
-              <a:defRPr sz="1900" b="0">
+              <a:t>The gateway subscribes to v1/devices/me/rpc/request/+ and replies on the matching response topic. Three methods: getStatus, setPublishInterval, resetCounters.</a:t>
+            </a:r>
+          </a:p>
+          <a:p>
+            <a:pPr>
+              <a:lnSpc>
+                <a:spcPct val="118000"/>
+              </a:lnSpc>
+              <a:spcAft>
+                <a:spcPts val="1100"/>
+              </a:spcAft>
+              <a:defRPr sz="1900" b="1">
                 <a:solidFill>
                   <a:srgbClr val="1A1A1A"/>
                 </a:solidFill>
@@ -5258,15 +5316,18 @@
               </a:defRPr>
             </a:pPr>
             <a:r>
-              <a:t>2.   Board 2 serial:  the same packet arriving, validated, deduplicated</a:t>
-            </a:r>
-          </a:p>
-          <a:p>
-            <a:pPr>
-              <a:spcAft>
-                <a:spcPts val="1600"/>
-              </a:spcAft>
-              <a:defRPr sz="1900" b="0">
+              <a:t>Verified end to end - a dashboard button produced the request in the gateway log, the applied change, and the new interval back in the next telemetry message. The round trip, not just the request.</a:t>
+            </a:r>
+          </a:p>
+          <a:p>
+            <a:pPr>
+              <a:lnSpc>
+                <a:spcPct val="118000"/>
+              </a:lnSpc>
+              <a:spcAft>
+                <a:spcPts val="1100"/>
+              </a:spcAft>
+              <a:defRPr sz="1700" b="0">
                 <a:solidFill>
                   <a:srgbClr val="1A1A1A"/>
                 </a:solidFill>
@@ -5274,47 +5335,18 @@
               </a:defRPr>
             </a:pPr>
             <a:r>
-              <a:t>3.   ThingsBoard:  the same numbers, in the cloud</a:t>
-            </a:r>
-          </a:p>
-          <a:p>
-            <a:pPr>
-              <a:spcAft>
-                <a:spcPts val="1600"/>
-              </a:spcAft>
-              <a:defRPr sz="1900" b="1">
-                <a:solidFill>
-                  <a:srgbClr val="0B6B62"/>
-                </a:solidFill>
-                <a:latin typeface="Calibri"/>
-              </a:defRPr>
-            </a:pPr>
-            <a:r>
-              <a:t>4.   Warm the sensor by hand and watch the chart move</a:t>
-            </a:r>
-          </a:p>
-          <a:p>
-            <a:pPr>
-              <a:spcAft>
-                <a:spcPts val="2400"/>
-              </a:spcAft>
-              <a:defRPr sz="1900" b="0">
-                <a:solidFill>
-                  <a:srgbClr val="1A1A1A"/>
-                </a:solidFill>
-                <a:latin typeface="Calibri"/>
-              </a:defRPr>
-            </a:pPr>
-            <a:r>
-              <a:t>5.   Unplug Board 1:  node1_online goes false after 20 s</a:t>
-            </a:r>
-          </a:p>
-          <a:p>
-            <a:pPr>
-              <a:spcAft>
-                <a:spcPts val="0"/>
-              </a:spcAft>
-              <a:defRPr sz="1600" b="0">
+              <a:t>setPublishInterval range-checks and rejects rather than clamping. Silently applying a value the operator did not ask for would leave them believing something untrue about the device.</a:t>
+            </a:r>
+          </a:p>
+          <a:p>
+            <a:pPr>
+              <a:lnSpc>
+                <a:spcPct val="118000"/>
+              </a:lnSpc>
+              <a:spcAft>
+                <a:spcPts val="1100"/>
+              </a:spcAft>
+              <a:defRPr sz="1700" b="0">
                 <a:solidFill>
                   <a:srgbClr val="606060"/>
                 </a:solidFill>
@@ -5322,7 +5354,7 @@
               </a:defRPr>
             </a:pPr>
             <a:r>
-              <a:t>Roughly 21 C to 28 C in fifteen seconds - it proves the whole chain, sensor to cloud, in one gesture.</a:t>
+              <a:t>Unsent payloads go to a twelve-slot ring buffer and flush oldest-first on reconnect. Measured: 4 buffered, 4 flushed, 0 dropped.</a:t>
             </a:r>
           </a:p>
         </p:txBody>
@@ -5379,7 +5411,7 @@
               </a:defRPr>
             </a:pPr>
             <a:r>
-              <a:t>HARDWARE SUBSTITUTION</a:t>
+              <a:t>SWITCH TO HARDWARE</a:t>
             </a:r>
           </a:p>
           <a:p>
@@ -5395,7 +5427,7 @@
               </a:defRPr>
             </a:pPr>
             <a:r>
-              <a:t>DHT11 instead of BMP280</a:t>
+              <a:t>Live demonstration</a:t>
             </a:r>
           </a:p>
         </p:txBody>
@@ -5453,7 +5485,7 @@
         <p:spPr>
           <a:xfrm>
             <a:off x="640080" y="1828800"/>
-            <a:ext cx="10911535" cy="4480560"/>
+            <a:ext cx="9509760" cy="4480560"/>
           </a:xfrm>
           <a:prstGeom prst="rect">
             <a:avLst/>
@@ -5467,10 +5499,13 @@
           <a:lstStyle/>
           <a:p>
             <a:pPr>
-              <a:spcAft>
-                <a:spcPts val="2200"/>
-              </a:spcAft>
-              <a:defRPr sz="2000" b="0">
+              <a:lnSpc>
+                <a:spcPct val="118000"/>
+              </a:lnSpc>
+              <a:spcAft>
+                <a:spcPts val="1100"/>
+              </a:spcAft>
+              <a:defRPr sz="1900" b="0">
                 <a:solidFill>
                   <a:srgbClr val="1A1A1A"/>
                 </a:solidFill>
@@ -5478,31 +5513,18 @@
               </a:defRPr>
             </a:pPr>
             <a:r>
-              <a:t>The brief specified BMP280. The available hardware was DHT11.</a:t>
-            </a:r>
-          </a:p>
-          <a:p>
-            <a:pPr>
-              <a:spcAft>
-                <a:spcPts val="800"/>
-              </a:spcAft>
-              <a:defRPr sz="1800" b="1">
-                <a:solidFill>
-                  <a:srgbClr val="A83A1F"/>
-                </a:solidFill>
-                <a:latin typeface="Calibri"/>
-              </a:defRPr>
-            </a:pPr>
-            <a:r>
-              <a:t>Lost</a:t>
-            </a:r>
-          </a:p>
-          <a:p>
-            <a:pPr>
-              <a:spcAft>
-                <a:spcPts val="800"/>
-              </a:spcAft>
-              <a:defRPr sz="1700" b="0">
+              <a:t>1.   Board 1 serial:  no Wi-Fi association, and a real link-layer ack</a:t>
+            </a:r>
+          </a:p>
+          <a:p>
+            <a:pPr>
+              <a:lnSpc>
+                <a:spcPct val="118000"/>
+              </a:lnSpc>
+              <a:spcAft>
+                <a:spcPts val="1100"/>
+              </a:spcAft>
+              <a:defRPr sz="1900" b="0">
                 <a:solidFill>
                   <a:srgbClr val="1A1A1A"/>
                 </a:solidFill>
@@ -5510,15 +5532,18 @@
               </a:defRPr>
             </a:pPr>
             <a:r>
-              <a:t>-   No I2C experience - DHT11 is single-wire bit-banged</a:t>
-            </a:r>
-          </a:p>
-          <a:p>
-            <a:pPr>
-              <a:spcAft>
-                <a:spcPts val="1800"/>
-              </a:spcAft>
-              <a:defRPr sz="1700" b="0">
+              <a:t>2.   Board 2 serial:  the same packet arriving, validated, deduplicated</a:t>
+            </a:r>
+          </a:p>
+          <a:p>
+            <a:pPr>
+              <a:lnSpc>
+                <a:spcPct val="118000"/>
+              </a:lnSpc>
+              <a:spcAft>
+                <a:spcPts val="1100"/>
+              </a:spcAft>
+              <a:defRPr sz="1900" b="0">
                 <a:solidFill>
                   <a:srgbClr val="1A1A1A"/>
                 </a:solidFill>
@@ -5526,15 +5551,18 @@
               </a:defRPr>
             </a:pPr>
             <a:r>
-              <a:t>-   Lower resolution, hence the stepped chart traces</a:t>
-            </a:r>
-          </a:p>
-          <a:p>
-            <a:pPr>
-              <a:spcAft>
-                <a:spcPts val="800"/>
-              </a:spcAft>
-              <a:defRPr sz="1800" b="1">
+              <a:t>3.   ThingsBoard:  the same numbers, in the cloud</a:t>
+            </a:r>
+          </a:p>
+          <a:p>
+            <a:pPr>
+              <a:lnSpc>
+                <a:spcPct val="118000"/>
+              </a:lnSpc>
+              <a:spcAft>
+                <a:spcPts val="1100"/>
+              </a:spcAft>
+              <a:defRPr sz="1900" b="1">
                 <a:solidFill>
                   <a:srgbClr val="0B6B62"/>
                 </a:solidFill>
@@ -5542,15 +5570,18 @@
               </a:defRPr>
             </a:pPr>
             <a:r>
-              <a:t>Gained</a:t>
-            </a:r>
-          </a:p>
-          <a:p>
-            <a:pPr>
-              <a:spcAft>
-                <a:spcPts val="800"/>
-              </a:spcAft>
-              <a:defRPr sz="1700" b="0">
+              <a:t>4.   Warm the sensor by hand and watch the chart move</a:t>
+            </a:r>
+          </a:p>
+          <a:p>
+            <a:pPr>
+              <a:lnSpc>
+                <a:spcPct val="118000"/>
+              </a:lnSpc>
+              <a:spcAft>
+                <a:spcPts val="1100"/>
+              </a:spcAft>
+              <a:defRPr sz="1900" b="0">
                 <a:solidFill>
                   <a:srgbClr val="1A1A1A"/>
                 </a:solidFill>
@@ -5558,23 +5589,26 @@
               </a:defRPr>
             </a:pPr>
             <a:r>
-              <a:t>-   Humidity responds to a hand in seconds; indoor pressure would be flat for hours</a:t>
-            </a:r>
-          </a:p>
-          <a:p>
-            <a:pPr>
-              <a:spcAft>
-                <a:spcPts val="0"/>
-              </a:spcAft>
-              <a:defRPr sz="1700" b="0">
-                <a:solidFill>
-                  <a:srgbClr val="1A1A1A"/>
-                </a:solidFill>
-                <a:latin typeface="Calibri"/>
-              </a:defRPr>
-            </a:pPr>
-            <a:r>
-              <a:t>-   Everything above the sensing layer is unchanged - the packet carries two floats and does not care what they represent</a:t>
+              <a:t>5.   Unplug Board 1:  node1_online goes false after 20 s</a:t>
+            </a:r>
+          </a:p>
+          <a:p>
+            <a:pPr>
+              <a:lnSpc>
+                <a:spcPct val="118000"/>
+              </a:lnSpc>
+              <a:spcAft>
+                <a:spcPts val="1100"/>
+              </a:spcAft>
+              <a:defRPr sz="1600" b="0">
+                <a:solidFill>
+                  <a:srgbClr val="606060"/>
+                </a:solidFill>
+                <a:latin typeface="Calibri"/>
+              </a:defRPr>
+            </a:pPr>
+            <a:r>
+              <a:t>Roughly 21 C to 28 C in fifteen seconds - it proves the whole chain, sensor to cloud, in one gesture.</a:t>
             </a:r>
           </a:p>
         </p:txBody>
@@ -5631,7 +5665,7 @@
               </a:defRPr>
             </a:pPr>
             <a:r>
-              <a:t>HONESTLY</a:t>
+              <a:t>HARDWARE SUBSTITUTION</a:t>
             </a:r>
           </a:p>
           <a:p>
@@ -5647,7 +5681,7 @@
               </a:defRPr>
             </a:pPr>
             <a:r>
-              <a:t>Limitations</a:t>
+              <a:t>DHT11 instead of BMP280</a:t>
             </a:r>
           </a:p>
         </p:txBody>
@@ -5705,7 +5739,7 @@
         <p:spPr>
           <a:xfrm>
             <a:off x="640080" y="1828800"/>
-            <a:ext cx="10911535" cy="4480560"/>
+            <a:ext cx="9509760" cy="4480560"/>
           </a:xfrm>
           <a:prstGeom prst="rect">
             <a:avLst/>
@@ -5719,10 +5753,13 @@
           <a:lstStyle/>
           <a:p>
             <a:pPr>
-              <a:spcAft>
-                <a:spcPts val="1500"/>
-              </a:spcAft>
-              <a:defRPr sz="1800" b="0">
+              <a:lnSpc>
+                <a:spcPct val="118000"/>
+              </a:lnSpc>
+              <a:spcAft>
+                <a:spcPts val="1100"/>
+              </a:spcAft>
+              <a:defRPr sz="2000" b="0">
                 <a:solidFill>
                   <a:srgbClr val="1A1A1A"/>
                 </a:solidFill>
@@ -5730,15 +5767,37 @@
               </a:defRPr>
             </a:pPr>
             <a:r>
-              <a:t>-   One hop only - two radios cannot demonstrate multi-hop forwarding</a:t>
-            </a:r>
-          </a:p>
-          <a:p>
-            <a:pPr>
-              <a:spcAft>
-                <a:spcPts val="1500"/>
-              </a:spcAft>
-              <a:defRPr sz="1800" b="0">
+              <a:t>The brief specified BMP280. The available hardware was DHT11.</a:t>
+            </a:r>
+          </a:p>
+          <a:p>
+            <a:pPr>
+              <a:lnSpc>
+                <a:spcPct val="118000"/>
+              </a:lnSpc>
+              <a:spcAft>
+                <a:spcPts val="1100"/>
+              </a:spcAft>
+              <a:defRPr sz="1800" b="1">
+                <a:solidFill>
+                  <a:srgbClr val="A83A1F"/>
+                </a:solidFill>
+                <a:latin typeface="Calibri"/>
+              </a:defRPr>
+            </a:pPr>
+            <a:r>
+              <a:t>Lost</a:t>
+            </a:r>
+          </a:p>
+          <a:p>
+            <a:pPr>
+              <a:lnSpc>
+                <a:spcPct val="118000"/>
+              </a:lnSpc>
+              <a:spcAft>
+                <a:spcPts val="1100"/>
+              </a:spcAft>
+              <a:defRPr sz="1700" b="0">
                 <a:solidFill>
                   <a:srgbClr val="1A1A1A"/>
                 </a:solidFill>
@@ -5746,15 +5805,18 @@
               </a:defRPr>
             </a:pPr>
             <a:r>
-              <a:t>-   ttl and hop_count are designed for but unexercised</a:t>
-            </a:r>
-          </a:p>
-          <a:p>
-            <a:pPr>
-              <a:spcAft>
-                <a:spcPts val="1500"/>
-              </a:spcAft>
-              <a:defRPr sz="1800" b="0">
+              <a:t>-   No I2C experience - DHT11 is single-wire bit-banged</a:t>
+            </a:r>
+          </a:p>
+          <a:p>
+            <a:pPr>
+              <a:lnSpc>
+                <a:spcPct val="118000"/>
+              </a:lnSpc>
+              <a:spcAft>
+                <a:spcPts val="1100"/>
+              </a:spcAft>
+              <a:defRPr sz="1700" b="0">
                 <a:solidFill>
                   <a:srgbClr val="1A1A1A"/>
                 </a:solidFill>
@@ -5762,15 +5824,37 @@
               </a:defRPr>
             </a:pPr>
             <a:r>
-              <a:t>-   MQTT without TLS - the radio leg is encrypted, the cloud leg is not</a:t>
-            </a:r>
-          </a:p>
-          <a:p>
-            <a:pPr>
-              <a:spcAft>
-                <a:spcPts val="1500"/>
-              </a:spcAft>
-              <a:defRPr sz="1800" b="0">
+              <a:t>-   Lower resolution, hence the stepped chart traces</a:t>
+            </a:r>
+          </a:p>
+          <a:p>
+            <a:pPr>
+              <a:lnSpc>
+                <a:spcPct val="118000"/>
+              </a:lnSpc>
+              <a:spcAft>
+                <a:spcPts val="1100"/>
+              </a:spcAft>
+              <a:defRPr sz="1800" b="1">
+                <a:solidFill>
+                  <a:srgbClr val="0B6B62"/>
+                </a:solidFill>
+                <a:latin typeface="Calibri"/>
+              </a:defRPr>
+            </a:pPr>
+            <a:r>
+              <a:t>Gained</a:t>
+            </a:r>
+          </a:p>
+          <a:p>
+            <a:pPr>
+              <a:lnSpc>
+                <a:spcPct val="118000"/>
+              </a:lnSpc>
+              <a:spcAft>
+                <a:spcPts val="1100"/>
+              </a:spcAft>
+              <a:defRPr sz="1700" b="0">
                 <a:solidFill>
                   <a:srgbClr val="1A1A1A"/>
                 </a:solidFill>
@@ -5778,15 +5862,18 @@
               </a:defRPr>
             </a:pPr>
             <a:r>
-              <a:t>-   Credentials compiled into firmware, recoverable over USB</a:t>
-            </a:r>
-          </a:p>
-          <a:p>
-            <a:pPr>
-              <a:spcAft>
-                <a:spcPts val="1500"/>
-              </a:spcAft>
-              <a:defRPr sz="1800" b="0">
+              <a:t>-   Humidity responds to a hand in seconds; indoor pressure would be flat for hours</a:t>
+            </a:r>
+          </a:p>
+          <a:p>
+            <a:pPr>
+              <a:lnSpc>
+                <a:spcPct val="118000"/>
+              </a:lnSpc>
+              <a:spcAft>
+                <a:spcPts val="1100"/>
+              </a:spcAft>
+              <a:defRPr sz="1700" b="0">
                 <a:solidFill>
                   <a:srgbClr val="1A1A1A"/>
                 </a:solidFill>
@@ -5794,23 +5881,7 @@
               </a:defRPr>
             </a:pPr>
             <a:r>
-              <a:t>-   Manual channel configuration - a gateway roam silently breaks the link</a:t>
-            </a:r>
-          </a:p>
-          <a:p>
-            <a:pPr>
-              <a:spcAft>
-                <a:spcPts val="1500"/>
-              </a:spcAft>
-              <a:defRPr sz="1800" b="0">
-                <a:solidFill>
-                  <a:srgbClr val="1A1A1A"/>
-                </a:solidFill>
-                <a:latin typeface="Calibri"/>
-              </a:defRPr>
-            </a:pPr>
-            <a:r>
-              <a:t>-   Single remote node - dedup state is one slot, not an array</a:t>
+              <a:t>-   Everything above the sensing layer is unchanged - the packet carries two floats and does not care what they represent</a:t>
             </a:r>
           </a:p>
         </p:txBody>
@@ -5867,7 +5938,7 @@
               </a:defRPr>
             </a:pPr>
             <a:r>
-              <a:t>MEASURED, NOT ASSUMED</a:t>
+              <a:t>HONESTLY</a:t>
             </a:r>
           </a:p>
           <a:p>
@@ -5883,7 +5954,7 @@
               </a:defRPr>
             </a:pPr>
             <a:r>
-              <a:t>What we found</a:t>
+              <a:t>Limitations</a:t>
             </a:r>
           </a:p>
         </p:txBody>
@@ -5941,7 +6012,7 @@
         <p:spPr>
           <a:xfrm>
             <a:off x="640080" y="1828800"/>
-            <a:ext cx="10911535" cy="4480560"/>
+            <a:ext cx="9509760" cy="4480560"/>
           </a:xfrm>
           <a:prstGeom prst="rect">
             <a:avLst/>
@@ -5955,26 +6026,13 @@
           <a:lstStyle/>
           <a:p>
             <a:pPr>
-              <a:spcAft>
-                <a:spcPts val="800"/>
-              </a:spcAft>
-              <a:defRPr sz="1900" b="1">
-                <a:solidFill>
-                  <a:srgbClr val="0B6B62"/>
-                </a:solidFill>
-                <a:latin typeface="Calibri"/>
-              </a:defRPr>
-            </a:pPr>
-            <a:r>
-              <a:t>Port 1883 is open outbound on eduroam</a:t>
-            </a:r>
-          </a:p>
-          <a:p>
-            <a:pPr>
-              <a:spcAft>
-                <a:spcPts val="1800"/>
-              </a:spcAft>
-              <a:defRPr sz="1600" b="0">
+              <a:lnSpc>
+                <a:spcPct val="118000"/>
+              </a:lnSpc>
+              <a:spcAft>
+                <a:spcPts val="1100"/>
+              </a:spcAft>
+              <a:defRPr sz="1800" b="0">
                 <a:solidFill>
                   <a:srgbClr val="1A1A1A"/>
                 </a:solidFill>
@@ -5982,31 +6040,18 @@
               </a:defRPr>
             </a:pPr>
             <a:r>
-              <a:t>Proved by the MQTT return code: state=5 is a reply from the broker, so the packets crossed the firewall. state=-2 would have meant no TCP connection at all.</a:t>
-            </a:r>
-          </a:p>
-          <a:p>
-            <a:pPr>
-              <a:spcAft>
-                <a:spcPts val="800"/>
-              </a:spcAft>
-              <a:defRPr sz="1900" b="1">
-                <a:solidFill>
-                  <a:srgbClr val="0B6B62"/>
-                </a:solidFill>
-                <a:latin typeface="Calibri"/>
-              </a:defRPr>
-            </a:pPr>
-            <a:r>
-              <a:t>WPA2-Enterprise costs ~97 KB of flash</a:t>
-            </a:r>
-          </a:p>
-          <a:p>
-            <a:pPr>
-              <a:spcAft>
-                <a:spcPts val="1800"/>
-              </a:spcAft>
-              <a:defRPr sz="1600" b="0">
+              <a:t>-   One hop only - two radios cannot demonstrate multi-hop forwarding</a:t>
+            </a:r>
+          </a:p>
+          <a:p>
+            <a:pPr>
+              <a:lnSpc>
+                <a:spcPct val="118000"/>
+              </a:lnSpc>
+              <a:spcAft>
+                <a:spcPts val="1100"/>
+              </a:spcAft>
+              <a:defRPr sz="1800" b="0">
                 <a:solidFill>
                   <a:srgbClr val="1A1A1A"/>
                 </a:solidFill>
@@ -6014,31 +6059,18 @@
               </a:defRPr>
             </a:pPr>
             <a:r>
-              <a:t>915,267 bytes with PSK against 1,012,651 with PEAP. Enterprise auth is not free.</a:t>
-            </a:r>
-          </a:p>
-          <a:p>
-            <a:pPr>
-              <a:spcAft>
-                <a:spcPts val="800"/>
-              </a:spcAft>
-              <a:defRPr sz="1900" b="1">
-                <a:solidFill>
-                  <a:srgbClr val="0B6B62"/>
-                </a:solidFill>
-                <a:latin typeface="Calibri"/>
-              </a:defRPr>
-            </a:pPr>
-            <a:r>
-              <a:t>eduroam routes by RADIUS realm, not email domain</a:t>
-            </a:r>
-          </a:p>
-          <a:p>
-            <a:pPr>
-              <a:spcAft>
-                <a:spcPts val="0"/>
-              </a:spcAft>
-              <a:defRPr sz="1600" b="0">
+              <a:t>-   ttl and hop_count are designed for but unexercised</a:t>
+            </a:r>
+          </a:p>
+          <a:p>
+            <a:pPr>
+              <a:lnSpc>
+                <a:spcPct val="118000"/>
+              </a:lnSpc>
+              <a:spcAft>
+                <a:spcPts val="1100"/>
+              </a:spcAft>
+              <a:defRPr sz="1800" b="0">
                 <a:solidFill>
                   <a:srgbClr val="1A1A1A"/>
                 </a:solidFill>
@@ -6046,7 +6078,64 @@
               </a:defRPr>
             </a:pPr>
             <a:r>
-              <a:t>user@student.&lt;institution&gt; failed; user@&lt;institution&gt; worked. The failure is silent - the same status code as a wrong password.</a:t>
+              <a:t>-   MQTT without TLS - the radio leg is encrypted, the cloud leg is not</a:t>
+            </a:r>
+          </a:p>
+          <a:p>
+            <a:pPr>
+              <a:lnSpc>
+                <a:spcPct val="118000"/>
+              </a:lnSpc>
+              <a:spcAft>
+                <a:spcPts val="1100"/>
+              </a:spcAft>
+              <a:defRPr sz="1800" b="0">
+                <a:solidFill>
+                  <a:srgbClr val="1A1A1A"/>
+                </a:solidFill>
+                <a:latin typeface="Calibri"/>
+              </a:defRPr>
+            </a:pPr>
+            <a:r>
+              <a:t>-   Credentials compiled into firmware, recoverable over USB</a:t>
+            </a:r>
+          </a:p>
+          <a:p>
+            <a:pPr>
+              <a:lnSpc>
+                <a:spcPct val="118000"/>
+              </a:lnSpc>
+              <a:spcAft>
+                <a:spcPts val="1100"/>
+              </a:spcAft>
+              <a:defRPr sz="1800" b="0">
+                <a:solidFill>
+                  <a:srgbClr val="1A1A1A"/>
+                </a:solidFill>
+                <a:latin typeface="Calibri"/>
+              </a:defRPr>
+            </a:pPr>
+            <a:r>
+              <a:t>-   Manual channel configuration - a gateway roam silently breaks the link</a:t>
+            </a:r>
+          </a:p>
+          <a:p>
+            <a:pPr>
+              <a:lnSpc>
+                <a:spcPct val="118000"/>
+              </a:lnSpc>
+              <a:spcAft>
+                <a:spcPts val="1100"/>
+              </a:spcAft>
+              <a:defRPr sz="1800" b="0">
+                <a:solidFill>
+                  <a:srgbClr val="1A1A1A"/>
+                </a:solidFill>
+                <a:latin typeface="Calibri"/>
+              </a:defRPr>
+            </a:pPr>
+            <a:r>
+              <a:t>-   Single remote node - dedup state is one slot, not an array</a:t>
             </a:r>
           </a:p>
         </p:txBody>
@@ -6103,7 +6192,7 @@
               </a:defRPr>
             </a:pPr>
             <a:r>
-              <a:t>WHAT WOULD COME NEXT</a:t>
+              <a:t>MEASURED, NOT ASSUMED</a:t>
             </a:r>
           </a:p>
           <a:p>
@@ -6119,7 +6208,7 @@
               </a:defRPr>
             </a:pPr>
             <a:r>
-              <a:t>Further work</a:t>
+              <a:t>What we found</a:t>
             </a:r>
           </a:p>
         </p:txBody>
@@ -6177,7 +6266,7 @@
         <p:spPr>
           <a:xfrm>
             <a:off x="640080" y="1828800"/>
-            <a:ext cx="10911535" cy="4480560"/>
+            <a:ext cx="9509760" cy="4480560"/>
           </a:xfrm>
           <a:prstGeom prst="rect">
             <a:avLst/>
@@ -6191,10 +6280,32 @@
           <a:lstStyle/>
           <a:p>
             <a:pPr>
-              <a:spcAft>
-                <a:spcPts val="1700"/>
-              </a:spcAft>
-              <a:defRPr sz="1900" b="0">
+              <a:lnSpc>
+                <a:spcPct val="118000"/>
+              </a:lnSpc>
+              <a:spcAft>
+                <a:spcPts val="1100"/>
+              </a:spcAft>
+              <a:defRPr sz="1900" b="1">
+                <a:solidFill>
+                  <a:srgbClr val="0B6B62"/>
+                </a:solidFill>
+                <a:latin typeface="Calibri"/>
+              </a:defRPr>
+            </a:pPr>
+            <a:r>
+              <a:t>Port 1883 is open outbound on eduroam</a:t>
+            </a:r>
+          </a:p>
+          <a:p>
+            <a:pPr>
+              <a:lnSpc>
+                <a:spcPct val="118000"/>
+              </a:lnSpc>
+              <a:spcAft>
+                <a:spcPts val="1100"/>
+              </a:spcAft>
+              <a:defRPr sz="1600" b="0">
                 <a:solidFill>
                   <a:srgbClr val="1A1A1A"/>
                 </a:solidFill>
@@ -6202,15 +6313,37 @@
               </a:defRPr>
             </a:pPr>
             <a:r>
-              <a:t>1.   A third node - actually exercise ttl and hop_count</a:t>
-            </a:r>
-          </a:p>
-          <a:p>
-            <a:pPr>
-              <a:spcAft>
-                <a:spcPts val="1700"/>
-              </a:spcAft>
-              <a:defRPr sz="1900" b="0">
+              <a:t>Proved by the MQTT return code: state=5 is a reply from the broker, so the packets crossed the firewall. state=-2 would have meant no TCP connection at all.</a:t>
+            </a:r>
+          </a:p>
+          <a:p>
+            <a:pPr>
+              <a:lnSpc>
+                <a:spcPct val="118000"/>
+              </a:lnSpc>
+              <a:spcAft>
+                <a:spcPts val="1100"/>
+              </a:spcAft>
+              <a:defRPr sz="1900" b="1">
+                <a:solidFill>
+                  <a:srgbClr val="0B6B62"/>
+                </a:solidFill>
+                <a:latin typeface="Calibri"/>
+              </a:defRPr>
+            </a:pPr>
+            <a:r>
+              <a:t>WPA2-Enterprise costs ~97 KB of flash</a:t>
+            </a:r>
+          </a:p>
+          <a:p>
+            <a:pPr>
+              <a:lnSpc>
+                <a:spcPct val="118000"/>
+              </a:lnSpc>
+              <a:spcAft>
+                <a:spcPts val="1100"/>
+              </a:spcAft>
+              <a:defRPr sz="1600" b="0">
                 <a:solidFill>
                   <a:srgbClr val="1A1A1A"/>
                 </a:solidFill>
@@ -6218,15 +6351,37 @@
               </a:defRPr>
             </a:pPr>
             <a:r>
-              <a:t>2.   MQTT over TLS on port 8883</a:t>
-            </a:r>
-          </a:p>
-          <a:p>
-            <a:pPr>
-              <a:spcAft>
-                <a:spcPts val="1700"/>
-              </a:spcAft>
-              <a:defRPr sz="1900" b="0">
+              <a:t>915,267 bytes with PSK against 1,012,651 with PEAP. Enterprise auth is not free.</a:t>
+            </a:r>
+          </a:p>
+          <a:p>
+            <a:pPr>
+              <a:lnSpc>
+                <a:spcPct val="118000"/>
+              </a:lnSpc>
+              <a:spcAft>
+                <a:spcPts val="1100"/>
+              </a:spcAft>
+              <a:defRPr sz="1900" b="1">
+                <a:solidFill>
+                  <a:srgbClr val="0B6B62"/>
+                </a:solidFill>
+                <a:latin typeface="Calibri"/>
+              </a:defRPr>
+            </a:pPr>
+            <a:r>
+              <a:t>eduroam routes by RADIUS realm, not email domain</a:t>
+            </a:r>
+          </a:p>
+          <a:p>
+            <a:pPr>
+              <a:lnSpc>
+                <a:spcPct val="118000"/>
+              </a:lnSpc>
+              <a:spcAft>
+                <a:spcPts val="1100"/>
+              </a:spcAft>
+              <a:defRPr sz="1600" b="0">
                 <a:solidFill>
                   <a:srgbClr val="1A1A1A"/>
                 </a:solidFill>
@@ -6234,39 +6389,7 @@
               </a:defRPr>
             </a:pPr>
             <a:r>
-              <a:t>3.   Credentials provisioned into NVS at first boot, not compiled in</a:t>
-            </a:r>
-          </a:p>
-          <a:p>
-            <a:pPr>
-              <a:spcAft>
-                <a:spcPts val="1700"/>
-              </a:spcAft>
-              <a:defRPr sz="1900" b="0">
-                <a:solidFill>
-                  <a:srgbClr val="1A1A1A"/>
-                </a:solidFill>
-                <a:latin typeface="Calibri"/>
-              </a:defRPr>
-            </a:pPr>
-            <a:r>
-              <a:t>4.   Automatic channel recovery instead of a manual re-upload</a:t>
-            </a:r>
-          </a:p>
-          <a:p>
-            <a:pPr>
-              <a:spcAft>
-                <a:spcPts val="1700"/>
-              </a:spcAft>
-              <a:defRPr sz="1900" b="0">
-                <a:solidFill>
-                  <a:srgbClr val="1A1A1A"/>
-                </a:solidFill>
-                <a:latin typeface="Calibri"/>
-              </a:defRPr>
-            </a:pPr>
-            <a:r>
-              <a:t>5.   Persist the buffer to NVS so it survives a reboot, not just a reconnect</a:t>
+              <a:t>user@student.&lt;institution&gt; failed; user@&lt;institution&gt; worked. The failure is silent - the same status code as a wrong password.</a:t>
             </a:r>
           </a:p>
         </p:txBody>
@@ -6297,95 +6420,6 @@
         </p:nvSpPr>
         <p:spPr>
           <a:xfrm>
-            <a:off x="914400" y="2377440"/>
-            <a:ext cx="10362895" cy="2377440"/>
-          </a:xfrm>
-          <a:prstGeom prst="rect">
-            <a:avLst/>
-          </a:prstGeom>
-          <a:noFill/>
-        </p:spPr>
-        <p:txBody>
-          <a:bodyPr wrap="square">
-            <a:spAutoFit/>
-          </a:bodyPr>
-          <a:lstStyle/>
-          <a:p>
-            <a:pPr algn="ctr">
-              <a:spcAft>
-                <a:spcPts val="2600"/>
-              </a:spcAft>
-              <a:defRPr sz="4400" b="1">
-                <a:solidFill>
-                  <a:srgbClr val="1A1A1A"/>
-                </a:solidFill>
-                <a:latin typeface="Calibri"/>
-              </a:defRPr>
-            </a:pPr>
-            <a:r>
-              <a:t>Questions</a:t>
-            </a:r>
-          </a:p>
-          <a:p>
-            <a:pPr algn="ctr">
-              <a:spcAft>
-                <a:spcPts val="1800"/>
-              </a:spcAft>
-              <a:defRPr sz="1900" b="0">
-                <a:solidFill>
-                  <a:srgbClr val="606060"/>
-                </a:solidFill>
-                <a:latin typeface="Calibri"/>
-              </a:defRPr>
-            </a:pPr>
-            <a:r>
-              <a:t>Two ESP32 boards.  No wire between them.  Two sensors, one cloud stream.</a:t>
-            </a:r>
-          </a:p>
-          <a:p>
-            <a:pPr algn="ctr">
-              <a:spcAft>
-                <a:spcPts val="0"/>
-              </a:spcAft>
-              <a:defRPr sz="1400" b="0">
-                <a:solidFill>
-                  <a:srgbClr val="606060"/>
-                </a:solidFill>
-                <a:latin typeface="Calibri"/>
-              </a:defRPr>
-            </a:pPr>
-            <a:r>
-              <a:t>Code, evidence and full report:  github.com/bhanuGupta1/esp32-espnow-thingsboard-gateway</a:t>
-            </a:r>
-          </a:p>
-        </p:txBody>
-      </p:sp>
-    </p:spTree>
-  </p:cSld>
-  <p:clrMapOvr>
-    <a:masterClrMapping/>
-  </p:clrMapOvr>
-</p:sld>
-</file>
-
-<file path=ppt/slides/slide18.xml><?xml version="1.0" encoding="utf-8"?>
-<p:sld xmlns:a="http://schemas.openxmlformats.org/drawingml/2006/main" xmlns:p="http://schemas.openxmlformats.org/presentationml/2006/main" xmlns:r="http://schemas.openxmlformats.org/officeDocument/2006/relationships">
-  <p:cSld>
-    <p:spTree>
-      <p:nvGrpSpPr>
-        <p:cNvPr id="1" name=""/>
-        <p:cNvGrpSpPr/>
-        <p:nvPr/>
-      </p:nvGrpSpPr>
-      <p:grpSpPr/>
-      <p:sp>
-        <p:nvSpPr>
-          <p:cNvPr id="2" name="TextBox 1"/>
-          <p:cNvSpPr txBox="1"/>
-          <p:nvPr/>
-        </p:nvSpPr>
-        <p:spPr>
-          <a:xfrm>
             <a:off x="640080" y="411480"/>
             <a:ext cx="10911535" cy="1005840"/>
           </a:xfrm>
@@ -6412,7 +6446,7 @@
               </a:defRPr>
             </a:pPr>
             <a:r>
-              <a:t>WIRING</a:t>
+              <a:t>WHAT WOULD COME NEXT</a:t>
             </a:r>
           </a:p>
           <a:p>
@@ -6428,7 +6462,7 @@
               </a:defRPr>
             </a:pPr>
             <a:r>
-              <a:t>Circuit</a:t>
+              <a:t>Further work</a:t>
             </a:r>
           </a:p>
         </p:txBody>
@@ -6477,30 +6511,222 @@
           </a:p>
         </p:txBody>
       </p:sp>
-      <p:pic>
-        <p:nvPicPr>
-          <p:cNvPr id="4" name="Picture 3" descr="fig_circuit_diagram.png"/>
-          <p:cNvPicPr>
-            <a:picLocks noChangeAspect="1"/>
-          </p:cNvPicPr>
+      <p:sp>
+        <p:nvSpPr>
+          <p:cNvPr id="4" name="TextBox 3"/>
+          <p:cNvSpPr txBox="1"/>
           <p:nvPr/>
-        </p:nvPicPr>
-        <p:blipFill>
-          <a:blip r:embed="rId2"/>
-          <a:stretch>
-            <a:fillRect/>
-          </a:stretch>
-        </p:blipFill>
+        </p:nvSpPr>
         <p:spPr>
           <a:xfrm>
-            <a:off x="640080" y="1783080"/>
-            <a:ext cx="10908792" cy="6732847"/>
+            <a:off x="640080" y="1828800"/>
+            <a:ext cx="9509760" cy="4480560"/>
           </a:xfrm>
           <a:prstGeom prst="rect">
             <a:avLst/>
           </a:prstGeom>
+          <a:noFill/>
         </p:spPr>
-      </p:pic>
+        <p:txBody>
+          <a:bodyPr wrap="square">
+            <a:spAutoFit/>
+          </a:bodyPr>
+          <a:lstStyle/>
+          <a:p>
+            <a:pPr>
+              <a:lnSpc>
+                <a:spcPct val="118000"/>
+              </a:lnSpc>
+              <a:spcAft>
+                <a:spcPts val="1100"/>
+              </a:spcAft>
+              <a:defRPr sz="1900" b="0">
+                <a:solidFill>
+                  <a:srgbClr val="1A1A1A"/>
+                </a:solidFill>
+                <a:latin typeface="Calibri"/>
+              </a:defRPr>
+            </a:pPr>
+            <a:r>
+              <a:t>1.   A third node - actually exercise ttl and hop_count</a:t>
+            </a:r>
+          </a:p>
+          <a:p>
+            <a:pPr>
+              <a:lnSpc>
+                <a:spcPct val="118000"/>
+              </a:lnSpc>
+              <a:spcAft>
+                <a:spcPts val="1100"/>
+              </a:spcAft>
+              <a:defRPr sz="1900" b="0">
+                <a:solidFill>
+                  <a:srgbClr val="1A1A1A"/>
+                </a:solidFill>
+                <a:latin typeface="Calibri"/>
+              </a:defRPr>
+            </a:pPr>
+            <a:r>
+              <a:t>2.   MQTT over TLS on port 8883</a:t>
+            </a:r>
+          </a:p>
+          <a:p>
+            <a:pPr>
+              <a:lnSpc>
+                <a:spcPct val="118000"/>
+              </a:lnSpc>
+              <a:spcAft>
+                <a:spcPts val="1100"/>
+              </a:spcAft>
+              <a:defRPr sz="1900" b="0">
+                <a:solidFill>
+                  <a:srgbClr val="1A1A1A"/>
+                </a:solidFill>
+                <a:latin typeface="Calibri"/>
+              </a:defRPr>
+            </a:pPr>
+            <a:r>
+              <a:t>3.   Credentials provisioned into NVS at first boot, not compiled in</a:t>
+            </a:r>
+          </a:p>
+          <a:p>
+            <a:pPr>
+              <a:lnSpc>
+                <a:spcPct val="118000"/>
+              </a:lnSpc>
+              <a:spcAft>
+                <a:spcPts val="1100"/>
+              </a:spcAft>
+              <a:defRPr sz="1900" b="0">
+                <a:solidFill>
+                  <a:srgbClr val="1A1A1A"/>
+                </a:solidFill>
+                <a:latin typeface="Calibri"/>
+              </a:defRPr>
+            </a:pPr>
+            <a:r>
+              <a:t>4.   Automatic channel recovery instead of a manual re-upload</a:t>
+            </a:r>
+          </a:p>
+          <a:p>
+            <a:pPr>
+              <a:lnSpc>
+                <a:spcPct val="118000"/>
+              </a:lnSpc>
+              <a:spcAft>
+                <a:spcPts val="1100"/>
+              </a:spcAft>
+              <a:defRPr sz="1900" b="0">
+                <a:solidFill>
+                  <a:srgbClr val="1A1A1A"/>
+                </a:solidFill>
+                <a:latin typeface="Calibri"/>
+              </a:defRPr>
+            </a:pPr>
+            <a:r>
+              <a:t>5.   Persist the buffer to NVS so it survives a reboot, not just a reconnect</a:t>
+            </a:r>
+          </a:p>
+        </p:txBody>
+      </p:sp>
+    </p:spTree>
+  </p:cSld>
+  <p:clrMapOvr>
+    <a:masterClrMapping/>
+  </p:clrMapOvr>
+</p:sld>
+</file>
+
+<file path=ppt/slides/slide18.xml><?xml version="1.0" encoding="utf-8"?>
+<p:sld xmlns:a="http://schemas.openxmlformats.org/drawingml/2006/main" xmlns:p="http://schemas.openxmlformats.org/presentationml/2006/main" xmlns:r="http://schemas.openxmlformats.org/officeDocument/2006/relationships">
+  <p:cSld>
+    <p:spTree>
+      <p:nvGrpSpPr>
+        <p:cNvPr id="1" name=""/>
+        <p:cNvGrpSpPr/>
+        <p:nvPr/>
+      </p:nvGrpSpPr>
+      <p:grpSpPr/>
+      <p:sp>
+        <p:nvSpPr>
+          <p:cNvPr id="2" name="TextBox 1"/>
+          <p:cNvSpPr txBox="1"/>
+          <p:nvPr/>
+        </p:nvSpPr>
+        <p:spPr>
+          <a:xfrm>
+            <a:off x="914400" y="2377440"/>
+            <a:ext cx="9509760" cy="2377440"/>
+          </a:xfrm>
+          <a:prstGeom prst="rect">
+            <a:avLst/>
+          </a:prstGeom>
+          <a:noFill/>
+        </p:spPr>
+        <p:txBody>
+          <a:bodyPr wrap="square">
+            <a:spAutoFit/>
+          </a:bodyPr>
+          <a:lstStyle/>
+          <a:p>
+            <a:pPr algn="ctr">
+              <a:lnSpc>
+                <a:spcPct val="118000"/>
+              </a:lnSpc>
+              <a:spcAft>
+                <a:spcPts val="1100"/>
+              </a:spcAft>
+              <a:defRPr sz="4400" b="1">
+                <a:solidFill>
+                  <a:srgbClr val="1A1A1A"/>
+                </a:solidFill>
+                <a:latin typeface="Calibri"/>
+              </a:defRPr>
+            </a:pPr>
+            <a:r>
+              <a:t>Questions</a:t>
+            </a:r>
+          </a:p>
+          <a:p>
+            <a:pPr algn="ctr">
+              <a:lnSpc>
+                <a:spcPct val="118000"/>
+              </a:lnSpc>
+              <a:spcAft>
+                <a:spcPts val="1100"/>
+              </a:spcAft>
+              <a:defRPr sz="1900" b="0">
+                <a:solidFill>
+                  <a:srgbClr val="606060"/>
+                </a:solidFill>
+                <a:latin typeface="Calibri"/>
+              </a:defRPr>
+            </a:pPr>
+            <a:r>
+              <a:t>Two ESP32 boards.  No wire between them.  Two sensors, one cloud stream.</a:t>
+            </a:r>
+          </a:p>
+          <a:p>
+            <a:pPr algn="ctr">
+              <a:lnSpc>
+                <a:spcPct val="118000"/>
+              </a:lnSpc>
+              <a:spcAft>
+                <a:spcPts val="1100"/>
+              </a:spcAft>
+              <a:defRPr sz="1400" b="0">
+                <a:solidFill>
+                  <a:srgbClr val="606060"/>
+                </a:solidFill>
+                <a:latin typeface="Calibri"/>
+              </a:defRPr>
+            </a:pPr>
+            <a:r>
+              <a:t>Code, evidence and full report:  github.com/bhanuGupta1/esp32-espnow-thingsboard-gateway</a:t>
+            </a:r>
+          </a:p>
+        </p:txBody>
+      </p:sp>
     </p:spTree>
   </p:cSld>
   <p:clrMapOvr>
@@ -6627,7 +6853,7 @@
         <p:spPr>
           <a:xfrm>
             <a:off x="640080" y="1828800"/>
-            <a:ext cx="10911535" cy="4480560"/>
+            <a:ext cx="9509760" cy="4480560"/>
           </a:xfrm>
           <a:prstGeom prst="rect">
             <a:avLst/>
@@ -6641,8 +6867,11 @@
           <a:lstStyle/>
           <a:p>
             <a:pPr>
-              <a:spcAft>
-                <a:spcPts val="2600"/>
+              <a:lnSpc>
+                <a:spcPct val="118000"/>
+              </a:lnSpc>
+              <a:spcAft>
+                <a:spcPts val="1100"/>
               </a:spcAft>
               <a:defRPr sz="2200" b="0">
                 <a:solidFill>
@@ -6657,8 +6886,11 @@
           </a:p>
           <a:p>
             <a:pPr>
-              <a:spcAft>
-                <a:spcPts val="1400"/>
+              <a:lnSpc>
+                <a:spcPct val="118000"/>
+              </a:lnSpc>
+              <a:spcAft>
+                <a:spcPts val="1100"/>
               </a:spcAft>
               <a:defRPr sz="1900" b="0">
                 <a:solidFill>
@@ -6673,8 +6905,11 @@
           </a:p>
           <a:p>
             <a:pPr>
-              <a:spcAft>
-                <a:spcPts val="1400"/>
+              <a:lnSpc>
+                <a:spcPct val="118000"/>
+              </a:lnSpc>
+              <a:spcAft>
+                <a:spcPts val="1100"/>
               </a:spcAft>
               <a:defRPr sz="1900" b="0">
                 <a:solidFill>
@@ -6689,8 +6924,11 @@
           </a:p>
           <a:p>
             <a:pPr>
-              <a:spcAft>
-                <a:spcPts val="1400"/>
+              <a:lnSpc>
+                <a:spcPct val="118000"/>
+              </a:lnSpc>
+              <a:spcAft>
+                <a:spcPts val="1100"/>
               </a:spcAft>
               <a:defRPr sz="1900" b="0">
                 <a:solidFill>
@@ -6705,8 +6943,11 @@
           </a:p>
           <a:p>
             <a:pPr>
-              <a:spcAft>
-                <a:spcPts val="0"/>
+              <a:lnSpc>
+                <a:spcPct val="118000"/>
+              </a:lnSpc>
+              <a:spcAft>
+                <a:spcPts val="1100"/>
               </a:spcAft>
               <a:defRPr sz="2200" b="1">
                 <a:solidFill>
@@ -6847,7 +7088,7 @@
         <p:spPr>
           <a:xfrm>
             <a:off x="640080" y="1783080"/>
-            <a:ext cx="6400800" cy="4526280"/>
+            <a:ext cx="6931448" cy="4526280"/>
           </a:xfrm>
           <a:prstGeom prst="rect">
             <a:avLst/>
@@ -6861,8 +7102,11 @@
           <a:lstStyle/>
           <a:p>
             <a:pPr>
-              <a:spcAft>
-                <a:spcPts val="600"/>
+              <a:lnSpc>
+                <a:spcPct val="118000"/>
+              </a:lnSpc>
+              <a:spcAft>
+                <a:spcPts val="1100"/>
               </a:spcAft>
               <a:defRPr sz="2000" b="1">
                 <a:solidFill>
@@ -6877,8 +7121,11 @@
           </a:p>
           <a:p>
             <a:pPr>
-              <a:spcAft>
-                <a:spcPts val="1800"/>
+              <a:lnSpc>
+                <a:spcPct val="118000"/>
+              </a:lnSpc>
+              <a:spcAft>
+                <a:spcPts val="1100"/>
               </a:spcAft>
               <a:defRPr sz="1700" b="0">
                 <a:solidFill>
@@ -6893,8 +7140,11 @@
           </a:p>
           <a:p>
             <a:pPr>
-              <a:spcAft>
-                <a:spcPts val="600"/>
+              <a:lnSpc>
+                <a:spcPct val="118000"/>
+              </a:lnSpc>
+              <a:spcAft>
+                <a:spcPts val="1100"/>
               </a:spcAft>
               <a:defRPr sz="2000" b="1">
                 <a:solidFill>
@@ -6909,8 +7159,11 @@
           </a:p>
           <a:p>
             <a:pPr>
-              <a:spcAft>
-                <a:spcPts val="2000"/>
+              <a:lnSpc>
+                <a:spcPct val="118000"/>
+              </a:lnSpc>
+              <a:spcAft>
+                <a:spcPts val="1100"/>
               </a:spcAft>
               <a:defRPr sz="1700" b="0">
                 <a:solidFill>
@@ -6925,8 +7178,11 @@
           </a:p>
           <a:p>
             <a:pPr>
-              <a:spcAft>
-                <a:spcPts val="1600"/>
+              <a:lnSpc>
+                <a:spcPct val="118000"/>
+              </a:lnSpc>
+              <a:spcAft>
+                <a:spcPts val="1100"/>
               </a:spcAft>
               <a:defRPr sz="1800" b="1">
                 <a:solidFill>
@@ -6941,8 +7197,11 @@
           </a:p>
           <a:p>
             <a:pPr>
-              <a:spcAft>
-                <a:spcPts val="0"/>
+              <a:lnSpc>
+                <a:spcPct val="118000"/>
+              </a:lnSpc>
+              <a:spcAft>
+                <a:spcPts val="1100"/>
               </a:spcAft>
               <a:defRPr sz="1500" b="0">
                 <a:solidFill>
@@ -6973,8 +7232,8 @@
         </p:blipFill>
         <p:spPr>
           <a:xfrm>
-            <a:off x="7766313" y="1783080"/>
-            <a:ext cx="3785302" cy="5047488"/>
+            <a:off x="7983008" y="1783080"/>
+            <a:ext cx="3565864" cy="4754880"/>
           </a:xfrm>
           <a:prstGeom prst="rect">
             <a:avLst/>
@@ -7114,8 +7373,8 @@
         </p:blipFill>
         <p:spPr>
           <a:xfrm>
-            <a:off x="640080" y="1783080"/>
-            <a:ext cx="10908792" cy="6426809"/>
+            <a:off x="2059036" y="1783080"/>
+            <a:ext cx="8070878" cy="4754880"/>
           </a:xfrm>
           <a:prstGeom prst="rect">
             <a:avLst/>
@@ -7174,7 +7433,7 @@
               </a:defRPr>
             </a:pPr>
             <a:r>
-              <a:t>THE GOVERNING CONSTRAINT</a:t>
+              <a:t>WIRING</a:t>
             </a:r>
           </a:p>
           <a:p>
@@ -7190,7 +7449,7 @@
               </a:defRPr>
             </a:pPr>
             <a:r>
-              <a:t>One radio, one channel</a:t>
+              <a:t>Circuit</a:t>
             </a:r>
           </a:p>
         </p:txBody>
@@ -7239,125 +7498,30 @@
           </a:p>
         </p:txBody>
       </p:sp>
-      <p:sp>
-        <p:nvSpPr>
-          <p:cNvPr id="4" name="TextBox 3"/>
-          <p:cNvSpPr txBox="1"/>
+      <p:pic>
+        <p:nvPicPr>
+          <p:cNvPr id="4" name="Picture 3" descr="fig_circuit_diagram.png"/>
+          <p:cNvPicPr>
+            <a:picLocks noChangeAspect="1"/>
+          </p:cNvPicPr>
           <p:nvPr/>
-        </p:nvSpPr>
+        </p:nvPicPr>
+        <p:blipFill>
+          <a:blip r:embed="rId2"/>
+          <a:stretch>
+            <a:fillRect/>
+          </a:stretch>
+        </p:blipFill>
         <p:spPr>
           <a:xfrm>
-            <a:off x="640080" y="1828800"/>
-            <a:ext cx="10911535" cy="4480560"/>
+            <a:off x="2242465" y="1783080"/>
+            <a:ext cx="7704021" cy="4754880"/>
           </a:xfrm>
           <a:prstGeom prst="rect">
             <a:avLst/>
           </a:prstGeom>
-          <a:noFill/>
         </p:spPr>
-        <p:txBody>
-          <a:bodyPr wrap="square">
-            <a:spAutoFit/>
-          </a:bodyPr>
-          <a:lstStyle/>
-          <a:p>
-            <a:pPr>
-              <a:spcAft>
-                <a:spcPts val="2000"/>
-              </a:spcAft>
-              <a:defRPr sz="2100" b="0">
-                <a:solidFill>
-                  <a:srgbClr val="1A1A1A"/>
-                </a:solidFill>
-                <a:latin typeface="Calibri"/>
-              </a:defRPr>
-            </a:pPr>
-            <a:r>
-              <a:t>An ESP32 has a single radio, so it is on exactly one channel at a time.</a:t>
-            </a:r>
-          </a:p>
-          <a:p>
-            <a:pPr>
-              <a:spcAft>
-                <a:spcPts val="2000"/>
-              </a:spcAft>
-              <a:defRPr sz="1900" b="0">
-                <a:solidFill>
-                  <a:srgbClr val="1A1A1A"/>
-                </a:solidFill>
-                <a:latin typeface="Calibri"/>
-              </a:defRPr>
-            </a:pPr>
-            <a:r>
-              <a:t>The gateway must join Wi-Fi for the cloud - and the access point decides which channel that is.</a:t>
-            </a:r>
-          </a:p>
-          <a:p>
-            <a:pPr>
-              <a:spcAft>
-                <a:spcPts val="2400"/>
-              </a:spcAft>
-              <a:defRPr sz="2100" b="1">
-                <a:solidFill>
-                  <a:srgbClr val="0B6B62"/>
-                </a:solidFill>
-                <a:latin typeface="Calibri"/>
-              </a:defRPr>
-            </a:pPr>
-            <a:r>
-              <a:t>So the channel is discovered at runtime, never chosen at design time.</a:t>
-            </a:r>
-          </a:p>
-          <a:p>
-            <a:pPr>
-              <a:spcAft>
-                <a:spcPts val="1200"/>
-              </a:spcAft>
-              <a:defRPr sz="1700" b="0">
-                <a:solidFill>
-                  <a:srgbClr val="1A1A1A"/>
-                </a:solidFill>
-                <a:latin typeface="Calibri"/>
-              </a:defRPr>
-            </a:pPr>
-            <a:r>
-              <a:t>-   The node is pinned to that channel by hand, and reads it back to confirm</a:t>
-            </a:r>
-          </a:p>
-          <a:p>
-            <a:pPr>
-              <a:spcAft>
-                <a:spcPts val="1200"/>
-              </a:spcAft>
-              <a:defRPr sz="1700" b="0">
-                <a:solidFill>
-                  <a:srgbClr val="1A1A1A"/>
-                </a:solidFill>
-                <a:latin typeface="Calibri"/>
-              </a:defRPr>
-            </a:pPr>
-            <a:r>
-              <a:t>-   The node never associates - association would let the two boards drift apart</a:t>
-            </a:r>
-          </a:p>
-          <a:p>
-            <a:pPr>
-              <a:spcAft>
-                <a:spcPts val="1200"/>
-              </a:spcAft>
-              <a:defRPr sz="1700" b="0">
-                <a:solidFill>
-                  <a:srgbClr val="1A1A1A"/>
-                </a:solidFill>
-                <a:latin typeface="Calibri"/>
-              </a:defRPr>
-            </a:pPr>
-            <a:r>
-              <a:t>-   Gateway must be flashed and running before the node can even be configured</a:t>
-            </a:r>
-          </a:p>
-        </p:txBody>
-      </p:sp>
+      </p:pic>
     </p:spTree>
   </p:cSld>
   <p:clrMapOvr>
@@ -7410,7 +7574,7 @@
               </a:defRPr>
             </a:pPr>
             <a:r>
-              <a:t>26 BYTES</a:t>
+              <a:t>THE GOVERNING CONSTRAINT</a:t>
             </a:r>
           </a:p>
           <a:p>
@@ -7426,7 +7590,7 @@
               </a:defRPr>
             </a:pPr>
             <a:r>
-              <a:t>Packet design</a:t>
+              <a:t>One radio, one channel</a:t>
             </a:r>
           </a:p>
         </p:txBody>
@@ -7484,7 +7648,7 @@
         <p:spPr>
           <a:xfrm>
             <a:off x="640080" y="1828800"/>
-            <a:ext cx="5852160" cy="4480560"/>
+            <a:ext cx="9509760" cy="4480560"/>
           </a:xfrm>
           <a:prstGeom prst="rect">
             <a:avLst/>
@@ -7498,201 +7662,116 @@
           <a:lstStyle/>
           <a:p>
             <a:pPr>
-              <a:spcAft>
-                <a:spcPts val="900"/>
-              </a:spcAft>
-              <a:defRPr sz="1400" b="0">
+              <a:lnSpc>
+                <a:spcPct val="118000"/>
+              </a:lnSpc>
+              <a:spcAft>
+                <a:spcPts val="1100"/>
+              </a:spcAft>
+              <a:defRPr sz="2100" b="0">
                 <a:solidFill>
                   <a:srgbClr val="1A1A1A"/>
                 </a:solidFill>
-                <a:latin typeface="Consolas"/>
-              </a:defRPr>
-            </a:pPr>
-            <a:r>
-              <a:t>version, msg_type      protocol evolution</a:t>
-            </a:r>
-          </a:p>
-          <a:p>
-            <a:pPr>
-              <a:spcAft>
-                <a:spcPts val="900"/>
-              </a:spcAft>
-              <a:defRPr sz="1400" b="0">
+                <a:latin typeface="Calibri"/>
+              </a:defRPr>
+            </a:pPr>
+            <a:r>
+              <a:t>An ESP32 has a single radio, so it is on exactly one channel at a time.</a:t>
+            </a:r>
+          </a:p>
+          <a:p>
+            <a:pPr>
+              <a:lnSpc>
+                <a:spcPct val="118000"/>
+              </a:lnSpc>
+              <a:spcAft>
+                <a:spcPts val="1100"/>
+              </a:spcAft>
+              <a:defRPr sz="1900" b="0">
                 <a:solidFill>
                   <a:srgbClr val="1A1A1A"/>
                 </a:solidFill>
-                <a:latin typeface="Consolas"/>
-              </a:defRPr>
-            </a:pPr>
-            <a:r>
-              <a:t>src_id, dst_id         addressing, not broadcast</a:t>
-            </a:r>
-          </a:p>
-          <a:p>
-            <a:pPr>
-              <a:spcAft>
-                <a:spcPts val="900"/>
-              </a:spcAft>
-              <a:defRPr sz="1400" b="0">
+                <a:latin typeface="Calibri"/>
+              </a:defRPr>
+            </a:pPr>
+            <a:r>
+              <a:t>The gateway must join Wi-Fi for the cloud - and the access point decides which channel that is.</a:t>
+            </a:r>
+          </a:p>
+          <a:p>
+            <a:pPr>
+              <a:lnSpc>
+                <a:spcPct val="118000"/>
+              </a:lnSpc>
+              <a:spcAft>
+                <a:spcPts val="1100"/>
+              </a:spcAft>
+              <a:defRPr sz="2100" b="1">
+                <a:solidFill>
+                  <a:srgbClr val="0B6B62"/>
+                </a:solidFill>
+                <a:latin typeface="Calibri"/>
+              </a:defRPr>
+            </a:pPr>
+            <a:r>
+              <a:t>So the channel is discovered at runtime, never chosen at design time.</a:t>
+            </a:r>
+          </a:p>
+          <a:p>
+            <a:pPr>
+              <a:lnSpc>
+                <a:spcPct val="118000"/>
+              </a:lnSpc>
+              <a:spcAft>
+                <a:spcPts val="1100"/>
+              </a:spcAft>
+              <a:defRPr sz="1700" b="0">
                 <a:solidFill>
                   <a:srgbClr val="1A1A1A"/>
                 </a:solidFill>
-                <a:latin typeface="Consolas"/>
-              </a:defRPr>
-            </a:pPr>
-            <a:r>
-              <a:t>boot_id                random per power-up</a:t>
-            </a:r>
-          </a:p>
-          <a:p>
-            <a:pPr>
-              <a:spcAft>
-                <a:spcPts val="900"/>
-              </a:spcAft>
-              <a:defRPr sz="1400" b="0">
+                <a:latin typeface="Calibri"/>
+              </a:defRPr>
+            </a:pPr>
+            <a:r>
+              <a:t>-   The node is pinned to that channel by hand, and reads it back to confirm</a:t>
+            </a:r>
+          </a:p>
+          <a:p>
+            <a:pPr>
+              <a:lnSpc>
+                <a:spcPct val="118000"/>
+              </a:lnSpc>
+              <a:spcAft>
+                <a:spcPts val="1100"/>
+              </a:spcAft>
+              <a:defRPr sz="1700" b="0">
                 <a:solidFill>
                   <a:srgbClr val="1A1A1A"/>
                 </a:solidFill>
-                <a:latin typeface="Consolas"/>
-              </a:defRPr>
-            </a:pPr>
-            <a:r>
-              <a:t>seq                    ordering within a session</a:t>
-            </a:r>
-          </a:p>
-          <a:p>
-            <a:pPr>
-              <a:spcAft>
-                <a:spcPts val="900"/>
-              </a:spcAft>
-              <a:defRPr sz="1400" b="0">
+                <a:latin typeface="Calibri"/>
+              </a:defRPr>
+            </a:pPr>
+            <a:r>
+              <a:t>-   The node never associates - association would let the two boards drift apart</a:t>
+            </a:r>
+          </a:p>
+          <a:p>
+            <a:pPr>
+              <a:lnSpc>
+                <a:spcPct val="118000"/>
+              </a:lnSpc>
+              <a:spcAft>
+                <a:spcPts val="1100"/>
+              </a:spcAft>
+              <a:defRPr sz="1700" b="0">
                 <a:solidFill>
                   <a:srgbClr val="1A1A1A"/>
                 </a:solidFill>
-                <a:latin typeface="Consolas"/>
-              </a:defRPr>
-            </a:pPr>
-            <a:r>
-              <a:t>ttl, hop_count         carried, never decremented</a:t>
-            </a:r>
-          </a:p>
-          <a:p>
-            <a:pPr>
-              <a:spcAft>
-                <a:spcPts val="900"/>
-              </a:spcAft>
-              <a:defRPr sz="1400" b="0">
-                <a:solidFill>
-                  <a:srgbClr val="1A1A1A"/>
-                </a:solidFill>
-                <a:latin typeface="Consolas"/>
-              </a:defRPr>
-            </a:pPr>
-            <a:r>
-              <a:t>temperature, humidity  the payload</a:t>
-            </a:r>
-          </a:p>
-          <a:p>
-            <a:pPr>
-              <a:spcAft>
-                <a:spcPts val="900"/>
-              </a:spcAft>
-              <a:defRPr sz="1400" b="0">
-                <a:solidFill>
-                  <a:srgbClr val="1A1A1A"/>
-                </a:solidFill>
-                <a:latin typeface="Consolas"/>
-              </a:defRPr>
-            </a:pPr>
-            <a:r>
-              <a:t>uptime_ms              sender liveness</a:t>
-            </a:r>
-          </a:p>
-        </p:txBody>
-      </p:sp>
-      <p:sp>
-        <p:nvSpPr>
-          <p:cNvPr id="5" name="TextBox 4"/>
-          <p:cNvSpPr txBox="1"/>
-          <p:nvPr/>
-        </p:nvSpPr>
-        <p:spPr>
-          <a:xfrm>
-            <a:off x="6766560" y="1828800"/>
-            <a:ext cx="4754880" cy="4480560"/>
-          </a:xfrm>
-          <a:prstGeom prst="rect">
-            <a:avLst/>
-          </a:prstGeom>
-          <a:noFill/>
-        </p:spPr>
-        <p:txBody>
-          <a:bodyPr wrap="square">
-            <a:spAutoFit/>
-          </a:bodyPr>
-          <a:lstStyle/>
-          <a:p>
-            <a:pPr>
-              <a:spcAft>
-                <a:spcPts val="1000"/>
-              </a:spcAft>
-              <a:defRPr sz="1900" b="1">
-                <a:solidFill>
-                  <a:srgbClr val="0B6B62"/>
-                </a:solidFill>
-                <a:latin typeface="Calibri"/>
-              </a:defRPr>
-            </a:pPr>
-            <a:r>
-              <a:t>Why no checksum?</a:t>
-            </a:r>
-          </a:p>
-          <a:p>
-            <a:pPr>
-              <a:spcAft>
-                <a:spcPts val="2000"/>
-              </a:spcAft>
-              <a:defRPr sz="1600" b="0">
-                <a:solidFill>
-                  <a:srgbClr val="1A1A1A"/>
-                </a:solidFill>
-                <a:latin typeface="Calibri"/>
-              </a:defRPr>
-            </a:pPr>
-            <a:r>
-              <a:t>802.11 already CRC-checks every delivered frame. A checksum would duplicate hardware work - and would not authenticate anything.</a:t>
-            </a:r>
-          </a:p>
-          <a:p>
-            <a:pPr>
-              <a:spcAft>
-                <a:spcPts val="800"/>
-              </a:spcAft>
-              <a:defRPr sz="1400" b="1">
-                <a:solidFill>
-                  <a:srgbClr val="1A1A1A"/>
-                </a:solidFill>
-                <a:latin typeface="Calibri"/>
-              </a:defRPr>
-            </a:pPr>
-            <a:r>
-              <a:t>static_assert(sizeof == 26)</a:t>
-            </a:r>
-          </a:p>
-          <a:p>
-            <a:pPr>
-              <a:spcAft>
-                <a:spcPts val="800"/>
-              </a:spcAft>
-              <a:defRPr sz="1500" b="0">
-                <a:solidFill>
-                  <a:srgbClr val="606060"/>
-                </a:solidFill>
-                <a:latin typeface="Calibri"/>
-              </a:defRPr>
-            </a:pPr>
-            <a:r>
-              <a:t>Pins the size in both sketches. It constrains layout but does not prove field agreement - fields could be reordered and still pass.</a:t>
+                <a:latin typeface="Calibri"/>
+              </a:defRPr>
+            </a:pPr>
+            <a:r>
+              <a:t>-   Gateway must be flashed and running before the node can even be configured</a:t>
             </a:r>
           </a:p>
         </p:txBody>
@@ -7749,7 +7828,7 @@
               </a:defRPr>
             </a:pPr>
             <a:r>
-              <a:t>SOFTWARE</a:t>
+              <a:t>26 BYTES</a:t>
             </a:r>
           </a:p>
           <a:p>
@@ -7765,7 +7844,7 @@
               </a:defRPr>
             </a:pPr>
             <a:r>
-              <a:t>Deduplication</a:t>
+              <a:t>Packet design</a:t>
             </a:r>
           </a:p>
         </p:txBody>
@@ -7823,7 +7902,7 @@
         <p:spPr>
           <a:xfrm>
             <a:off x="640080" y="1828800"/>
-            <a:ext cx="10911535" cy="4480560"/>
+            <a:ext cx="5852160" cy="4480560"/>
           </a:xfrm>
           <a:prstGeom prst="rect">
             <a:avLst/>
@@ -7837,10 +7916,169 @@
           <a:lstStyle/>
           <a:p>
             <a:pPr>
-              <a:spcAft>
-                <a:spcPts val="2200"/>
-              </a:spcAft>
-              <a:defRPr sz="2200" b="1">
+              <a:lnSpc>
+                <a:spcPct val="118000"/>
+              </a:lnSpc>
+              <a:spcAft>
+                <a:spcPts val="1100"/>
+              </a:spcAft>
+              <a:defRPr sz="1400" b="0">
+                <a:solidFill>
+                  <a:srgbClr val="1A1A1A"/>
+                </a:solidFill>
+                <a:latin typeface="Consolas"/>
+              </a:defRPr>
+            </a:pPr>
+            <a:r>
+              <a:t>version, msg_type      protocol evolution</a:t>
+            </a:r>
+          </a:p>
+          <a:p>
+            <a:pPr>
+              <a:lnSpc>
+                <a:spcPct val="118000"/>
+              </a:lnSpc>
+              <a:spcAft>
+                <a:spcPts val="1100"/>
+              </a:spcAft>
+              <a:defRPr sz="1400" b="0">
+                <a:solidFill>
+                  <a:srgbClr val="1A1A1A"/>
+                </a:solidFill>
+                <a:latin typeface="Consolas"/>
+              </a:defRPr>
+            </a:pPr>
+            <a:r>
+              <a:t>src_id, dst_id         addressing, not broadcast</a:t>
+            </a:r>
+          </a:p>
+          <a:p>
+            <a:pPr>
+              <a:lnSpc>
+                <a:spcPct val="118000"/>
+              </a:lnSpc>
+              <a:spcAft>
+                <a:spcPts val="1100"/>
+              </a:spcAft>
+              <a:defRPr sz="1400" b="0">
+                <a:solidFill>
+                  <a:srgbClr val="1A1A1A"/>
+                </a:solidFill>
+                <a:latin typeface="Consolas"/>
+              </a:defRPr>
+            </a:pPr>
+            <a:r>
+              <a:t>boot_id                random per power-up</a:t>
+            </a:r>
+          </a:p>
+          <a:p>
+            <a:pPr>
+              <a:lnSpc>
+                <a:spcPct val="118000"/>
+              </a:lnSpc>
+              <a:spcAft>
+                <a:spcPts val="1100"/>
+              </a:spcAft>
+              <a:defRPr sz="1400" b="0">
+                <a:solidFill>
+                  <a:srgbClr val="1A1A1A"/>
+                </a:solidFill>
+                <a:latin typeface="Consolas"/>
+              </a:defRPr>
+            </a:pPr>
+            <a:r>
+              <a:t>seq                    ordering within a session</a:t>
+            </a:r>
+          </a:p>
+          <a:p>
+            <a:pPr>
+              <a:lnSpc>
+                <a:spcPct val="118000"/>
+              </a:lnSpc>
+              <a:spcAft>
+                <a:spcPts val="1100"/>
+              </a:spcAft>
+              <a:defRPr sz="1400" b="0">
+                <a:solidFill>
+                  <a:srgbClr val="1A1A1A"/>
+                </a:solidFill>
+                <a:latin typeface="Consolas"/>
+              </a:defRPr>
+            </a:pPr>
+            <a:r>
+              <a:t>ttl, hop_count         carried, never decremented</a:t>
+            </a:r>
+          </a:p>
+          <a:p>
+            <a:pPr>
+              <a:lnSpc>
+                <a:spcPct val="118000"/>
+              </a:lnSpc>
+              <a:spcAft>
+                <a:spcPts val="1100"/>
+              </a:spcAft>
+              <a:defRPr sz="1400" b="0">
+                <a:solidFill>
+                  <a:srgbClr val="1A1A1A"/>
+                </a:solidFill>
+                <a:latin typeface="Consolas"/>
+              </a:defRPr>
+            </a:pPr>
+            <a:r>
+              <a:t>temperature, humidity  the payload</a:t>
+            </a:r>
+          </a:p>
+          <a:p>
+            <a:pPr>
+              <a:lnSpc>
+                <a:spcPct val="118000"/>
+              </a:lnSpc>
+              <a:spcAft>
+                <a:spcPts val="1100"/>
+              </a:spcAft>
+              <a:defRPr sz="1400" b="0">
+                <a:solidFill>
+                  <a:srgbClr val="1A1A1A"/>
+                </a:solidFill>
+                <a:latin typeface="Consolas"/>
+              </a:defRPr>
+            </a:pPr>
+            <a:r>
+              <a:t>uptime_ms              sender liveness</a:t>
+            </a:r>
+          </a:p>
+        </p:txBody>
+      </p:sp>
+      <p:sp>
+        <p:nvSpPr>
+          <p:cNvPr id="5" name="TextBox 4"/>
+          <p:cNvSpPr txBox="1"/>
+          <p:nvPr/>
+        </p:nvSpPr>
+        <p:spPr>
+          <a:xfrm>
+            <a:off x="6766560" y="1828800"/>
+            <a:ext cx="4754880" cy="4480560"/>
+          </a:xfrm>
+          <a:prstGeom prst="rect">
+            <a:avLst/>
+          </a:prstGeom>
+          <a:noFill/>
+        </p:spPr>
+        <p:txBody>
+          <a:bodyPr wrap="square">
+            <a:spAutoFit/>
+          </a:bodyPr>
+          <a:lstStyle/>
+          <a:p>
+            <a:pPr>
+              <a:lnSpc>
+                <a:spcPct val="118000"/>
+              </a:lnSpc>
+              <a:spcAft>
+                <a:spcPts val="1100"/>
+              </a:spcAft>
+              <a:defRPr sz="1900" b="1">
                 <a:solidFill>
                   <a:srgbClr val="0B6B62"/>
                 </a:solidFill>
@@ -7848,15 +8086,18 @@
               </a:defRPr>
             </a:pPr>
             <a:r>
-              <a:t>Key:   (src_id, boot_id, seq)</a:t>
-            </a:r>
-          </a:p>
-          <a:p>
-            <a:pPr>
-              <a:spcAft>
-                <a:spcPts val="1800"/>
-              </a:spcAft>
-              <a:defRPr sz="1800" b="0">
+              <a:t>Why no checksum?</a:t>
+            </a:r>
+          </a:p>
+          <a:p>
+            <a:pPr>
+              <a:lnSpc>
+                <a:spcPct val="118000"/>
+              </a:lnSpc>
+              <a:spcAft>
+                <a:spcPts val="1100"/>
+              </a:spcAft>
+              <a:defRPr sz="1600" b="0">
                 <a:solidFill>
                   <a:srgbClr val="1A1A1A"/>
                 </a:solidFill>
@@ -7864,15 +8105,18 @@
               </a:defRPr>
             </a:pPr>
             <a:r>
-              <a:t>Strict last-sequence-wins. Anything not newer than the highest already accepted in this session is a duplicate.</a:t>
-            </a:r>
-          </a:p>
-          <a:p>
-            <a:pPr>
-              <a:spcAft>
-                <a:spcPts val="1000"/>
-              </a:spcAft>
-              <a:defRPr sz="1900" b="1">
+              <a:t>802.11 already CRC-checks every delivered frame. A checksum would duplicate hardware work - and would not authenticate anything.</a:t>
+            </a:r>
+          </a:p>
+          <a:p>
+            <a:pPr>
+              <a:lnSpc>
+                <a:spcPct val="118000"/>
+              </a:lnSpc>
+              <a:spcAft>
+                <a:spcPts val="1100"/>
+              </a:spcAft>
+              <a:defRPr sz="1400" b="1">
                 <a:solidFill>
                   <a:srgbClr val="1A1A1A"/>
                 </a:solidFill>
@@ -7880,31 +8124,18 @@
               </a:defRPr>
             </a:pPr>
             <a:r>
-              <a:t>boot_id is randomised every power-up.</a:t>
-            </a:r>
-          </a:p>
-          <a:p>
-            <a:pPr>
-              <a:spcAft>
-                <a:spcPts val="1800"/>
-              </a:spcAft>
-              <a:defRPr sz="1700" b="0">
-                <a:solidFill>
-                  <a:srgbClr val="1A1A1A"/>
-                </a:solidFill>
-                <a:latin typeface="Calibri"/>
-              </a:defRPr>
-            </a:pPr>
-            <a:r>
-              <a:t>Without it, a node restart looks identical to a replay: every packet arrives with a sequence below the stored baseline and is rejected forever. The node never comes back.</a:t>
-            </a:r>
-          </a:p>
-          <a:p>
-            <a:pPr>
-              <a:spcAft>
-                <a:spcPts val="0"/>
-              </a:spcAft>
-              <a:defRPr sz="1700" b="0">
+              <a:t>static_assert(sizeof == 26)</a:t>
+            </a:r>
+          </a:p>
+          <a:p>
+            <a:pPr>
+              <a:lnSpc>
+                <a:spcPct val="118000"/>
+              </a:lnSpc>
+              <a:spcAft>
+                <a:spcPts val="1100"/>
+              </a:spcAft>
+              <a:defRPr sz="1500" b="0">
                 <a:solidFill>
                   <a:srgbClr val="606060"/>
                 </a:solidFill>
@@ -7912,7 +8143,7 @@
               </a:defRPr>
             </a:pPr>
             <a:r>
-              <a:t>A forward jump is a gap, not a duplicate - those packets were lost, not repeated. A receiver demanding contiguous sequences would deadlock on the first loss.</a:t>
+              <a:t>Pins the size in both sketches. It constrains layout but does not prove field agreement - fields could be reordered and still pass.</a:t>
             </a:r>
           </a:p>
         </p:txBody>
@@ -7969,7 +8200,7 @@
               </a:defRPr>
             </a:pPr>
             <a:r>
-              <a:t>THREAT MODEL</a:t>
+              <a:t>SOFTWARE</a:t>
             </a:r>
           </a:p>
           <a:p>
@@ -7985,7 +8216,7 @@
               </a:defRPr>
             </a:pPr>
             <a:r>
-              <a:t>Security</a:t>
+              <a:t>Deduplication</a:t>
             </a:r>
           </a:p>
         </p:txBody>
@@ -8042,8 +8273,8 @@
         </p:nvSpPr>
         <p:spPr>
           <a:xfrm>
-            <a:off x="640080" y="1783080"/>
-            <a:ext cx="5760720" cy="4526280"/>
+            <a:off x="640080" y="1828800"/>
+            <a:ext cx="9509760" cy="4480560"/>
           </a:xfrm>
           <a:prstGeom prst="rect">
             <a:avLst/>
@@ -8057,42 +8288,70 @@
           <a:lstStyle/>
           <a:p>
             <a:pPr>
-              <a:spcAft>
-                <a:spcPts val="1000"/>
+              <a:lnSpc>
+                <a:spcPct val="118000"/>
+              </a:lnSpc>
+              <a:spcAft>
+                <a:spcPts val="1100"/>
+              </a:spcAft>
+              <a:defRPr sz="2200" b="1">
+                <a:solidFill>
+                  <a:srgbClr val="0B6B62"/>
+                </a:solidFill>
+                <a:latin typeface="Calibri"/>
+              </a:defRPr>
+            </a:pPr>
+            <a:r>
+              <a:t>Key:   (src_id, boot_id, seq)</a:t>
+            </a:r>
+          </a:p>
+          <a:p>
+            <a:pPr>
+              <a:lnSpc>
+                <a:spcPct val="118000"/>
+              </a:lnSpc>
+              <a:spcAft>
+                <a:spcPts val="1100"/>
+              </a:spcAft>
+              <a:defRPr sz="1800" b="0">
+                <a:solidFill>
+                  <a:srgbClr val="1A1A1A"/>
+                </a:solidFill>
+                <a:latin typeface="Calibri"/>
+              </a:defRPr>
+            </a:pPr>
+            <a:r>
+              <a:t>Strict last-sequence-wins. Anything not newer than the highest already accepted in this session is a duplicate.</a:t>
+            </a:r>
+          </a:p>
+          <a:p>
+            <a:pPr>
+              <a:lnSpc>
+                <a:spcPct val="118000"/>
+              </a:lnSpc>
+              <a:spcAft>
+                <a:spcPts val="1100"/>
               </a:spcAft>
               <a:defRPr sz="1900" b="1">
                 <a:solidFill>
-                  <a:srgbClr val="0B6B62"/>
-                </a:solidFill>
-                <a:latin typeface="Calibri"/>
-              </a:defRPr>
-            </a:pPr>
-            <a:r>
-              <a:t>Defended</a:t>
-            </a:r>
-          </a:p>
-          <a:p>
-            <a:pPr>
-              <a:spcAft>
-                <a:spcPts val="900"/>
-              </a:spcAft>
-              <a:defRPr sz="1600" b="0">
-                <a:solidFill>
                   <a:srgbClr val="1A1A1A"/>
                 </a:solidFill>
                 <a:latin typeface="Calibri"/>
               </a:defRPr>
             </a:pPr>
             <a:r>
-              <a:t>+   Length, version, type, addressing, range validation</a:t>
-            </a:r>
-          </a:p>
-          <a:p>
-            <a:pPr>
-              <a:spcAft>
-                <a:spcPts val="900"/>
-              </a:spcAft>
-              <a:defRPr sz="1600" b="0">
+              <a:t>boot_id is randomised every power-up.</a:t>
+            </a:r>
+          </a:p>
+          <a:p>
+            <a:pPr>
+              <a:lnSpc>
+                <a:spcPct val="118000"/>
+              </a:lnSpc>
+              <a:spcAft>
+                <a:spcPts val="1100"/>
+              </a:spcAft>
+              <a:defRPr sz="1700" b="0">
                 <a:solidFill>
                   <a:srgbClr val="1A1A1A"/>
                 </a:solidFill>
@@ -8100,197 +8359,26 @@
               </a:defRPr>
             </a:pPr>
             <a:r>
-              <a:t>+   Replay rejection via sequence numbers</a:t>
-            </a:r>
-          </a:p>
-          <a:p>
-            <a:pPr>
-              <a:spcAft>
-                <a:spcPts val="900"/>
-              </a:spcAft>
-              <a:defRPr sz="1600" b="0">
-                <a:solidFill>
-                  <a:srgbClr val="1A1A1A"/>
-                </a:solidFill>
-                <a:latin typeface="Calibri"/>
-              </a:defRPr>
-            </a:pPr>
-            <a:r>
-              <a:t>+   ESP-NOW encryption + sender auth - PMK + per-peer LMK</a:t>
-            </a:r>
-          </a:p>
-          <a:p>
-            <a:pPr>
-              <a:spcAft>
-                <a:spcPts val="900"/>
-              </a:spcAft>
-              <a:defRPr sz="1600" b="0">
-                <a:solidFill>
-                  <a:srgbClr val="1A1A1A"/>
-                </a:solidFill>
-                <a:latin typeface="Calibri"/>
-              </a:defRPr>
-            </a:pPr>
-            <a:r>
-              <a:t>+   Sender MAC filtering (defence in depth)</a:t>
-            </a:r>
-          </a:p>
-          <a:p>
-            <a:pPr>
-              <a:spcAft>
-                <a:spcPts val="900"/>
-              </a:spcAft>
-              <a:defRPr sz="1600" b="0">
-                <a:solidFill>
-                  <a:srgbClr val="1A1A1A"/>
-                </a:solidFill>
-                <a:latin typeface="Calibri"/>
-              </a:defRPr>
-            </a:pPr>
-            <a:r>
-              <a:t>+   Credentials excluded from version control</a:t>
-            </a:r>
-          </a:p>
-        </p:txBody>
-      </p:sp>
-      <p:sp>
-        <p:nvSpPr>
-          <p:cNvPr id="5" name="TextBox 4"/>
-          <p:cNvSpPr txBox="1"/>
-          <p:nvPr/>
-        </p:nvSpPr>
-        <p:spPr>
-          <a:xfrm>
-            <a:off x="6492240" y="1783080"/>
-            <a:ext cx="5029200" cy="4526280"/>
-          </a:xfrm>
-          <a:prstGeom prst="rect">
-            <a:avLst/>
-          </a:prstGeom>
-          <a:noFill/>
-        </p:spPr>
-        <p:txBody>
-          <a:bodyPr wrap="square">
-            <a:spAutoFit/>
-          </a:bodyPr>
-          <a:lstStyle/>
-          <a:p>
-            <a:pPr>
-              <a:spcAft>
-                <a:spcPts val="1000"/>
-              </a:spcAft>
-              <a:defRPr sz="1900" b="1">
-                <a:solidFill>
-                  <a:srgbClr val="A83A1F"/>
-                </a:solidFill>
-                <a:latin typeface="Calibri"/>
-              </a:defRPr>
-            </a:pPr>
-            <a:r>
-              <a:t>Not defended</a:t>
-            </a:r>
-          </a:p>
-          <a:p>
-            <a:pPr>
-              <a:spcAft>
-                <a:spcPts val="900"/>
-              </a:spcAft>
-              <a:defRPr sz="1600" b="0">
-                <a:solidFill>
-                  <a:srgbClr val="1A1A1A"/>
-                </a:solidFill>
-                <a:latin typeface="Calibri"/>
-              </a:defRPr>
-            </a:pPr>
-            <a:r>
-              <a:t>-   MQTT without TLS - token in clear text</a:t>
-            </a:r>
-          </a:p>
-          <a:p>
-            <a:pPr>
-              <a:spcAft>
-                <a:spcPts val="900"/>
-              </a:spcAft>
-              <a:defRPr sz="1600" b="0">
-                <a:solidFill>
-                  <a:srgbClr val="1A1A1A"/>
-                </a:solidFill>
-                <a:latin typeface="Calibri"/>
-              </a:defRPr>
-            </a:pPr>
-            <a:r>
-              <a:t>-   RADIUS certificate not validated</a:t>
-            </a:r>
-          </a:p>
-          <a:p>
-            <a:pPr>
-              <a:spcAft>
-                <a:spcPts val="900"/>
-              </a:spcAft>
-              <a:defRPr sz="1600" b="0">
-                <a:solidFill>
-                  <a:srgbClr val="1A1A1A"/>
-                </a:solidFill>
-                <a:latin typeface="Calibri"/>
-              </a:defRPr>
-            </a:pPr>
-            <a:r>
-              <a:t>-   Credentials readable from flash over USB</a:t>
-            </a:r>
-          </a:p>
-        </p:txBody>
-      </p:sp>
-      <p:sp>
-        <p:nvSpPr>
-          <p:cNvPr id="6" name="TextBox 5"/>
-          <p:cNvSpPr txBox="1"/>
-          <p:nvPr/>
-        </p:nvSpPr>
-        <p:spPr>
-          <a:xfrm>
-            <a:off x="640080" y="4892040"/>
-            <a:ext cx="10911535" cy="1463040"/>
-          </a:xfrm>
-          <a:prstGeom prst="rect">
-            <a:avLst/>
-          </a:prstGeom>
-          <a:noFill/>
-        </p:spPr>
-        <p:txBody>
-          <a:bodyPr wrap="square">
-            <a:spAutoFit/>
-          </a:bodyPr>
-          <a:lstStyle/>
-          <a:p>
-            <a:pPr>
-              <a:spcAft>
-                <a:spcPts val="800"/>
-              </a:spcAft>
-              <a:defRPr sz="1700" b="1">
-                <a:solidFill>
-                  <a:srgbClr val="A83A1F"/>
-                </a:solidFill>
-                <a:latin typeface="Calibri"/>
-              </a:defRPr>
-            </a:pPr>
-            <a:r>
-              <a:t>The interesting finding</a:t>
-            </a:r>
-          </a:p>
-          <a:p>
-            <a:pPr>
-              <a:spcAft>
-                <a:spcPts val="0"/>
-              </a:spcAft>
-              <a:defRPr sz="1500" b="0">
-                <a:solidFill>
-                  <a:srgbClr val="1A1A1A"/>
-                </a:solidFill>
-                <a:latin typeface="Calibri"/>
-              </a:defRPr>
-            </a:pPr>
-            <a:r>
-              <a:t>src_id is a claim, not proof. A forged packet with a high sequence number under the live boot_id advances the dedup baseline - after which every genuine packet is rejected until the node reboots. Replay protection becomes the attack surface. Fixed by encrypting the link: a MAC filter was not enough, because the attacker controls the value being filtered on.</a:t>
+              <a:t>Without it, a node restart looks identical to a replay: every packet arrives with a sequence below the stored baseline and is rejected forever. The node never comes back.</a:t>
+            </a:r>
+          </a:p>
+          <a:p>
+            <a:pPr>
+              <a:lnSpc>
+                <a:spcPct val="118000"/>
+              </a:lnSpc>
+              <a:spcAft>
+                <a:spcPts val="1100"/>
+              </a:spcAft>
+              <a:defRPr sz="1700" b="0">
+                <a:solidFill>
+                  <a:srgbClr val="606060"/>
+                </a:solidFill>
+                <a:latin typeface="Calibri"/>
+              </a:defRPr>
+            </a:pPr>
+            <a:r>
+              <a:t>A forward jump is a gap, not a duplicate - those packets were lost, not repeated. A receiver demanding contiguous sequences would deadlock on the first loss.</a:t>
             </a:r>
           </a:p>
         </p:txBody>
@@ -8347,7 +8435,7 @@
               </a:defRPr>
             </a:pPr>
             <a:r>
-              <a:t>MEASURED</a:t>
+              <a:t>THREAT MODEL</a:t>
             </a:r>
           </a:p>
           <a:p>
@@ -8363,7 +8451,7 @@
               </a:defRPr>
             </a:pPr>
             <a:r>
-              <a:t>Results</a:t>
+              <a:t>Security</a:t>
             </a:r>
           </a:p>
         </p:txBody>
@@ -8420,8 +8508,8 @@
         </p:nvSpPr>
         <p:spPr>
           <a:xfrm>
-            <a:off x="640080" y="1920240"/>
-            <a:ext cx="10911535" cy="4389120"/>
+            <a:off x="640080" y="1783080"/>
+            <a:ext cx="5760720" cy="4526280"/>
           </a:xfrm>
           <a:prstGeom prst="rect">
             <a:avLst/>
@@ -8435,10 +8523,32 @@
           <a:lstStyle/>
           <a:p>
             <a:pPr>
-              <a:spcAft>
-                <a:spcPts val="1600"/>
-              </a:spcAft>
-              <a:defRPr sz="2000" b="1">
+              <a:lnSpc>
+                <a:spcPct val="118000"/>
+              </a:lnSpc>
+              <a:spcAft>
+                <a:spcPts val="1100"/>
+              </a:spcAft>
+              <a:defRPr sz="1900" b="1">
+                <a:solidFill>
+                  <a:srgbClr val="0B6B62"/>
+                </a:solidFill>
+                <a:latin typeface="Calibri"/>
+              </a:defRPr>
+            </a:pPr>
+            <a:r>
+              <a:t>Defended</a:t>
+            </a:r>
+          </a:p>
+          <a:p>
+            <a:pPr>
+              <a:lnSpc>
+                <a:spcPct val="118000"/>
+              </a:lnSpc>
+              <a:spcAft>
+                <a:spcPts val="1100"/>
+              </a:spcAft>
+              <a:defRPr sz="1600" b="0">
                 <a:solidFill>
                   <a:srgbClr val="1A1A1A"/>
                 </a:solidFill>
@@ -8446,15 +8556,18 @@
               </a:defRPr>
             </a:pPr>
             <a:r>
-              <a:t>634        packets received and validated</a:t>
-            </a:r>
-          </a:p>
-          <a:p>
-            <a:pPr>
-              <a:spcAft>
-                <a:spcPts val="1600"/>
-              </a:spcAft>
-              <a:defRPr sz="2000" b="1">
+              <a:t>+   Length, version, type, addressing, range validation</a:t>
+            </a:r>
+          </a:p>
+          <a:p>
+            <a:pPr>
+              <a:lnSpc>
+                <a:spcPct val="118000"/>
+              </a:lnSpc>
+              <a:spcAft>
+                <a:spcPts val="1100"/>
+              </a:spcAft>
+              <a:defRPr sz="1600" b="0">
                 <a:solidFill>
                   <a:srgbClr val="1A1A1A"/>
                 </a:solidFill>
@@ -8462,15 +8575,18 @@
               </a:defRPr>
             </a:pPr>
             <a:r>
-              <a:t>82        duplicates rejected</a:t>
-            </a:r>
-          </a:p>
-          <a:p>
-            <a:pPr>
-              <a:spcAft>
-                <a:spcPts val="1600"/>
-              </a:spcAft>
-              <a:defRPr sz="2000" b="1">
+              <a:t>+   Replay rejection via sequence numbers</a:t>
+            </a:r>
+          </a:p>
+          <a:p>
+            <a:pPr>
+              <a:lnSpc>
+                <a:spcPct val="118000"/>
+              </a:lnSpc>
+              <a:spcAft>
+                <a:spcPts val="1100"/>
+              </a:spcAft>
+              <a:defRPr sz="1600" b="0">
                 <a:solidFill>
                   <a:srgbClr val="1A1A1A"/>
                 </a:solidFill>
@@ -8478,15 +8594,18 @@
               </a:defRPr>
             </a:pPr>
             <a:r>
-              <a:t>0        invalid packets - both boards agree on the 26-byte layout</a:t>
-            </a:r>
-          </a:p>
-          <a:p>
-            <a:pPr>
-              <a:spcAft>
-                <a:spcPts val="1600"/>
-              </a:spcAft>
-              <a:defRPr sz="2000" b="1">
+              <a:t>+   ESP-NOW encryption + sender auth - PMK + per-peer LMK</a:t>
+            </a:r>
+          </a:p>
+          <a:p>
+            <a:pPr>
+              <a:lnSpc>
+                <a:spcPct val="118000"/>
+              </a:lnSpc>
+              <a:spcAft>
+                <a:spcPts val="1100"/>
+              </a:spcAft>
+              <a:defRPr sz="1600" b="0">
                 <a:solidFill>
                   <a:srgbClr val="1A1A1A"/>
                 </a:solidFill>
@@ -8494,23 +8613,186 @@
               </a:defRPr>
             </a:pPr>
             <a:r>
-              <a:t>14 / 14        acceptance criteria evidenced</a:t>
-            </a:r>
-          </a:p>
-          <a:p>
-            <a:pPr>
-              <a:spcAft>
-                <a:spcPts val="0"/>
+              <a:t>+   Sender MAC filtering (defence in depth)</a:t>
+            </a:r>
+          </a:p>
+          <a:p>
+            <a:pPr>
+              <a:lnSpc>
+                <a:spcPct val="118000"/>
+              </a:lnSpc>
+              <a:spcAft>
+                <a:spcPts val="1100"/>
               </a:spcAft>
               <a:defRPr sz="1600" b="0">
                 <a:solidFill>
-                  <a:srgbClr val="606060"/>
-                </a:solidFill>
-                <a:latin typeface="Calibri"/>
-              </a:defRPr>
-            </a:pPr>
-            <a:r>
-              <a:t>Node offline detection latches at 20 s; last known value keeps publishing while node1_online carries the truth about freshness.</a:t>
+                  <a:srgbClr val="1A1A1A"/>
+                </a:solidFill>
+                <a:latin typeface="Calibri"/>
+              </a:defRPr>
+            </a:pPr>
+            <a:r>
+              <a:t>+   Credentials excluded from version control</a:t>
+            </a:r>
+          </a:p>
+        </p:txBody>
+      </p:sp>
+      <p:sp>
+        <p:nvSpPr>
+          <p:cNvPr id="5" name="TextBox 4"/>
+          <p:cNvSpPr txBox="1"/>
+          <p:nvPr/>
+        </p:nvSpPr>
+        <p:spPr>
+          <a:xfrm>
+            <a:off x="6492240" y="1783080"/>
+            <a:ext cx="5029200" cy="4526280"/>
+          </a:xfrm>
+          <a:prstGeom prst="rect">
+            <a:avLst/>
+          </a:prstGeom>
+          <a:noFill/>
+        </p:spPr>
+        <p:txBody>
+          <a:bodyPr wrap="square">
+            <a:spAutoFit/>
+          </a:bodyPr>
+          <a:lstStyle/>
+          <a:p>
+            <a:pPr>
+              <a:lnSpc>
+                <a:spcPct val="118000"/>
+              </a:lnSpc>
+              <a:spcAft>
+                <a:spcPts val="1100"/>
+              </a:spcAft>
+              <a:defRPr sz="1900" b="1">
+                <a:solidFill>
+                  <a:srgbClr val="A83A1F"/>
+                </a:solidFill>
+                <a:latin typeface="Calibri"/>
+              </a:defRPr>
+            </a:pPr>
+            <a:r>
+              <a:t>Not defended</a:t>
+            </a:r>
+          </a:p>
+          <a:p>
+            <a:pPr>
+              <a:lnSpc>
+                <a:spcPct val="118000"/>
+              </a:lnSpc>
+              <a:spcAft>
+                <a:spcPts val="1100"/>
+              </a:spcAft>
+              <a:defRPr sz="1600" b="0">
+                <a:solidFill>
+                  <a:srgbClr val="1A1A1A"/>
+                </a:solidFill>
+                <a:latin typeface="Calibri"/>
+              </a:defRPr>
+            </a:pPr>
+            <a:r>
+              <a:t>-   MQTT without TLS - token in clear text</a:t>
+            </a:r>
+          </a:p>
+          <a:p>
+            <a:pPr>
+              <a:lnSpc>
+                <a:spcPct val="118000"/>
+              </a:lnSpc>
+              <a:spcAft>
+                <a:spcPts val="1100"/>
+              </a:spcAft>
+              <a:defRPr sz="1600" b="0">
+                <a:solidFill>
+                  <a:srgbClr val="1A1A1A"/>
+                </a:solidFill>
+                <a:latin typeface="Calibri"/>
+              </a:defRPr>
+            </a:pPr>
+            <a:r>
+              <a:t>-   RADIUS certificate not validated</a:t>
+            </a:r>
+          </a:p>
+          <a:p>
+            <a:pPr>
+              <a:lnSpc>
+                <a:spcPct val="118000"/>
+              </a:lnSpc>
+              <a:spcAft>
+                <a:spcPts val="1100"/>
+              </a:spcAft>
+              <a:defRPr sz="1600" b="0">
+                <a:solidFill>
+                  <a:srgbClr val="1A1A1A"/>
+                </a:solidFill>
+                <a:latin typeface="Calibri"/>
+              </a:defRPr>
+            </a:pPr>
+            <a:r>
+              <a:t>-   Credentials readable from flash over USB</a:t>
+            </a:r>
+          </a:p>
+        </p:txBody>
+      </p:sp>
+      <p:sp>
+        <p:nvSpPr>
+          <p:cNvPr id="6" name="TextBox 5"/>
+          <p:cNvSpPr txBox="1"/>
+          <p:nvPr/>
+        </p:nvSpPr>
+        <p:spPr>
+          <a:xfrm>
+            <a:off x="640080" y="4892040"/>
+            <a:ext cx="9509760" cy="1463040"/>
+          </a:xfrm>
+          <a:prstGeom prst="rect">
+            <a:avLst/>
+          </a:prstGeom>
+          <a:noFill/>
+        </p:spPr>
+        <p:txBody>
+          <a:bodyPr wrap="square">
+            <a:spAutoFit/>
+          </a:bodyPr>
+          <a:lstStyle/>
+          <a:p>
+            <a:pPr>
+              <a:lnSpc>
+                <a:spcPct val="118000"/>
+              </a:lnSpc>
+              <a:spcAft>
+                <a:spcPts val="1100"/>
+              </a:spcAft>
+              <a:defRPr sz="1700" b="1">
+                <a:solidFill>
+                  <a:srgbClr val="A83A1F"/>
+                </a:solidFill>
+                <a:latin typeface="Calibri"/>
+              </a:defRPr>
+            </a:pPr>
+            <a:r>
+              <a:t>The interesting finding</a:t>
+            </a:r>
+          </a:p>
+          <a:p>
+            <a:pPr>
+              <a:lnSpc>
+                <a:spcPct val="118000"/>
+              </a:lnSpc>
+              <a:spcAft>
+                <a:spcPts val="1100"/>
+              </a:spcAft>
+              <a:defRPr sz="1500" b="0">
+                <a:solidFill>
+                  <a:srgbClr val="1A1A1A"/>
+                </a:solidFill>
+                <a:latin typeface="Calibri"/>
+              </a:defRPr>
+            </a:pPr>
+            <a:r>
+              <a:t>src_id is a claim, not proof. A forged packet with a high sequence number under the live boot_id advances the dedup baseline - after which every genuine packet is rejected until the node reboots. Replay protection becomes the attack surface. Fixed by encrypting the link: a MAC filter was not enough, because the attacker controls the value being filtered on.</a:t>
             </a:r>
           </a:p>
         </p:txBody>

</xml_diff>

<commit_message>
Write speaker notes into every slide
The deck said what the project is but carried nothing about how to present it,
so the presenter was left reconstructing the argument live.

Each slide now has notes with a time budget, the words to say, and the backup
detail a question would need. They are longest where the explaining actually
happens: the two diagrams, the security story, and the three minutes of live
hardware where most of the marks are.

The notes also carry the things worth saying before being asked - the one-hop
limitation, the sensor substitution, and the unencrypted cloud leg.
</commit_message>
<xml_diff>
--- a/PRESENTATION.pptx
+++ b/PRESENTATION.pptx
@@ -519,7 +519,29 @@
           <a:lstStyle/>
           <a:p>
             <a:r>
-              <a:t>10 minutes total, then 5 for questions. Names and course code on this slide before you present. Have both boards powered and the dashboard already open.</a:t>
+              <a:t>~15 s. Do not read the slide.</a:t>
+            </a:r>
+          </a:p>
+          <a:p/>
+          <a:p>
+            <a:r>
+              <a:t>SAY: "Project one. Two ESP32 boards. One of them has no internet connection at</a:t>
+            </a:r>
+          </a:p>
+          <a:p>
+            <a:r>
+              <a:t>all, and its readings still reach the cloud - because the other one carries</a:t>
+            </a:r>
+          </a:p>
+          <a:p>
+            <a:r>
+              <a:t>them for it."</a:t>
+            </a:r>
+          </a:p>
+          <a:p/>
+          <a:p>
+            <a:r>
+              <a:t>Then move on. The title slide is not where marks are.</a:t>
             </a:r>
           </a:p>
         </p:txBody>
@@ -589,7 +611,55 @@
           <a:lstStyle/>
           <a:p>
             <a:r>
-              <a:t>This is the money shot. Two physically separate sensors, one of which has no network connection, arriving as a single cloud stream.</a:t>
+              <a:t>~40 s.</a:t>
+            </a:r>
+          </a:p>
+          <a:p/>
+          <a:p>
+            <a:r>
+              <a:t>SAY: "Two physically separate sensors appear in the cloud as one device and one</a:t>
+            </a:r>
+          </a:p>
+          <a:p>
+            <a:r>
+              <a:t>data stream, because the merge happens on Board 2 before anything leaves the</a:t>
+            </a:r>
+          </a:p>
+          <a:p>
+            <a:r>
+              <a:t>building. Blue is the gateway's own sensor. Green is the remote node, arriving</a:t>
+            </a:r>
+          </a:p>
+          <a:p>
+            <a:r>
+              <a:t>by radio."</a:t>
+            </a:r>
+          </a:p>
+          <a:p/>
+          <a:p>
+            <a:r>
+              <a:t>WHY MERGE AT THE EDGE: less traffic, less power, and the cloud does not have to</a:t>
+            </a:r>
+          </a:p>
+          <a:p>
+            <a:r>
+              <a:t>correlate two separate streams. Two 26-byte frames every five seconds become one</a:t>
+            </a:r>
+          </a:p>
+          <a:p>
+            <a:r>
+              <a:t>publish every ten. And the remote node needs no cloud credentials at all.</a:t>
+            </a:r>
+          </a:p>
+          <a:p/>
+          <a:p>
+            <a:r>
+              <a:t>IF THE TRACE LOOKS STEPPED: that is the DHT11's one-degree resolution, not a</a:t>
+            </a:r>
+          </a:p>
+          <a:p>
+            <a:r>
+              <a:t>frozen sensor. Say it before they wonder.</a:t>
             </a:r>
           </a:p>
         </p:txBody>
@@ -659,7 +729,164 @@
           <a:lstStyle/>
           <a:p>
             <a:r>
-              <a:t>SWITCH TO LIVE. Three windows: both serials and the dashboard. Warm the sensor with your thumb - about 7 degrees in 15 seconds, and it relaxes back after.</a:t>
+              <a:t>3 MINUTES. Most of the marks are here. Stop presenting, start operating,</a:t>
+            </a:r>
+          </a:p>
+          <a:p>
+            <a:r>
+              <a:t>and keep talking while you do it.</a:t>
+            </a:r>
+          </a:p>
+          <a:p/>
+          <a:p>
+            <a:r>
+              <a:t>BEFORE YOU BEGIN: three windows visible at once - Board 1 serial, Board 2</a:t>
+            </a:r>
+          </a:p>
+          <a:p>
+            <a:r>
+              <a:t>serial, ThingsBoard. The argument only lands if all three are on screen.</a:t>
+            </a:r>
+          </a:p>
+          <a:p/>
+          <a:p>
+            <a:r>
+              <a:t>1. BOTH TERMINALS</a:t>
+            </a:r>
+          </a:p>
+          <a:p>
+            <a:r>
+              <a:t>   "Left is Board 1 sending. Right is Board 2 receiving. Same sequence number,</a:t>
+            </a:r>
+          </a:p>
+          <a:p>
+            <a:r>
+              <a:t>   one millisecond apart."</a:t>
+            </a:r>
+          </a:p>
+          <a:p>
+            <a:r>
+              <a:t>   If pressed on why that matters: the acknowledgement is from the receiving</a:t>
+            </a:r>
+          </a:p>
+          <a:p>
+            <a:r>
+              <a:t>   radio, not the application. It proves the bytes arrived, not that they were</a:t>
+            </a:r>
+          </a:p>
+          <a:p>
+            <a:r>
+              <a:t>   accepted. The arrival line on the other board proves acceptance. Together</a:t>
+            </a:r>
+          </a:p>
+          <a:p>
+            <a:r>
+              <a:t>   they prove both - which one port alone cannot.</a:t>
+            </a:r>
+          </a:p>
+          <a:p/>
+          <a:p>
+            <a:r>
+              <a:t>2. THUMB ON THE SENSOR</a:t>
+            </a:r>
+          </a:p>
+          <a:p>
+            <a:r>
+              <a:t>   "Watch the temperature climb."</a:t>
+            </a:r>
+          </a:p>
+          <a:p>
+            <a:r>
+              <a:t>   WAIT. Let them see it move. This proves the entire chain - sensor, radio,</a:t>
+            </a:r>
+          </a:p>
+          <a:p>
+            <a:r>
+              <a:t>   gateway, internet, dashboard - in about fifteen seconds. It is the single</a:t>
+            </a:r>
+          </a:p>
+          <a:p>
+            <a:r>
+              <a:t>   most convincing thing you can do.</a:t>
+            </a:r>
+          </a:p>
+          <a:p/>
+          <a:p>
+            <a:r>
+              <a:t>3. PRESS "FAST PUBLISH (2 s)"</a:t>
+            </a:r>
+          </a:p>
+          <a:p>
+            <a:r>
+              <a:t>   "That button sends an instruction from the cloud down to the device. It</a:t>
+            </a:r>
+          </a:p>
+          <a:p>
+            <a:r>
+              <a:t>   changes how often it reports - from ten seconds to two."</a:t>
+            </a:r>
+          </a:p>
+          <a:p>
+            <a:r>
+              <a:t>   Then show the value returning: "And there is the device confirming it. Not</a:t>
+            </a:r>
+          </a:p>
+          <a:p>
+            <a:r>
+              <a:t>   just that we sent it - that it arrived and took effect."</a:t>
+            </a:r>
+          </a:p>
+          <a:p/>
+          <a:p>
+            <a:r>
+              <a:t>4. UNPLUG BOARD 1 - keep talking, do not stand in silence</a:t>
+            </a:r>
+          </a:p>
+          <a:p>
+            <a:r>
+              <a:t>   "The gateway keeps publishing its own reading. Give it twenty seconds and it</a:t>
+            </a:r>
+          </a:p>
+          <a:p>
+            <a:r>
+              <a:t>   will mark the other board offline - but it keeps showing the last known</a:t>
+            </a:r>
+          </a:p>
+          <a:p>
+            <a:r>
+              <a:t>   temperature so the chart does not gap. The status flag carries the truth</a:t>
+            </a:r>
+          </a:p>
+          <a:p>
+            <a:r>
+              <a:t>   about freshness."</a:t>
+            </a:r>
+          </a:p>
+          <a:p/>
+          <a:p>
+            <a:r>
+              <a:t>5. PLUG IT BACK IN</a:t>
+            </a:r>
+          </a:p>
+          <a:p>
+            <a:r>
+              <a:t>   "New random ID, numbering restarts, accepted cleanly. No flood of rejected</a:t>
+            </a:r>
+          </a:p>
+          <a:p>
+            <a:r>
+              <a:t>   duplicates."</a:t>
+            </a:r>
+          </a:p>
+          <a:p/>
+          <a:p>
+            <a:r>
+              <a:t>IF THE LINK IS DEAD: it is the channel. Read it off Board 2's boot banner, put</a:t>
+            </a:r>
+          </a:p>
+          <a:p>
+            <a:r>
+              <a:t>it in sketch 04, re-upload to Board 1. Two minutes. Do not guess.</a:t>
             </a:r>
           </a:p>
         </p:txBody>
@@ -729,7 +956,34 @@
           <a:lstStyle/>
           <a:p>
             <a:r>
-              <a:t>Own the substitution rather than hiding it. The gain is real: indoor pressure would be a flat line for hours, humidity responds to a hand in seconds.</a:t>
+              <a:t>~30 s.</a:t>
+            </a:r>
+          </a:p>
+          <a:p/>
+          <a:p>
+            <a:r>
+              <a:t>SAY: "The brief specified a BMP280. The hardware available was a DHT11. That</a:t>
+            </a:r>
+          </a:p>
+          <a:p>
+            <a:r>
+              <a:t>changes what we measure - humidity instead of pressure - but not the</a:t>
+            </a:r>
+          </a:p>
+          <a:p>
+            <a:r>
+              <a:t>architecture we are demonstrating. It is documented in the report rather than</a:t>
+            </a:r>
+          </a:p>
+          <a:p>
+            <a:r>
+              <a:t>glossed over."</a:t>
+            </a:r>
+          </a:p>
+          <a:p/>
+          <a:p>
+            <a:r>
+              <a:t>Owning a substitution is stronger than hoping nobody checks.</a:t>
             </a:r>
           </a:p>
         </p:txBody>
@@ -799,7 +1053,44 @@
           <a:lstStyle/>
           <a:p>
             <a:r>
-              <a:t>Name these yourself. Being asked about a limitation you did not mention is worse than raising it first.</a:t>
+              <a:t>~45 s. Name your own limits. It reads as maturity, not weakness.</a:t>
+            </a:r>
+          </a:p>
+          <a:p/>
+          <a:p>
+            <a:r>
+              <a:t>SAY: "One hop only - two radios cannot demonstrate forwarding. The cloud</a:t>
+            </a:r>
+          </a:p>
+          <a:p>
+            <a:r>
+              <a:t>connection is not encrypted, so the access token crosses in clear text.</a:t>
+            </a:r>
+          </a:p>
+          <a:p>
+            <a:r>
+              <a:t>Credentials are compiled into the firmware and recoverable over USB. And the</a:t>
+            </a:r>
+          </a:p>
+          <a:p>
+            <a:r>
+              <a:t>channel is set by hand, so a Wi-Fi roam breaks the link silently."</a:t>
+            </a:r>
+          </a:p>
+          <a:p/>
+          <a:p>
+            <a:r>
+              <a:t>DO NOT list ESP-NOW encryption as a limitation. It is implemented - a primary</a:t>
+            </a:r>
+          </a:p>
+          <a:p>
+            <a:r>
+              <a:t>master key plus a per-peer key, and the receiver authenticates the sender. That</a:t>
+            </a:r>
+          </a:p>
+          <a:p>
+            <a:r>
+              <a:t>is a feature you built, not a gap.</a:t>
             </a:r>
           </a:p>
         </p:txBody>
@@ -869,7 +1160,44 @@
           <a:lstStyle/>
           <a:p>
             <a:r>
-              <a:t>These are yours - measured, not read in a datasheet. Worth saying that explicitly.</a:t>
+              <a:t>~30 s.</a:t>
+            </a:r>
+          </a:p>
+          <a:p/>
+          <a:p>
+            <a:r>
+              <a:t>SAY: "We tested the assumptions rather than trusting them. Port 1883 is open</a:t>
+            </a:r>
+          </a:p>
+          <a:p>
+            <a:r>
+              <a:t>outbound on eduroam - we verified that rather than assuming it. The realm for</a:t>
+            </a:r>
+          </a:p>
+          <a:p>
+            <a:r>
+              <a:t>authentication turned out to be the university domain, not the student mail</a:t>
+            </a:r>
+          </a:p>
+          <a:p>
+            <a:r>
+              <a:t>domain, and enterprise Wi-Fi gives you no error that distinguishes a wrong</a:t>
+            </a:r>
+          </a:p>
+          <a:p>
+            <a:r>
+              <a:t>username from a wrong password or being out of range. We found it by changing</a:t>
+            </a:r>
+          </a:p>
+          <a:p>
+            <a:r>
+              <a:t>one thing at a time."</a:t>
+            </a:r>
+          </a:p>
+          <a:p/>
+          <a:p>
+            <a:r>
+              <a:t>That story answers "what was the hardest part" before it is asked.</a:t>
             </a:r>
           </a:p>
         </p:txBody>
@@ -939,7 +1267,44 @@
           <a:lstStyle/>
           <a:p>
             <a:r>
-              <a:t>Short. Shows you know what production would need.</a:t>
+              <a:t>~30 s.</a:t>
+            </a:r>
+          </a:p>
+          <a:p/>
+          <a:p>
+            <a:r>
+              <a:t>SAY: "Next steps, in order of value: a third board so the forwarding fields are</a:t>
+            </a:r>
+          </a:p>
+          <a:p>
+            <a:r>
+              <a:t>actually exercised. TLS on the cloud leg, which is the most serious remaining</a:t>
+            </a:r>
+          </a:p>
+          <a:p>
+            <a:r>
+              <a:t>exposure. Credentials provisioned at first boot rather than compiled in. And the</a:t>
+            </a:r>
+          </a:p>
+          <a:p>
+            <a:r>
+              <a:t>node scanning for the gateway instead of being told the channel by hand - that</a:t>
+            </a:r>
+          </a:p>
+          <a:p>
+            <a:r>
+              <a:t>would have prevented three outages during development."</a:t>
+            </a:r>
+          </a:p>
+          <a:p/>
+          <a:p>
+            <a:r>
+              <a:t>Each item maps to a limitation on the previous slide. That symmetry is</a:t>
+            </a:r>
+          </a:p>
+          <a:p>
+            <a:r>
+              <a:t>deliberate - show it.</a:t>
             </a:r>
           </a:p>
         </p:txBody>
@@ -1009,7 +1374,383 @@
           <a:lstStyle/>
           <a:p>
             <a:r>
-              <a:t>Stop here and take questions. Rehearsed answers are in DEMO_PLAN.md - especially the security one, which is the likeliest question.</a:t>
+              <a:t>Questions - 5 minutes.</a:t>
+            </a:r>
+          </a:p>
+          <a:p/>
+          <a:p>
+            <a:r>
+              <a:t>"HOW DOES IT WORK?" - One board measures and radios it across. The other adds</a:t>
+            </a:r>
+          </a:p>
+          <a:p>
+            <a:r>
+              <a:t>its own reading and sends both to the cloud.</a:t>
+            </a:r>
+          </a:p>
+          <a:p/>
+          <a:p>
+            <a:r>
+              <a:t>"WHY NOT WI-FI ON BOTH?" - Both would need credentials, setup and battery to</a:t>
+            </a:r>
+          </a:p>
+          <a:p>
+            <a:r>
+              <a:t>join. One gateway carrying several nodes scales better.</a:t>
+            </a:r>
+          </a:p>
+          <a:p/>
+          <a:p>
+            <a:r>
+              <a:t>"IS IT SECURE?" - The radio link is: encrypted, keys on both ends, and the</a:t>
+            </a:r>
+          </a:p>
+          <a:p>
+            <a:r>
+              <a:t>receiver rejects anything that does not decrypt. The cloud link is not. That is</a:t>
+            </a:r>
+          </a:p>
+          <a:p>
+            <a:r>
+              <a:t>the honest gap.</a:t>
+            </a:r>
+          </a:p>
+          <a:p/>
+          <a:p>
+            <a:r>
+              <a:t>"IS IT A MESH?" - Mesh-ready. Two radios can only do one hop. The format carries</a:t>
+            </a:r>
+          </a:p>
+          <a:p>
+            <a:r>
+              <a:t>a hop counter; we simply never forward.</a:t>
+            </a:r>
+          </a:p>
+          <a:p/>
+          <a:p>
+            <a:r>
+              <a:t>"WHY QoS 0?" - Telemetry every ten seconds. A lost sample is superseded ten</a:t>
+            </a:r>
+          </a:p>
+          <a:p>
+            <a:r>
+              <a:t>seconds later. QoS 1 costs round trips and a queue for data with a very short</a:t>
+            </a:r>
+          </a:p>
+          <a:p>
+            <a:r>
+              <a:t>shelf life.</a:t>
+            </a:r>
+          </a:p>
+          <a:p/>
+          <a:p>
+            <a:r>
+              <a:t>"ISN'T THE ACKNOWLEDGEMENT PROOF ENOUGH?" - No. It comes from the radio, not the</a:t>
+            </a:r>
+          </a:p>
+          <a:p>
+            <a:r>
+              <a:t>application. It proves the bytes arrived, not that they were accepted. That is</a:t>
+            </a:r>
+          </a:p>
+          <a:p>
+            <a:r>
+              <a:t>why we captured both boards against one clock.</a:t>
+            </a:r>
+          </a:p>
+          <a:p/>
+          <a:p>
+            <a:r>
+              <a:t>"WHAT WAS THE HARDEST PART?" - Not the code, the campus network. Enterprise</a:t>
+            </a:r>
+          </a:p>
+          <a:p>
+            <a:r>
+              <a:t>Wi-Fi gives no useful error, so a wrong username looks identical to a wrong</a:t>
+            </a:r>
+          </a:p>
+          <a:p>
+            <a:r>
+              <a:t>password or being out of range.</a:t>
+            </a:r>
+          </a:p>
+          <a:p/>
+          <a:p>
+            <a:r>
+              <a:t>"WHY DHT11?" - It is what was available. It changes what we measure, not the</a:t>
+            </a:r>
+          </a:p>
+          <a:p>
+            <a:r>
+              <a:t>architecture.</a:t>
+            </a:r>
+          </a:p>
+          <a:p/>
+          <a:p>
+            <a:r>
+              <a:t>IF YOU DO NOT KNOW: "I don't know off the top of my head - it is in the report</a:t>
+            </a:r>
+          </a:p>
+          <a:p>
+            <a:r>
+              <a:t>and I can check." That costs almost nothing. Guessing and being wrong costs a</a:t>
+            </a:r>
+          </a:p>
+          <a:p>
+            <a:r>
+              <a:t>great deal.</a:t>
+            </a:r>
+          </a:p>
+        </p:txBody>
+      </p:sp>
+      <p:sp>
+        <p:nvSpPr>
+          <p:cNvPr id="4" name="Slide Number Placeholder 3"/>
+          <p:cNvSpPr>
+            <a:spLocks noGrp="1"/>
+          </p:cNvSpPr>
+          <p:nvPr>
+            <p:ph type="sldNum" idx="5" sz="quarter"/>
+          </p:nvPr>
+        </p:nvSpPr>
+        <p:spPr/>
+      </p:sp>
+    </p:spTree>
+  </p:cSld>
+  <p:clrMapOvr>
+    <a:masterClrMapping/>
+  </p:clrMapOvr>
+</p:notes>
+</file>
+
+<file path=ppt/notesSlides/notesSlide17.xml><?xml version="1.0" encoding="utf-8"?>
+<p:notes xmlns:a="http://schemas.openxmlformats.org/drawingml/2006/main" xmlns:p="http://schemas.openxmlformats.org/presentationml/2006/main" xmlns:r="http://schemas.openxmlformats.org/officeDocument/2006/relationships">
+  <p:cSld>
+    <p:spTree>
+      <p:nvGrpSpPr>
+        <p:cNvPr id="1" name=""/>
+        <p:cNvGrpSpPr/>
+        <p:nvPr/>
+      </p:nvGrpSpPr>
+      <p:grpSpPr>
+        <a:xfrm>
+          <a:off x="0" y="0"/>
+          <a:ext cx="0" cy="0"/>
+          <a:chOff x="0" y="0"/>
+          <a:chExt cx="0" cy="0"/>
+        </a:xfrm>
+      </p:grpSpPr>
+      <p:sp>
+        <p:nvSpPr>
+          <p:cNvPr id="2" name="Slide Image Placeholder 1"/>
+          <p:cNvSpPr>
+            <a:spLocks noGrp="1"/>
+          </p:cNvSpPr>
+          <p:nvPr>
+            <p:ph type="sldImg" idx="2"/>
+          </p:nvPr>
+        </p:nvSpPr>
+        <p:spPr/>
+      </p:sp>
+      <p:sp>
+        <p:nvSpPr>
+          <p:cNvPr id="3" name="Notes Placeholder 2"/>
+          <p:cNvSpPr>
+            <a:spLocks noGrp="1"/>
+          </p:cNvSpPr>
+          <p:nvPr>
+            <p:ph type="body" idx="3" sz="quarter"/>
+          </p:nvPr>
+        </p:nvSpPr>
+        <p:spPr/>
+        <p:txBody>
+          <a:bodyPr/>
+          <a:lstStyle/>
+          <a:p>
+            <a:r>
+              <a:t>~40 s. The circuit diagram answers a different question from the block</a:t>
+            </a:r>
+          </a:p>
+          <a:p>
+            <a:r>
+              <a:t>diagram: block is what moves, circuit is which pin connects to which.</a:t>
+            </a:r>
+          </a:p>
+          <a:p/>
+          <a:p>
+            <a:r>
+              <a:t>SAY: "Three wires per board - power, ground, and data. Identical on both boards</a:t>
+            </a:r>
+          </a:p>
+          <a:p>
+            <a:r>
+              <a:t>apart from which pin the data goes into: GPIO4 on one, GPIO5 on the other.</a:t>
+            </a:r>
+          </a:p>
+          <a:p>
+            <a:r>
+              <a:t>Notice there is no wire between the two boards. Separate USB supplies, separate</a:t>
+            </a:r>
+          </a:p>
+          <a:p>
+            <a:r>
+              <a:t>grounds. Nothing crosses between them except radio."</a:t>
+            </a:r>
+          </a:p>
+          <a:p/>
+          <a:p>
+            <a:r>
+              <a:t>WHY THE PINS DIFFER: they were wired at different times and nothing required</a:t>
+            </a:r>
+          </a:p>
+          <a:p>
+            <a:r>
+              <a:t>them to match. That is the honest answer - do not invent a reason.</a:t>
+            </a:r>
+          </a:p>
+          <a:p/>
+          <a:p>
+            <a:r>
+              <a:t>IF ASKED where the pull-up resistor is: "These are three-pin breakout modules -</a:t>
+            </a:r>
+          </a:p>
+          <a:p>
+            <a:r>
+              <a:t>the resistor is already on the module. A bare DHT11 would need about 10 k on the</a:t>
+            </a:r>
+          </a:p>
+          <a:p>
+            <a:r>
+              <a:t>data line."</a:t>
+            </a:r>
+          </a:p>
+          <a:p/>
+          <a:p>
+            <a:r>
+              <a:t>IF ASKED about the dashed line: that is ESP-NOW, encrypted with a shared key</a:t>
+            </a:r>
+          </a:p>
+          <a:p>
+            <a:r>
+              <a:t>pair. It is drawn dashed precisely because it is not a wire.</a:t>
+            </a:r>
+          </a:p>
+        </p:txBody>
+      </p:sp>
+      <p:sp>
+        <p:nvSpPr>
+          <p:cNvPr id="4" name="Slide Number Placeholder 3"/>
+          <p:cNvSpPr>
+            <a:spLocks noGrp="1"/>
+          </p:cNvSpPr>
+          <p:nvPr>
+            <p:ph type="sldNum" idx="5" sz="quarter"/>
+          </p:nvPr>
+        </p:nvSpPr>
+        <p:spPr/>
+      </p:sp>
+    </p:spTree>
+  </p:cSld>
+  <p:clrMapOvr>
+    <a:masterClrMapping/>
+  </p:clrMapOvr>
+</p:notes>
+</file>
+
+<file path=ppt/notesSlides/notesSlide18.xml><?xml version="1.0" encoding="utf-8"?>
+<p:notes xmlns:a="http://schemas.openxmlformats.org/drawingml/2006/main" xmlns:p="http://schemas.openxmlformats.org/presentationml/2006/main" xmlns:r="http://schemas.openxmlformats.org/officeDocument/2006/relationships">
+  <p:cSld>
+    <p:spTree>
+      <p:nvGrpSpPr>
+        <p:cNvPr id="1" name=""/>
+        <p:cNvGrpSpPr/>
+        <p:nvPr/>
+      </p:nvGrpSpPr>
+      <p:grpSpPr>
+        <a:xfrm>
+          <a:off x="0" y="0"/>
+          <a:ext cx="0" cy="0"/>
+          <a:chOff x="0" y="0"/>
+          <a:chExt cx="0" cy="0"/>
+        </a:xfrm>
+      </p:grpSpPr>
+      <p:sp>
+        <p:nvSpPr>
+          <p:cNvPr id="2" name="Slide Image Placeholder 1"/>
+          <p:cNvSpPr>
+            <a:spLocks noGrp="1"/>
+          </p:cNvSpPr>
+          <p:nvPr>
+            <p:ph type="sldImg" idx="2"/>
+          </p:nvPr>
+        </p:nvSpPr>
+        <p:spPr/>
+      </p:sp>
+      <p:sp>
+        <p:nvSpPr>
+          <p:cNvPr id="3" name="Notes Placeholder 2"/>
+          <p:cNvSpPr>
+            <a:spLocks noGrp="1"/>
+          </p:cNvSpPr>
+          <p:nvPr>
+            <p:ph type="body" idx="3" sz="quarter"/>
+          </p:nvPr>
+        </p:nvSpPr>
+        <p:spPr/>
+        <p:txBody>
+          <a:bodyPr/>
+          <a:lstStyle/>
+          <a:p>
+            <a:r>
+              <a:t>~40 s.</a:t>
+            </a:r>
+          </a:p>
+          <a:p/>
+          <a:p>
+            <a:r>
+              <a:t>SAY: "Telemetry alone makes a device observable. It does not make it</a:t>
+            </a:r>
+          </a:p>
+          <a:p>
+            <a:r>
+              <a:t>manageable. These three buttons send commands from the cloud down to the</a:t>
+            </a:r>
+          </a:p>
+          <a:p>
+            <a:r>
+              <a:t>device - change how often it reports, reset its counters, ask for its status."</a:t>
+            </a:r>
+          </a:p>
+          <a:p/>
+          <a:p>
+            <a:r>
+              <a:t>THE KEY POINT: "And the device reports the change back in its own telemetry. So</a:t>
+            </a:r>
+          </a:p>
+          <a:p>
+            <a:r>
+              <a:t>we are not just seeing that the command was sent - we are seeing that it</a:t>
+            </a:r>
+          </a:p>
+          <a:p>
+            <a:r>
+              <a:t>arrived and took effect. The round trip is confirmed at both ends."</a:t>
+            </a:r>
+          </a:p>
+          <a:p/>
+          <a:p>
+            <a:r>
+              <a:t>ON VALIDATION: out-of-range values are refused rather than quietly adjusted.</a:t>
+            </a:r>
+          </a:p>
+          <a:p>
+            <a:r>
+              <a:t>Silently applying something different from what was asked would leave the</a:t>
+            </a:r>
+          </a:p>
+          <a:p>
+            <a:r>
+              <a:t>operator believing something untrue about the device.</a:t>
             </a:r>
           </a:p>
         </p:txBody>
@@ -1079,7 +1820,54 @@
           <a:lstStyle/>
           <a:p>
             <a:r>
-              <a:t>Frame the problem before the solution. The point is that a sensor with no network connection of its own still gets its data to the cloud.</a:t>
+              <a:t>~40 s.</a:t>
+            </a:r>
+          </a:p>
+          <a:p/>
+          <a:p>
+            <a:r>
+              <a:t>SAY: "Imagine a sensor somewhere with no Wi-Fi - a basement, a field, a corner</a:t>
+            </a:r>
+          </a:p>
+          <a:p>
+            <a:r>
+              <a:t>of a building. Connecting it properly is expensive. Every device needs its own</a:t>
+            </a:r>
+          </a:p>
+          <a:p>
+            <a:r>
+              <a:t>network password and its own setup, and joining Wi-Fi burns battery for several</a:t>
+            </a:r>
+          </a:p>
+          <a:p>
+            <a:r>
+              <a:t>seconds before a single reading is sent. So we flipped it. One device does the</a:t>
+            </a:r>
+          </a:p>
+          <a:p>
+            <a:r>
+              <a:t>connecting. The others talk to it cheaply over short-range radio."</a:t>
+            </a:r>
+          </a:p>
+          <a:p/>
+          <a:p>
+            <a:r>
+              <a:t>IF ASKED why joining is expensive: scan every channel for beacons, authenticate</a:t>
+            </a:r>
+          </a:p>
+          <a:p>
+            <a:r>
+              <a:t>against the university RADIUS server, associate, then request an IP by DHCP -</a:t>
+            </a:r>
+          </a:p>
+          <a:p>
+            <a:r>
+              <a:t>all before one useful byte moves. On battery the radio is the largest draw in</a:t>
+            </a:r>
+          </a:p>
+          <a:p>
+            <a:r>
+              <a:t>the device.</a:t>
             </a:r>
           </a:p>
         </p:txBody>
@@ -1149,7 +1937,66 @@
           <a:lstStyle/>
           <a:p>
             <a:r>
-              <a:t>Hold the boards up here. Physically separate them so the audience sees there is no wire. Say the scope claim now, not at the end.</a:t>
+              <a:t>~30 s. Say the limitation FIRST, before anyone asks.</a:t>
+            </a:r>
+          </a:p>
+          <a:p/>
+          <a:p>
+            <a:r>
+              <a:t>SAY: "Two ESP32 boards, each with a temperature and humidity sensor. Board 1</a:t>
+            </a:r>
+          </a:p>
+          <a:p>
+            <a:r>
+              <a:t>measures and sends by radio. Board 2 listens, adds its own reading, and</a:t>
+            </a:r>
+          </a:p>
+          <a:p>
+            <a:r>
+              <a:t>publishes both to the cloud."</a:t>
+            </a:r>
+          </a:p>
+          <a:p/>
+          <a:p>
+            <a:r>
+              <a:t>THEN: "With only two boards this is one hop - one sender, one receiver. We</a:t>
+            </a:r>
+          </a:p>
+          <a:p>
+            <a:r>
+              <a:t>designed the message so a third board could pass it along, but nothing is ever</a:t>
+            </a:r>
+          </a:p>
+          <a:p>
+            <a:r>
+              <a:t>actually forwarded here. It is mesh-ready, not a mesh."</a:t>
+            </a:r>
+          </a:p>
+          <a:p/>
+          <a:p>
+            <a:r>
+              <a:t>Volunteering your own limits reads as confidence. Being caught out on them does</a:t>
+            </a:r>
+          </a:p>
+          <a:p>
+            <a:r>
+              <a:t>not.</a:t>
+            </a:r>
+          </a:p>
+          <a:p/>
+          <a:p>
+            <a:r>
+              <a:t>BACKUP: ESP32-D0WD-V3, dual core 240 MHz, 520 KB RAM, 4 MB flash, one 2.4 GHz</a:t>
+            </a:r>
+          </a:p>
+          <a:p>
+            <a:r>
+              <a:t>radio. DHT11: 0-50 C plus/minus 2, 20-90 % RH plus/minus 5, 1 Hz max sample</a:t>
+            </a:r>
+          </a:p>
+          <a:p>
+            <a:r>
+              <a:t>rate. Substituted for the BMP280 in the brief - documented in the report.</a:t>
             </a:r>
           </a:p>
         </p:txBody>
@@ -1219,7 +2066,124 @@
           <a:lstStyle/>
           <a:p>
             <a:r>
-              <a:t>Walk left to right. Two protocols doing two different jobs: ESP-NOW has no IP stack at all, MQTT is TCP to the cloud.</a:t>
+              <a:t>~1 minute. This is your strongest slide. Point at the middle column first.</a:t>
+            </a:r>
+          </a:p>
+          <a:p/>
+          <a:p>
+            <a:r>
+              <a:t>SAY: "Three stages - the sensor, the middleman, the cloud. The one in the middle</a:t>
+            </a:r>
+          </a:p>
+          <a:p>
+            <a:r>
+              <a:t>is on both networks at the same time: the radio network and the Wi-Fi. That is</a:t>
+            </a:r>
+          </a:p>
+          <a:p>
+            <a:r>
+              <a:t>the whole trick. It holds both sets of keys, so Board 1 reaches the internet</a:t>
+            </a:r>
+          </a:p>
+          <a:p>
+            <a:r>
+              <a:t>without ever joining it."</a:t>
+            </a:r>
+          </a:p>
+          <a:p/>
+          <a:p>
+            <a:r>
+              <a:t>THEN WALK THE THREE ARROWS:</a:t>
+            </a:r>
+          </a:p>
+          <a:p>
+            <a:r>
+              <a:t>  Orange  - the radio between the boards. Dashed, because there is no wire.</a:t>
+            </a:r>
+          </a:p>
+          <a:p>
+            <a:r>
+              <a:t>  Green   - data going up to the cloud.</a:t>
+            </a:r>
+          </a:p>
+          <a:p>
+            <a:r>
+              <a:t>  Purple  - instructions coming back down.</a:t>
+            </a:r>
+          </a:p>
+          <a:p/>
+          <a:p>
+            <a:r>
+              <a:t>THE LINE WORTH MEMORISING:</a:t>
+            </a:r>
+          </a:p>
+          <a:p>
+            <a:r>
+              <a:t>  "Green means we can watch it. Purple means we can control it."</a:t>
+            </a:r>
+          </a:p>
+          <a:p/>
+          <a:p>
+            <a:r>
+              <a:t>WHY THREE COLUMNS: the diagram is drawn as columns so the single crossing point</a:t>
+            </a:r>
+          </a:p>
+          <a:p>
+            <a:r>
+              <a:t>is obvious. That crossing point is the entire argument of the project.</a:t>
+            </a:r>
+          </a:p>
+          <a:p/>
+          <a:p>
+            <a:r>
+              <a:t>THE THEORY UNDERNEATH: networks are built in layers. ESP-NOW works at the link</a:t>
+            </a:r>
+          </a:p>
+          <a:p>
+            <a:r>
+              <a:t>layer - no IP address, no routing, no concept of "somewhere else". It can only</a:t>
+            </a:r>
+          </a:p>
+          <a:p>
+            <a:r>
+              <a:t>reach a radio it can physically hear. MQTT works at the application layer, on</a:t>
+            </a:r>
+          </a:p>
+          <a:p>
+            <a:r>
+              <a:t>top of TCP and IP. Because the two protocols sit at different layers, one device</a:t>
+            </a:r>
+          </a:p>
+          <a:p>
+            <a:r>
+              <a:t>can bridge them. A bridge between layers is what the word "gateway" means.</a:t>
+            </a:r>
+          </a:p>
+          <a:p/>
+          <a:p>
+            <a:r>
+              <a:t>IF ASKED why two arrows for MQTT: because that is the difference between a</a:t>
+            </a:r>
+          </a:p>
+          <a:p>
+            <a:r>
+              <a:t>device you can watch and a device you can operate. One connection, two</a:t>
+            </a:r>
+          </a:p>
+          <a:p>
+            <a:r>
+              <a:t>directions.</a:t>
+            </a:r>
+          </a:p>
+          <a:p/>
+          <a:p>
+            <a:r>
+              <a:t>FOOTNOTES ON THE SLIDE protect you: the access point chooses the channel, and</a:t>
+            </a:r>
+          </a:p>
+          <a:p>
+            <a:r>
+              <a:t>ttl and hop_count exist but nothing is ever forwarded.</a:t>
             </a:r>
           </a:p>
         </p:txBody>
@@ -1289,7 +2253,76 @@
           <a:lstStyle/>
           <a:p>
             <a:r>
-              <a:t>This is the best thing you have to explain and it is worth dwelling on. The channel is discovered, not chosen. It dictates the whole upload order.</a:t>
+              <a:t>~45 s. This slide shows engineering judgement rather than coding.</a:t>
+            </a:r>
+          </a:p>
+          <a:p/>
+          <a:p>
+            <a:r>
+              <a:t>SAY: "A radio can only listen on one channel at a time. Board 2 has to join the</a:t>
+            </a:r>
+          </a:p>
+          <a:p>
+            <a:r>
+              <a:t>campus Wi-Fi to reach the cloud, and the Wi-Fi network decides which channel</a:t>
+            </a:r>
+          </a:p>
+          <a:p>
+            <a:r>
+              <a:t>that is. We do not get to pick it - we find out at runtime and tell Board 1 to</a:t>
+            </a:r>
+          </a:p>
+          <a:p>
+            <a:r>
+              <a:t>match. That decides the whole setup order: you cannot configure Board 1 until</a:t>
+            </a:r>
+          </a:p>
+          <a:p>
+            <a:r>
+              <a:t>Board 2 tells you where it landed."</a:t>
+            </a:r>
+          </a:p>
+          <a:p/>
+          <a:p>
+            <a:r>
+              <a:t>THEN THE HONEST PART: "It also means that if the Wi-Fi moves us to a different</a:t>
+            </a:r>
+          </a:p>
+          <a:p>
+            <a:r>
+              <a:t>channel, our link breaks silently. Wi-Fi and the cloud still look perfectly</a:t>
+            </a:r>
+          </a:p>
+          <a:p>
+            <a:r>
+              <a:t>healthy - only the radio link is dead. It happened three times during</a:t>
+            </a:r>
+          </a:p>
+          <a:p>
+            <a:r>
+              <a:t>development, so we check before every demonstration."</a:t>
+            </a:r>
+          </a:p>
+          <a:p/>
+          <a:p>
+            <a:r>
+              <a:t>WHY IT IS SILENT: every indicator a casual observer checks still passes. The</a:t>
+            </a:r>
+          </a:p>
+          <a:p>
+            <a:r>
+              <a:t>gateway keeps publishing its own sensor. Only the node's data stops.</a:t>
+            </a:r>
+          </a:p>
+          <a:p/>
+          <a:p>
+            <a:r>
+              <a:t>BACKUP: eduroam runs access points on channels 1, 6 and 11. We observed the</a:t>
+            </a:r>
+          </a:p>
+          <a:p>
+            <a:r>
+              <a:t>gateway on all three.</a:t>
             </a:r>
           </a:p>
         </p:txBody>
@@ -1359,7 +2392,45 @@
           <a:lstStyle/>
           <a:p>
             <a:r>
-              <a:t>26 bytes against a 250-byte limit. Point out ttl and hop_count are carried but never decremented - that is the mesh-ready part, and it is honest to say so.</a:t>
+              <a:t>~30 s.</a:t>
+            </a:r>
+          </a:p>
+          <a:p/>
+          <a:p>
+            <a:r>
+              <a:t>SAY: "Every message is 26 bytes. It carries a version, who it is from and to, a</a:t>
+            </a:r>
+          </a:p>
+          <a:p>
+            <a:r>
+              <a:t>sequence number, and the two readings. Small on purpose - the radio protocol</a:t>
+            </a:r>
+          </a:p>
+          <a:p>
+            <a:r>
+              <a:t>allows 250 bytes, and we use 26."</a:t>
+            </a:r>
+          </a:p>
+          <a:p/>
+          <a:p>
+            <a:r>
+              <a:t>WHY VERSION AND TYPE: so the format can change later without both boards</a:t>
+            </a:r>
+          </a:p>
+          <a:p>
+            <a:r>
+              <a:t>silently disagreeing about what the bytes mean.</a:t>
+            </a:r>
+          </a:p>
+          <a:p/>
+          <a:p>
+            <a:r>
+              <a:t>BACKUP: a compile-time assertion locks the structure at exactly 26 bytes, so the</a:t>
+            </a:r>
+          </a:p>
+          <a:p>
+            <a:r>
+              <a:t>two sketches cannot drift apart without the build failing.</a:t>
             </a:r>
           </a:p>
         </p:txBody>
@@ -1429,7 +2500,87 @@
           <a:lstStyle/>
           <a:p>
             <a:r>
-              <a:t>boot_id is the part worth explaining. Without it a node restart is indistinguishable from a replay and the node never comes back.</a:t>
+              <a:t>~45 s. This is a genuinely subtle piece of design - take the time.</a:t>
+            </a:r>
+          </a:p>
+          <a:p/>
+          <a:p>
+            <a:r>
+              <a:t>SAY: "Every message is numbered so we can spot repeats. But each board also</a:t>
+            </a:r>
+          </a:p>
+          <a:p>
+            <a:r>
+              <a:t>picks a random ID when it powers on, and that part is essential."</a:t>
+            </a:r>
+          </a:p>
+          <a:p/>
+          <a:p>
+            <a:r>
+              <a:t>THEN THE WHY: "Without it, a board restarting looks exactly like an attacker</a:t>
+            </a:r>
+          </a:p>
+          <a:p>
+            <a:r>
+              <a:t>replaying old messages. The numbers start low again, we would reject every one</a:t>
+            </a:r>
+          </a:p>
+          <a:p>
+            <a:r>
+              <a:t>of them, and the board would never come back - and nothing would look broken."</a:t>
+            </a:r>
+          </a:p>
+          <a:p/>
+          <a:p>
+            <a:r>
+              <a:t>THREE CASES the logic distinguishes:</a:t>
+            </a:r>
+          </a:p>
+          <a:p>
+            <a:r>
+              <a:t>  new packet     - accept</a:t>
+            </a:r>
+          </a:p>
+          <a:p>
+            <a:r>
+              <a:t>  duplicate      - reject</a:t>
+            </a:r>
+          </a:p>
+          <a:p>
+            <a:r>
+              <a:t>  gap (loss)     - accept, do not wait</a:t>
+            </a:r>
+          </a:p>
+          <a:p/>
+          <a:p>
+            <a:r>
+              <a:t>A jump forward is a gap, not a duplicate. If we demanded consecutive numbers we</a:t>
+            </a:r>
+          </a:p>
+          <a:p>
+            <a:r>
+              <a:t>would deadlock on the first lost packet, waiting forever for something that is</a:t>
+            </a:r>
+          </a:p>
+          <a:p>
+            <a:r>
+              <a:t>never coming.</a:t>
+            </a:r>
+          </a:p>
+          <a:p/>
+          <a:p>
+            <a:r>
+              <a:t>BACKUP: key is the triple (src_id, boot_id, seq). The comparison is wrap-aware -</a:t>
+            </a:r>
+          </a:p>
+          <a:p>
+            <a:r>
+              <a:t>unsigned subtraction then a signed compare - so it stays correct when a 32-bit</a:t>
+            </a:r>
+          </a:p>
+          <a:p>
+            <a:r>
+              <a:t>counter overflows.</a:t>
             </a:r>
           </a:p>
         </p:txBody>
@@ -1499,7 +2650,139 @@
           <a:lstStyle/>
           <a:p>
             <a:r>
-              <a:t>Security is 25 marks with the other domains. Lead with the attack you found yourselves - that reads far better than a list of things you did not do.</a:t>
+              <a:t>~90 seconds. Worth 25 marks. Slow down. Tell it as a story.</a:t>
+            </a:r>
+          </a:p>
+          <a:p/>
+          <a:p>
+            <a:r>
+              <a:t>SAY: "At first, anyone with a matching radio nearby could send us a fake</a:t>
+            </a:r>
+          </a:p>
+          <a:p>
+            <a:r>
+              <a:t>reading. The message says who it is from, but that is just a claim - anyone can</a:t>
+            </a:r>
+          </a:p>
+          <a:p>
+            <a:r>
+              <a:t>write anything in that field."</a:t>
+            </a:r>
+          </a:p>
+          <a:p/>
+          <a:p>
+            <a:r>
+              <a:t>"Our first fix was to check the sender's hardware address. Someone reviewed it</a:t>
+            </a:r>
+          </a:p>
+          <a:p>
+            <a:r>
+              <a:t>and pointed out the flaw straight away: an attacker can simply set that address</a:t>
+            </a:r>
+          </a:p>
+          <a:p>
+            <a:r>
+              <a:t>to whatever they like. We were checking a value the attacker controls. That is a</a:t>
+            </a:r>
+          </a:p>
+          <a:p>
+            <a:r>
+              <a:t>name badge, not a passport."</a:t>
+            </a:r>
+          </a:p>
+          <a:p/>
+          <a:p>
+            <a:r>
+              <a:t>"So we encrypted the link instead. Both boards share a key. Now a message only</a:t>
+            </a:r>
+          </a:p>
+          <a:p>
+            <a:r>
+              <a:t>works if the sender actually has that key. That is the difference between</a:t>
+            </a:r>
+          </a:p>
+          <a:p>
+            <a:r>
+              <a:t>claiming who you are and proving it."</a:t>
+            </a:r>
+          </a:p>
+          <a:p/>
+          <a:p>
+            <a:r>
+              <a:t>THEN CLOSE THE LOOP HONESTLY, before they ask:</a:t>
+            </a:r>
+          </a:p>
+          <a:p>
+            <a:r>
+              <a:t>"The cloud connection is still unencrypted - the access token crosses in plain</a:t>
+            </a:r>
+          </a:p>
+          <a:p>
+            <a:r>
+              <a:t>text. That is the most serious weakness left, and the fix is TLS on port 8883."</a:t>
+            </a:r>
+          </a:p>
+          <a:p/>
+          <a:p>
+            <a:r>
+              <a:t>THE RULE UNDERNEATH IT: you cannot authenticate using a value the attacker</a:t>
+            </a:r>
+          </a:p>
+          <a:p>
+            <a:r>
+              <a:t>supplies. That is the whole lesson and it generalises far beyond this project.</a:t>
+            </a:r>
+          </a:p>
+          <a:p/>
+          <a:p>
+            <a:r>
+              <a:t>WHAT THE ATTACK ACTUALLY DID: not a wrong temperature on a dashboard. A forged</a:t>
+            </a:r>
+          </a:p>
+          <a:p>
+            <a:r>
+              <a:t>packet carrying a very high sequence number advances the duplicate-detection</a:t>
+            </a:r>
+          </a:p>
+          <a:p>
+            <a:r>
+              <a:t>baseline, and after that every genuine packet from the real sensor is rejected</a:t>
+            </a:r>
+          </a:p>
+          <a:p>
+            <a:r>
+              <a:t>as a duplicate until the board reboots. One forged frame silences the real</a:t>
+            </a:r>
+          </a:p>
+          <a:p>
+            <a:r>
+              <a:t>sensor. It is a denial of service delivered through the integrity mechanism</a:t>
+            </a:r>
+          </a:p>
+          <a:p>
+            <a:r>
+              <a:t>itself.</a:t>
+            </a:r>
+          </a:p>
+          <a:p/>
+          <a:p>
+            <a:r>
+              <a:t>BACKUP: a primary master key protects the per-peer key during setup; the</a:t>
+            </a:r>
+          </a:p>
+          <a:p>
+            <a:r>
+              <a:t>per-peer key encrypts the payload. The receiver also needs a peer entry, or the</a:t>
+            </a:r>
+          </a:p>
+          <a:p>
+            <a:r>
+              <a:t>driver discards the frame before any application code runs - a silent failure</a:t>
+            </a:r>
+          </a:p>
+          <a:p>
+            <a:r>
+              <a:t>with no error at all.</a:t>
             </a:r>
           </a:p>
         </p:txBody>
@@ -1569,7 +2852,55 @@
           <a:lstStyle/>
           <a:p>
             <a:r>
-              <a:t>Numbers from evidence/01_gateway_running_state.txt. invalid=0 across 634 packets is the one to point at - it proves both boards agree on the packet layout.</a:t>
+              <a:t>~30 s.</a:t>
+            </a:r>
+          </a:p>
+          <a:p/>
+          <a:p>
+            <a:r>
+              <a:t>SAY: "634 messages received and validated. 82 repeats caught and rejected. Zero</a:t>
+            </a:r>
+          </a:p>
+          <a:p>
+            <a:r>
+              <a:t>corrupted - both boards agree on the format. Fourteen out of fourteen acceptance</a:t>
+            </a:r>
+          </a:p>
+          <a:p>
+            <a:r>
+              <a:t>criteria evidenced."</a:t>
+            </a:r>
+          </a:p>
+          <a:p/>
+          <a:p>
+            <a:r>
+              <a:t>ON THE OFFLINE BEHAVIOUR: "When the node goes quiet we keep publishing its last</a:t>
+            </a:r>
+          </a:p>
+          <a:p>
+            <a:r>
+              <a:t>known temperature, so the chart stays continuous - but a separate flag says the</a:t>
+            </a:r>
+          </a:p>
+          <a:p>
+            <a:r>
+              <a:t>data is stale. We do not put 'unknown' in the data field. We put it in a status</a:t>
+            </a:r>
+          </a:p>
+          <a:p>
+            <a:r>
+              <a:t>field."</a:t>
+            </a:r>
+          </a:p>
+          <a:p/>
+          <a:p>
+            <a:r>
+              <a:t>That is a design decision worth defending if asked: nobody is misled, and the</a:t>
+            </a:r>
+          </a:p>
+          <a:p>
+            <a:r>
+              <a:t>chart stays readable.</a:t>
             </a:r>
           </a:p>
         </p:txBody>

</xml_diff>